<commit_message>
atualiza apresentação jogando limpo
</commit_message>
<xml_diff>
--- a/apresentacoes/2026-06-29-jogando-limpo/culto-kids-2026-06-29-jogando-limpo.pptx
+++ b/apresentacoes/2026-06-29-jogando-limpo/culto-kids-2026-06-29-jogando-limpo.pptx
@@ -2,24 +2,24 @@
 <file path=ppt/presentation.xml><?xml version="1.0" encoding="utf-8"?>
 <p:presentation xmlns:p="http://schemas.openxmlformats.org/presentationml/2006/main">
   <p:sldMasterIdLst>
-    <p:sldMasterId xmlns:r="http://schemas.openxmlformats.org/officeDocument/2006/relationships" id="2147483648" r:id="Rf85f375a03a54501"/>
+    <p:sldMasterId xmlns:r="http://schemas.openxmlformats.org/officeDocument/2006/relationships" id="2147483648" r:id="Rabc6c7e2aaf248db"/>
   </p:sldMasterIdLst>
   <p:notesMasterIdLst>
-    <p:notesMasterId xmlns:r="http://schemas.openxmlformats.org/officeDocument/2006/relationships" r:id="R8c1b94679f5a47f8"/>
+    <p:notesMasterId xmlns:r="http://schemas.openxmlformats.org/officeDocument/2006/relationships" r:id="Rb52b841eb51647b8"/>
   </p:notesMasterIdLst>
   <p:sldIdLst>
-    <p:sldId xmlns:r="http://schemas.openxmlformats.org/officeDocument/2006/relationships" id="256" r:id="Re12995ddfe1b4afe"/>
-    <p:sldId xmlns:r="http://schemas.openxmlformats.org/officeDocument/2006/relationships" id="257" r:id="R20e46cf610de4fb2"/>
-    <p:sldId xmlns:r="http://schemas.openxmlformats.org/officeDocument/2006/relationships" id="258" r:id="R6204b5cc04a54aef"/>
-    <p:sldId xmlns:r="http://schemas.openxmlformats.org/officeDocument/2006/relationships" id="259" r:id="R5864065d00db4925"/>
-    <p:sldId xmlns:r="http://schemas.openxmlformats.org/officeDocument/2006/relationships" id="260" r:id="R895f3cceb2ad4cee"/>
-    <p:sldId xmlns:r="http://schemas.openxmlformats.org/officeDocument/2006/relationships" id="261" r:id="R65ac6482d721483a"/>
-    <p:sldId xmlns:r="http://schemas.openxmlformats.org/officeDocument/2006/relationships" id="262" r:id="Rdd0c007ff69547ab"/>
-    <p:sldId xmlns:r="http://schemas.openxmlformats.org/officeDocument/2006/relationships" id="263" r:id="Rc2c882c56352474e"/>
-    <p:sldId xmlns:r="http://schemas.openxmlformats.org/officeDocument/2006/relationships" id="264" r:id="R7e2745a05d144553"/>
-    <p:sldId xmlns:r="http://schemas.openxmlformats.org/officeDocument/2006/relationships" id="265" r:id="R0775e322d8dd4e79"/>
-    <p:sldId xmlns:r="http://schemas.openxmlformats.org/officeDocument/2006/relationships" id="266" r:id="R47318d20cc8f423a"/>
-    <p:sldId xmlns:r="http://schemas.openxmlformats.org/officeDocument/2006/relationships" id="267" r:id="R6b26dbba72d8448b"/>
+    <p:sldId xmlns:r="http://schemas.openxmlformats.org/officeDocument/2006/relationships" id="256" r:id="Raba87e51b9dc4a8c"/>
+    <p:sldId xmlns:r="http://schemas.openxmlformats.org/officeDocument/2006/relationships" id="257" r:id="Rb17d846855e049a0"/>
+    <p:sldId xmlns:r="http://schemas.openxmlformats.org/officeDocument/2006/relationships" id="258" r:id="Rbd139b9ce14f45ce"/>
+    <p:sldId xmlns:r="http://schemas.openxmlformats.org/officeDocument/2006/relationships" id="259" r:id="Rb8c4da2dc6ce4fcf"/>
+    <p:sldId xmlns:r="http://schemas.openxmlformats.org/officeDocument/2006/relationships" id="260" r:id="Ra2cd6b2557bd4cf6"/>
+    <p:sldId xmlns:r="http://schemas.openxmlformats.org/officeDocument/2006/relationships" id="261" r:id="Rf21c57c185ea499b"/>
+    <p:sldId xmlns:r="http://schemas.openxmlformats.org/officeDocument/2006/relationships" id="262" r:id="Rde3d6a08b268448d"/>
+    <p:sldId xmlns:r="http://schemas.openxmlformats.org/officeDocument/2006/relationships" id="263" r:id="R691dadd147d24e4f"/>
+    <p:sldId xmlns:r="http://schemas.openxmlformats.org/officeDocument/2006/relationships" id="264" r:id="Rfd476da85326425a"/>
+    <p:sldId xmlns:r="http://schemas.openxmlformats.org/officeDocument/2006/relationships" id="265" r:id="Rb897221b970540f1"/>
+    <p:sldId xmlns:r="http://schemas.openxmlformats.org/officeDocument/2006/relationships" id="266" r:id="R89ef0f32a2a54cf3"/>
+    <p:sldId xmlns:r="http://schemas.openxmlformats.org/officeDocument/2006/relationships" id="267" r:id="R7383854b19fe41b1"/>
   </p:sldIdLst>
   <p:sldSz cx="12192000" cy="6858000"/>
   <p:notesSz cx="6858000" cy="9144000"/>
@@ -1401,7 +1401,7 @@
   </p:cSld>
   <p:clrMap bg1="lt1" tx1="dk1" bg2="lt2" tx2="dk2" accent1="accent1" accent2="accent2" accent3="accent3" accent4="accent4" accent5="accent5" accent6="accent6" hlink="hlink" folHlink="folHlink"/>
   <p:sldLayoutIdLst>
-    <p:sldLayoutId xmlns:r="http://schemas.openxmlformats.org/officeDocument/2006/relationships" id="2147483649" r:id="R19a63f57479d4ef7"/>
+    <p:sldLayoutId xmlns:r="http://schemas.openxmlformats.org/officeDocument/2006/relationships" id="2147483649" r:id="Ra413d4782b624d6f"/>
   </p:sldLayoutIdLst>
   <p:txStyles>
     <p:titleStyle>
@@ -1952,7 +1952,7 @@
           <p:cNvPr id="1" name="">
             <a:extLst xmlns:a="http://schemas.openxmlformats.org/drawingml/2006/main">
               <a:ext uri="{FF2B5EF4-FFF2-40B4-BE49-F238E27FC236}">
-                <a16:creationId xmlns:a16="http://schemas.microsoft.com/office/drawing/2014/main" id="{A379ED83-0F84-477F-AC87-8A0CADC742E2}"/>
+                <a16:creationId xmlns:a16="http://schemas.microsoft.com/office/drawing/2014/main" id="{48380414-DD84-498C-A76C-464269F2E73A}"/>
               </a:ext>
             </a:extLst>
           </p:cNvPr>
@@ -1983,7 +1983,7 @@
           <p:cNvPr id="2" name="">
             <a:extLst xmlns:a="http://schemas.openxmlformats.org/drawingml/2006/main">
               <a:ext uri="{FF2B5EF4-FFF2-40B4-BE49-F238E27FC236}">
-                <a16:creationId xmlns:a16="http://schemas.microsoft.com/office/drawing/2014/main" id="{8EA20A11-822B-48EE-A0DB-8982E3B024BF}"/>
+                <a16:creationId xmlns:a16="http://schemas.microsoft.com/office/drawing/2014/main" id="{8F29791C-B08E-49D9-8792-48700C7EB665}"/>
               </a:ext>
             </a:extLst>
           </p:cNvPr>
@@ -2014,7 +2014,7 @@
           <p:cNvPr id="3" name="">
             <a:extLst xmlns:a="http://schemas.openxmlformats.org/drawingml/2006/main">
               <a:ext uri="{FF2B5EF4-FFF2-40B4-BE49-F238E27FC236}">
-                <a16:creationId xmlns:a16="http://schemas.microsoft.com/office/drawing/2014/main" id="{A7F6A757-1549-4AFB-BE7C-810A068D69DB}"/>
+                <a16:creationId xmlns:a16="http://schemas.microsoft.com/office/drawing/2014/main" id="{FD76607E-AA33-43CE-9054-771DB5AC3FD8}"/>
               </a:ext>
             </a:extLst>
           </p:cNvPr>
@@ -2045,7 +2045,7 @@
           <p:cNvPr id="4" name="">
             <a:extLst xmlns:a="http://schemas.openxmlformats.org/drawingml/2006/main">
               <a:ext uri="{FF2B5EF4-FFF2-40B4-BE49-F238E27FC236}">
-                <a16:creationId xmlns:a16="http://schemas.microsoft.com/office/drawing/2014/main" id="{7DBE7F2A-2466-43C5-AF41-F4D09FA7C75E}"/>
+                <a16:creationId xmlns:a16="http://schemas.microsoft.com/office/drawing/2014/main" id="{7F2870B2-FE6B-4280-9FD8-D6909CCD03BD}"/>
               </a:ext>
             </a:extLst>
           </p:cNvPr>
@@ -2076,7 +2076,7 @@
           <p:cNvPr id="5" name="">
             <a:extLst xmlns:a="http://schemas.openxmlformats.org/drawingml/2006/main">
               <a:ext uri="{FF2B5EF4-FFF2-40B4-BE49-F238E27FC236}">
-                <a16:creationId xmlns:a16="http://schemas.microsoft.com/office/drawing/2014/main" id="{3F260082-F503-4839-B872-3E064B24AFF0}"/>
+                <a16:creationId xmlns:a16="http://schemas.microsoft.com/office/drawing/2014/main" id="{20F45EC1-6789-4736-BD11-B46E347CC376}"/>
               </a:ext>
             </a:extLst>
           </p:cNvPr>
@@ -2107,7 +2107,7 @@
           <p:cNvPr id="6" name="">
             <a:extLst xmlns:a="http://schemas.openxmlformats.org/drawingml/2006/main">
               <a:ext uri="{FF2B5EF4-FFF2-40B4-BE49-F238E27FC236}">
-                <a16:creationId xmlns:a16="http://schemas.microsoft.com/office/drawing/2014/main" id="{C317FF42-3048-4F0A-BFFE-00D7D40A59E2}"/>
+                <a16:creationId xmlns:a16="http://schemas.microsoft.com/office/drawing/2014/main" id="{C4ECB8D4-BA6A-436B-AFAE-2BD9D5C35E2A}"/>
               </a:ext>
             </a:extLst>
           </p:cNvPr>
@@ -2138,7 +2138,7 @@
           <p:cNvPr id="7" name="">
             <a:extLst xmlns:a="http://schemas.openxmlformats.org/drawingml/2006/main">
               <a:ext uri="{FF2B5EF4-FFF2-40B4-BE49-F238E27FC236}">
-                <a16:creationId xmlns:a16="http://schemas.microsoft.com/office/drawing/2014/main" id="{5B2AA371-D974-4167-8611-498C159EE177}"/>
+                <a16:creationId xmlns:a16="http://schemas.microsoft.com/office/drawing/2014/main" id="{B8C48688-297F-4E98-A66C-F929B671F247}"/>
               </a:ext>
             </a:extLst>
           </p:cNvPr>
@@ -2169,7 +2169,7 @@
           <p:cNvPr id="8" name="">
             <a:extLst xmlns:a="http://schemas.openxmlformats.org/drawingml/2006/main">
               <a:ext uri="{FF2B5EF4-FFF2-40B4-BE49-F238E27FC236}">
-                <a16:creationId xmlns:a16="http://schemas.microsoft.com/office/drawing/2014/main" id="{859FA7DD-56D6-41F1-A818-B3A8A24BC4FA}"/>
+                <a16:creationId xmlns:a16="http://schemas.microsoft.com/office/drawing/2014/main" id="{D152251D-E072-461B-B248-E5C79BA415B7}"/>
               </a:ext>
             </a:extLst>
           </p:cNvPr>
@@ -2200,7 +2200,7 @@
           <p:cNvPr id="9" name="">
             <a:extLst xmlns:a="http://schemas.openxmlformats.org/drawingml/2006/main">
               <a:ext uri="{FF2B5EF4-FFF2-40B4-BE49-F238E27FC236}">
-                <a16:creationId xmlns:a16="http://schemas.microsoft.com/office/drawing/2014/main" id="{0A70B0A1-B670-4F4E-B75B-664390269ADB}"/>
+                <a16:creationId xmlns:a16="http://schemas.microsoft.com/office/drawing/2014/main" id="{EA0FB249-0997-4C94-9C0F-1931DFC287F7}"/>
               </a:ext>
             </a:extLst>
           </p:cNvPr>
@@ -2231,7 +2231,7 @@
           <p:cNvPr id="10" name="">
             <a:extLst xmlns:a="http://schemas.openxmlformats.org/drawingml/2006/main">
               <a:ext uri="{FF2B5EF4-FFF2-40B4-BE49-F238E27FC236}">
-                <a16:creationId xmlns:a16="http://schemas.microsoft.com/office/drawing/2014/main" id="{CB100154-ABF6-4E6E-AC1A-D53E7AC4367E}"/>
+                <a16:creationId xmlns:a16="http://schemas.microsoft.com/office/drawing/2014/main" id="{EAAD148E-0CA3-4DC7-ACA8-0856B99EDCD1}"/>
               </a:ext>
             </a:extLst>
           </p:cNvPr>
@@ -2262,7 +2262,7 @@
           <p:cNvPr id="11" name="">
             <a:extLst xmlns:a="http://schemas.openxmlformats.org/drawingml/2006/main">
               <a:ext uri="{FF2B5EF4-FFF2-40B4-BE49-F238E27FC236}">
-                <a16:creationId xmlns:a16="http://schemas.microsoft.com/office/drawing/2014/main" id="{4CB10E5F-7A7E-41DF-811C-04F17891E9AA}"/>
+                <a16:creationId xmlns:a16="http://schemas.microsoft.com/office/drawing/2014/main" id="{A31E9DFF-C1AD-4449-8047-9801385F6FEF}"/>
               </a:ext>
             </a:extLst>
           </p:cNvPr>
@@ -2293,7 +2293,7 @@
           <p:cNvPr id="12" name="">
             <a:extLst xmlns:a="http://schemas.openxmlformats.org/drawingml/2006/main">
               <a:ext uri="{FF2B5EF4-FFF2-40B4-BE49-F238E27FC236}">
-                <a16:creationId xmlns:a16="http://schemas.microsoft.com/office/drawing/2014/main" id="{777F5400-DC03-46E5-91B0-34F27DF0E42C}"/>
+                <a16:creationId xmlns:a16="http://schemas.microsoft.com/office/drawing/2014/main" id="{EFC24DDF-5B1D-4598-BC92-0527B5C07997}"/>
               </a:ext>
             </a:extLst>
           </p:cNvPr>
@@ -2324,7 +2324,7 @@
           <p:cNvPr id="13" name="">
             <a:extLst xmlns:a="http://schemas.openxmlformats.org/drawingml/2006/main">
               <a:ext uri="{FF2B5EF4-FFF2-40B4-BE49-F238E27FC236}">
-                <a16:creationId xmlns:a16="http://schemas.microsoft.com/office/drawing/2014/main" id="{4250D2AC-88B2-4904-A176-CE4FB9D2338F}"/>
+                <a16:creationId xmlns:a16="http://schemas.microsoft.com/office/drawing/2014/main" id="{DADB78ED-086D-44A8-81CD-E5C665F84DB6}"/>
               </a:ext>
             </a:extLst>
           </p:cNvPr>
@@ -2336,11 +2336,11 @@
         <p:spPr>
           <a:xfrm xmlns:a="http://schemas.openxmlformats.org/drawingml/2006/main">
             <a:off x="685800" y="514350"/>
-            <a:ext cx="3429000" cy="552450"/>
+            <a:ext cx="4762500" cy="552450"/>
           </a:xfrm>
           <a:prstGeom xmlns:a="http://schemas.openxmlformats.org/drawingml/2006/main" prst="roundRect">
             <a:avLst>
-              <a:gd name="adj" fmla="val 48276"/>
+              <a:gd name="adj" fmla="val 50000"/>
             </a:avLst>
           </a:prstGeom>
           <a:solidFill xmlns:a="http://schemas.openxmlformats.org/drawingml/2006/main">
@@ -2363,7 +2363,7 @@
           <p:cNvPr id="14" name="">
             <a:extLst xmlns:a="http://schemas.openxmlformats.org/drawingml/2006/main">
               <a:ext uri="{FF2B5EF4-FFF2-40B4-BE49-F238E27FC236}">
-                <a16:creationId xmlns:a16="http://schemas.microsoft.com/office/drawing/2014/main" id="{5DFD71F8-D1D6-4685-8F2E-5BB0E15F3ADB}"/>
+                <a16:creationId xmlns:a16="http://schemas.microsoft.com/office/drawing/2014/main" id="{50E78D0C-85D7-4B6D-A74B-177A48ECB4FB}"/>
               </a:ext>
             </a:extLst>
           </p:cNvPr>
@@ -2375,7 +2375,7 @@
         <p:spPr>
           <a:xfrm xmlns:a="http://schemas.openxmlformats.org/drawingml/2006/main">
             <a:off x="762000" y="571500"/>
-            <a:ext cx="3276600" cy="400050"/>
+            <a:ext cx="4610100" cy="438150"/>
           </a:xfrm>
           <a:prstGeom xmlns:a="http://schemas.openxmlformats.org/drawingml/2006/main" prst="rect">
             <a:avLst/>
@@ -2419,7 +2419,7 @@
           <p:cNvPr id="15" name="">
             <a:extLst xmlns:a="http://schemas.openxmlformats.org/drawingml/2006/main">
               <a:ext uri="{FF2B5EF4-FFF2-40B4-BE49-F238E27FC236}">
-                <a16:creationId xmlns:a16="http://schemas.microsoft.com/office/drawing/2014/main" id="{F71F3866-7A22-4FFA-B725-5411EDAE0E0C}"/>
+                <a16:creationId xmlns:a16="http://schemas.microsoft.com/office/drawing/2014/main" id="{10A479CC-B83D-4B84-9E7F-DB9C2D0C20A7}"/>
               </a:ext>
             </a:extLst>
           </p:cNvPr>
@@ -2475,7 +2475,7 @@
           <p:cNvPr id="16" name="">
             <a:extLst xmlns:a="http://schemas.openxmlformats.org/drawingml/2006/main">
               <a:ext uri="{FF2B5EF4-FFF2-40B4-BE49-F238E27FC236}">
-                <a16:creationId xmlns:a16="http://schemas.microsoft.com/office/drawing/2014/main" id="{BA5A9835-7013-4948-BD76-AABA60F47FB8}"/>
+                <a16:creationId xmlns:a16="http://schemas.microsoft.com/office/drawing/2014/main" id="{E54EC8AF-E8AB-4CB6-A8B4-5F62049008D5}"/>
               </a:ext>
             </a:extLst>
           </p:cNvPr>
@@ -2554,7 +2554,7 @@
           <p:cNvPr id="17" name="">
             <a:extLst xmlns:a="http://schemas.openxmlformats.org/drawingml/2006/main">
               <a:ext uri="{FF2B5EF4-FFF2-40B4-BE49-F238E27FC236}">
-                <a16:creationId xmlns:a16="http://schemas.microsoft.com/office/drawing/2014/main" id="{77A20B88-5D6B-48E6-A2EF-4CF51860A7CB}"/>
+                <a16:creationId xmlns:a16="http://schemas.microsoft.com/office/drawing/2014/main" id="{EE9F867E-9CDE-4FC0-B788-94FD42A9C519}"/>
               </a:ext>
             </a:extLst>
           </p:cNvPr>
@@ -2593,7 +2593,7 @@
           <p:cNvPr id="18" name="">
             <a:extLst xmlns:a="http://schemas.openxmlformats.org/drawingml/2006/main">
               <a:ext uri="{FF2B5EF4-FFF2-40B4-BE49-F238E27FC236}">
-                <a16:creationId xmlns:a16="http://schemas.microsoft.com/office/drawing/2014/main" id="{BDA1DFF8-1ABB-49C1-9D81-2C6A0A5FBD71}"/>
+                <a16:creationId xmlns:a16="http://schemas.microsoft.com/office/drawing/2014/main" id="{62BDC6E5-B676-423E-A2AF-1EE729B864C3}"/>
               </a:ext>
             </a:extLst>
           </p:cNvPr>
@@ -2649,7 +2649,7 @@
           <p:cNvPr id="19" name="">
             <a:extLst xmlns:a="http://schemas.openxmlformats.org/drawingml/2006/main">
               <a:ext uri="{FF2B5EF4-FFF2-40B4-BE49-F238E27FC236}">
-                <a16:creationId xmlns:a16="http://schemas.microsoft.com/office/drawing/2014/main" id="{460E1BD1-DCA5-49C6-ADD1-6625BE17C7BB}"/>
+                <a16:creationId xmlns:a16="http://schemas.microsoft.com/office/drawing/2014/main" id="{9C626187-804E-47A2-AC77-E309348A6222}"/>
               </a:ext>
             </a:extLst>
           </p:cNvPr>
@@ -2705,7 +2705,7 @@
           <p:cNvPr id="20" name="">
             <a:extLst xmlns:a="http://schemas.openxmlformats.org/drawingml/2006/main">
               <a:ext uri="{FF2B5EF4-FFF2-40B4-BE49-F238E27FC236}">
-                <a16:creationId xmlns:a16="http://schemas.microsoft.com/office/drawing/2014/main" id="{775B02D1-AE06-49F4-8E98-C8A65015135F}"/>
+                <a16:creationId xmlns:a16="http://schemas.microsoft.com/office/drawing/2014/main" id="{2BBC5B03-3A24-43E1-93CF-49F5231509E1}"/>
               </a:ext>
             </a:extLst>
           </p:cNvPr>
@@ -2744,7 +2744,7 @@
           <p:cNvPr id="21" name="">
             <a:extLst xmlns:a="http://schemas.openxmlformats.org/drawingml/2006/main">
               <a:ext uri="{FF2B5EF4-FFF2-40B4-BE49-F238E27FC236}">
-                <a16:creationId xmlns:a16="http://schemas.microsoft.com/office/drawing/2014/main" id="{B5FB8D6F-DFFC-4018-A25F-375EC5833F75}"/>
+                <a16:creationId xmlns:a16="http://schemas.microsoft.com/office/drawing/2014/main" id="{FFA0DE89-B0AC-427C-A6F9-1332194AA8BA}"/>
               </a:ext>
             </a:extLst>
           </p:cNvPr>
@@ -2787,18 +2787,16 @@
           <p:nvPr/>
         </p:nvPicPr>
         <p:blipFill>
-          <a:blip xmlns:r="http://schemas.openxmlformats.org/officeDocument/2006/relationships" xmlns:a="http://schemas.openxmlformats.org/drawingml/2006/main" r:embed="Rabe5dcf8a45740cb"/>
+          <a:blip xmlns:r="http://schemas.openxmlformats.org/officeDocument/2006/relationships" xmlns:a="http://schemas.openxmlformats.org/drawingml/2006/main" r:embed="R9891c62e81794cb5"/>
           <a:stretch xmlns:a="http://schemas.openxmlformats.org/drawingml/2006/main"/>
         </p:blipFill>
         <p:spPr>
           <a:xfrm xmlns:a="http://schemas.openxmlformats.org/drawingml/2006/main">
-            <a:off x="8667750" y="3135793"/>
-            <a:ext cx="2381250" cy="2929564"/>
-          </a:xfrm>
-          <a:prstGeom xmlns:a="http://schemas.openxmlformats.org/drawingml/2006/main" prst="roundRect">
-            <a:avLst>
-              <a:gd name="adj" fmla="val 9600"/>
-            </a:avLst>
+            <a:off x="8810625" y="3028950"/>
+            <a:ext cx="2095500" cy="3143250"/>
+          </a:xfrm>
+          <a:prstGeom xmlns:a="http://schemas.openxmlformats.org/drawingml/2006/main" prst="rect">
+            <a:avLst/>
           </a:prstGeom>
         </p:spPr>
       </p:pic>
@@ -2811,7 +2809,7 @@
           <p:nvPr/>
         </p:nvPicPr>
         <p:blipFill>
-          <a:blip xmlns:r="http://schemas.openxmlformats.org/officeDocument/2006/relationships" xmlns:a="http://schemas.openxmlformats.org/drawingml/2006/main" r:embed="Re4e169a4c783457c"/>
+          <a:blip xmlns:r="http://schemas.openxmlformats.org/officeDocument/2006/relationships" xmlns:a="http://schemas.openxmlformats.org/drawingml/2006/main" r:embed="Rd0560036bbfe4181"/>
           <a:stretch xmlns:a="http://schemas.openxmlformats.org/drawingml/2006/main"/>
         </p:blipFill>
         <p:spPr>
@@ -2829,7 +2827,7 @@
           <p:cNvPr id="24" name="">
             <a:extLst xmlns:a="http://schemas.openxmlformats.org/drawingml/2006/main">
               <a:ext uri="{FF2B5EF4-FFF2-40B4-BE49-F238E27FC236}">
-                <a16:creationId xmlns:a16="http://schemas.microsoft.com/office/drawing/2014/main" id="{77604E2A-0E85-48A3-8349-97DE038CC022}"/>
+                <a16:creationId xmlns:a16="http://schemas.microsoft.com/office/drawing/2014/main" id="{A32A31E5-923E-4647-AB63-6B6EBC750B29}"/>
               </a:ext>
             </a:extLst>
           </p:cNvPr>
@@ -2883,7 +2881,7 @@
     </p:spTree>
     <p:extLst>
       <p:ext uri="{BB962C8B-B14F-4D97-AF65-F5344CB8AC3E}">
-        <p14:creationId xmlns:p14="http://schemas.microsoft.com/office/powerpoint/2010/main" val="724174217"/>
+        <p14:creationId xmlns:p14="http://schemas.microsoft.com/office/powerpoint/2010/main" val="250155821"/>
       </p:ext>
     </p:extLst>
   </p:cSld>
@@ -2914,7 +2912,7 @@
           <p:cNvPr id="1" name="">
             <a:extLst xmlns:a="http://schemas.openxmlformats.org/drawingml/2006/main">
               <a:ext uri="{FF2B5EF4-FFF2-40B4-BE49-F238E27FC236}">
-                <a16:creationId xmlns:a16="http://schemas.microsoft.com/office/drawing/2014/main" id="{2B7AC781-D1CA-4B41-AA70-270DDA75F27A}"/>
+                <a16:creationId xmlns:a16="http://schemas.microsoft.com/office/drawing/2014/main" id="{5A6D7041-79AF-486E-B835-49F328E4951E}"/>
               </a:ext>
             </a:extLst>
           </p:cNvPr>
@@ -2945,7 +2943,7 @@
           <p:cNvPr id="2" name="">
             <a:extLst xmlns:a="http://schemas.openxmlformats.org/drawingml/2006/main">
               <a:ext uri="{FF2B5EF4-FFF2-40B4-BE49-F238E27FC236}">
-                <a16:creationId xmlns:a16="http://schemas.microsoft.com/office/drawing/2014/main" id="{1FD1DA62-82D7-4B75-8123-4FDD5DA410BD}"/>
+                <a16:creationId xmlns:a16="http://schemas.microsoft.com/office/drawing/2014/main" id="{5EEC8288-EC93-42A2-B869-A18FA22BE95E}"/>
               </a:ext>
             </a:extLst>
           </p:cNvPr>
@@ -2976,7 +2974,7 @@
           <p:cNvPr id="3" name="">
             <a:extLst xmlns:a="http://schemas.openxmlformats.org/drawingml/2006/main">
               <a:ext uri="{FF2B5EF4-FFF2-40B4-BE49-F238E27FC236}">
-                <a16:creationId xmlns:a16="http://schemas.microsoft.com/office/drawing/2014/main" id="{187CB851-BBB6-418B-8277-AAF87304B07D}"/>
+                <a16:creationId xmlns:a16="http://schemas.microsoft.com/office/drawing/2014/main" id="{E20E4F2E-7976-43AA-A350-46693241BF1A}"/>
               </a:ext>
             </a:extLst>
           </p:cNvPr>
@@ -3007,7 +3005,7 @@
           <p:cNvPr id="4" name="">
             <a:extLst xmlns:a="http://schemas.openxmlformats.org/drawingml/2006/main">
               <a:ext uri="{FF2B5EF4-FFF2-40B4-BE49-F238E27FC236}">
-                <a16:creationId xmlns:a16="http://schemas.microsoft.com/office/drawing/2014/main" id="{36875134-03E9-4903-A017-F7FB15EBDDB1}"/>
+                <a16:creationId xmlns:a16="http://schemas.microsoft.com/office/drawing/2014/main" id="{50F5DCE3-3865-428E-84A2-51B6B3241BCF}"/>
               </a:ext>
             </a:extLst>
           </p:cNvPr>
@@ -3038,7 +3036,7 @@
           <p:cNvPr id="5" name="">
             <a:extLst xmlns:a="http://schemas.openxmlformats.org/drawingml/2006/main">
               <a:ext uri="{FF2B5EF4-FFF2-40B4-BE49-F238E27FC236}">
-                <a16:creationId xmlns:a16="http://schemas.microsoft.com/office/drawing/2014/main" id="{1A018CE9-6B5E-4DCE-83A6-D92FBF7D6E40}"/>
+                <a16:creationId xmlns:a16="http://schemas.microsoft.com/office/drawing/2014/main" id="{9995D53A-DDA2-4158-9CE0-582F1C42E001}"/>
               </a:ext>
             </a:extLst>
           </p:cNvPr>
@@ -3069,7 +3067,7 @@
           <p:cNvPr id="6" name="">
             <a:extLst xmlns:a="http://schemas.openxmlformats.org/drawingml/2006/main">
               <a:ext uri="{FF2B5EF4-FFF2-40B4-BE49-F238E27FC236}">
-                <a16:creationId xmlns:a16="http://schemas.microsoft.com/office/drawing/2014/main" id="{FC2A2EFB-D287-44D7-A94A-3C58946D8268}"/>
+                <a16:creationId xmlns:a16="http://schemas.microsoft.com/office/drawing/2014/main" id="{7802358F-86AF-4F74-BE1C-7F67A8F29542}"/>
               </a:ext>
             </a:extLst>
           </p:cNvPr>
@@ -3100,7 +3098,7 @@
           <p:cNvPr id="7" name="">
             <a:extLst xmlns:a="http://schemas.openxmlformats.org/drawingml/2006/main">
               <a:ext uri="{FF2B5EF4-FFF2-40B4-BE49-F238E27FC236}">
-                <a16:creationId xmlns:a16="http://schemas.microsoft.com/office/drawing/2014/main" id="{291D8440-2A26-4FC1-B6D6-574EF2CB1D02}"/>
+                <a16:creationId xmlns:a16="http://schemas.microsoft.com/office/drawing/2014/main" id="{4F56955F-0C11-4234-8A44-4CAC2162C030}"/>
               </a:ext>
             </a:extLst>
           </p:cNvPr>
@@ -3131,7 +3129,7 @@
           <p:cNvPr id="8" name="">
             <a:extLst xmlns:a="http://schemas.openxmlformats.org/drawingml/2006/main">
               <a:ext uri="{FF2B5EF4-FFF2-40B4-BE49-F238E27FC236}">
-                <a16:creationId xmlns:a16="http://schemas.microsoft.com/office/drawing/2014/main" id="{9BFF1440-D59C-4674-8E98-DBCB24540FAF}"/>
+                <a16:creationId xmlns:a16="http://schemas.microsoft.com/office/drawing/2014/main" id="{5D3F9B06-2FED-4517-B4C7-F2519999D644}"/>
               </a:ext>
             </a:extLst>
           </p:cNvPr>
@@ -3162,7 +3160,7 @@
           <p:cNvPr id="9" name="">
             <a:extLst xmlns:a="http://schemas.openxmlformats.org/drawingml/2006/main">
               <a:ext uri="{FF2B5EF4-FFF2-40B4-BE49-F238E27FC236}">
-                <a16:creationId xmlns:a16="http://schemas.microsoft.com/office/drawing/2014/main" id="{F1AFC31A-C538-4333-8539-7EBA599AA815}"/>
+                <a16:creationId xmlns:a16="http://schemas.microsoft.com/office/drawing/2014/main" id="{8A70B263-86E5-4163-8F26-616070528C3E}"/>
               </a:ext>
             </a:extLst>
           </p:cNvPr>
@@ -3193,7 +3191,7 @@
           <p:cNvPr id="10" name="">
             <a:extLst xmlns:a="http://schemas.openxmlformats.org/drawingml/2006/main">
               <a:ext uri="{FF2B5EF4-FFF2-40B4-BE49-F238E27FC236}">
-                <a16:creationId xmlns:a16="http://schemas.microsoft.com/office/drawing/2014/main" id="{99C9A071-E43E-4F91-834A-630D63A231D6}"/>
+                <a16:creationId xmlns:a16="http://schemas.microsoft.com/office/drawing/2014/main" id="{5ED11488-AC3A-4718-80ED-2DD73046DCD4}"/>
               </a:ext>
             </a:extLst>
           </p:cNvPr>
@@ -3224,7 +3222,7 @@
           <p:cNvPr id="11" name="">
             <a:extLst xmlns:a="http://schemas.openxmlformats.org/drawingml/2006/main">
               <a:ext uri="{FF2B5EF4-FFF2-40B4-BE49-F238E27FC236}">
-                <a16:creationId xmlns:a16="http://schemas.microsoft.com/office/drawing/2014/main" id="{BC3733D6-9D72-49AB-9421-8DCF255116CD}"/>
+                <a16:creationId xmlns:a16="http://schemas.microsoft.com/office/drawing/2014/main" id="{7A5D0C6C-9CC1-4262-B847-23B76DD4AD09}"/>
               </a:ext>
             </a:extLst>
           </p:cNvPr>
@@ -3255,7 +3253,7 @@
           <p:cNvPr id="12" name="">
             <a:extLst xmlns:a="http://schemas.openxmlformats.org/drawingml/2006/main">
               <a:ext uri="{FF2B5EF4-FFF2-40B4-BE49-F238E27FC236}">
-                <a16:creationId xmlns:a16="http://schemas.microsoft.com/office/drawing/2014/main" id="{7818DD50-8D89-4760-8B91-F49EE8BB514A}"/>
+                <a16:creationId xmlns:a16="http://schemas.microsoft.com/office/drawing/2014/main" id="{2922E030-6E3F-4D18-9A8F-FAE1C888890D}"/>
               </a:ext>
             </a:extLst>
           </p:cNvPr>
@@ -3286,7 +3284,7 @@
           <p:cNvPr id="13" name="">
             <a:extLst xmlns:a="http://schemas.openxmlformats.org/drawingml/2006/main">
               <a:ext uri="{FF2B5EF4-FFF2-40B4-BE49-F238E27FC236}">
-                <a16:creationId xmlns:a16="http://schemas.microsoft.com/office/drawing/2014/main" id="{94879B9F-8989-48B9-9B33-36925582437B}"/>
+                <a16:creationId xmlns:a16="http://schemas.microsoft.com/office/drawing/2014/main" id="{8668C1DA-478E-40AE-BF4D-4BE5BFA2C98C}"/>
               </a:ext>
             </a:extLst>
           </p:cNvPr>
@@ -3342,7 +3340,7 @@
           <p:cNvPr id="14" name="">
             <a:extLst xmlns:a="http://schemas.openxmlformats.org/drawingml/2006/main">
               <a:ext uri="{FF2B5EF4-FFF2-40B4-BE49-F238E27FC236}">
-                <a16:creationId xmlns:a16="http://schemas.microsoft.com/office/drawing/2014/main" id="{76B824EC-4EA8-45D9-A8CF-6C87C8ADE340}"/>
+                <a16:creationId xmlns:a16="http://schemas.microsoft.com/office/drawing/2014/main" id="{D06DDAEB-9358-489B-AE96-B080AC0268E9}"/>
               </a:ext>
             </a:extLst>
           </p:cNvPr>
@@ -3381,7 +3379,7 @@
           <p:cNvPr id="15" name="">
             <a:extLst xmlns:a="http://schemas.openxmlformats.org/drawingml/2006/main">
               <a:ext uri="{FF2B5EF4-FFF2-40B4-BE49-F238E27FC236}">
-                <a16:creationId xmlns:a16="http://schemas.microsoft.com/office/drawing/2014/main" id="{0196A5EE-8CDF-4F6B-9EED-615EAEA89141}"/>
+                <a16:creationId xmlns:a16="http://schemas.microsoft.com/office/drawing/2014/main" id="{E42DB982-DD98-49B1-B5A6-CC39B54C7399}"/>
               </a:ext>
             </a:extLst>
           </p:cNvPr>
@@ -3437,7 +3435,7 @@
           <p:cNvPr id="16" name="">
             <a:extLst xmlns:a="http://schemas.openxmlformats.org/drawingml/2006/main">
               <a:ext uri="{FF2B5EF4-FFF2-40B4-BE49-F238E27FC236}">
-                <a16:creationId xmlns:a16="http://schemas.microsoft.com/office/drawing/2014/main" id="{62724713-765C-4B78-9D04-FF0CE020368D}"/>
+                <a16:creationId xmlns:a16="http://schemas.microsoft.com/office/drawing/2014/main" id="{81DDCE90-0DCD-4BE9-8A30-4897E11CEB3B}"/>
               </a:ext>
             </a:extLst>
           </p:cNvPr>
@@ -3476,7 +3474,7 @@
           <p:cNvPr id="17" name="">
             <a:extLst xmlns:a="http://schemas.openxmlformats.org/drawingml/2006/main">
               <a:ext uri="{FF2B5EF4-FFF2-40B4-BE49-F238E27FC236}">
-                <a16:creationId xmlns:a16="http://schemas.microsoft.com/office/drawing/2014/main" id="{A75DCD80-7C5B-4C59-B5F7-E1B5C91C344B}"/>
+                <a16:creationId xmlns:a16="http://schemas.microsoft.com/office/drawing/2014/main" id="{5DDD2B70-C9C5-4856-AFF7-8ECD019264CA}"/>
               </a:ext>
             </a:extLst>
           </p:cNvPr>
@@ -3532,7 +3530,7 @@
           <p:cNvPr id="18" name="">
             <a:extLst xmlns:a="http://schemas.openxmlformats.org/drawingml/2006/main">
               <a:ext uri="{FF2B5EF4-FFF2-40B4-BE49-F238E27FC236}">
-                <a16:creationId xmlns:a16="http://schemas.microsoft.com/office/drawing/2014/main" id="{777F50D9-2487-42D6-A90F-5C26A03012A7}"/>
+                <a16:creationId xmlns:a16="http://schemas.microsoft.com/office/drawing/2014/main" id="{B6BF82C0-97BA-4136-A258-2B85A164A851}"/>
               </a:ext>
             </a:extLst>
           </p:cNvPr>
@@ -3571,7 +3569,7 @@
           <p:cNvPr id="19" name="">
             <a:extLst xmlns:a="http://schemas.openxmlformats.org/drawingml/2006/main">
               <a:ext uri="{FF2B5EF4-FFF2-40B4-BE49-F238E27FC236}">
-                <a16:creationId xmlns:a16="http://schemas.microsoft.com/office/drawing/2014/main" id="{C814E002-4751-4444-9299-FD4A6EC7CCC2}"/>
+                <a16:creationId xmlns:a16="http://schemas.microsoft.com/office/drawing/2014/main" id="{F21AB985-96FD-47B2-8C54-4783A1C23290}"/>
               </a:ext>
             </a:extLst>
           </p:cNvPr>
@@ -3650,7 +3648,7 @@
           <p:cNvPr id="20" name="">
             <a:extLst xmlns:a="http://schemas.openxmlformats.org/drawingml/2006/main">
               <a:ext uri="{FF2B5EF4-FFF2-40B4-BE49-F238E27FC236}">
-                <a16:creationId xmlns:a16="http://schemas.microsoft.com/office/drawing/2014/main" id="{11A4616F-9010-4BC3-9A97-31AC7400919B}"/>
+                <a16:creationId xmlns:a16="http://schemas.microsoft.com/office/drawing/2014/main" id="{E51F1144-D5D9-4ECE-8902-980EB519BC51}"/>
               </a:ext>
             </a:extLst>
           </p:cNvPr>
@@ -3689,7 +3687,7 @@
           <p:cNvPr id="21" name="">
             <a:extLst xmlns:a="http://schemas.openxmlformats.org/drawingml/2006/main">
               <a:ext uri="{FF2B5EF4-FFF2-40B4-BE49-F238E27FC236}">
-                <a16:creationId xmlns:a16="http://schemas.microsoft.com/office/drawing/2014/main" id="{E2DBB56E-BAF8-443A-8D8A-96BA93CB26C4}"/>
+                <a16:creationId xmlns:a16="http://schemas.microsoft.com/office/drawing/2014/main" id="{92D943EC-32B8-4E73-BA5F-8D3B6681A8E5}"/>
               </a:ext>
             </a:extLst>
           </p:cNvPr>
@@ -3745,7 +3743,7 @@
           <p:cNvPr id="22" name="">
             <a:extLst xmlns:a="http://schemas.openxmlformats.org/drawingml/2006/main">
               <a:ext uri="{FF2B5EF4-FFF2-40B4-BE49-F238E27FC236}">
-                <a16:creationId xmlns:a16="http://schemas.microsoft.com/office/drawing/2014/main" id="{ACEF2923-9CCE-46BA-A47E-EE05C24E4E44}"/>
+                <a16:creationId xmlns:a16="http://schemas.microsoft.com/office/drawing/2014/main" id="{2A26362C-758C-4B1C-8CB4-A24018F65371}"/>
               </a:ext>
             </a:extLst>
           </p:cNvPr>
@@ -3799,7 +3797,7 @@
     </p:spTree>
     <p:extLst>
       <p:ext uri="{BB962C8B-B14F-4D97-AF65-F5344CB8AC3E}">
-        <p14:creationId xmlns:p14="http://schemas.microsoft.com/office/powerpoint/2010/main" val="1975890660"/>
+        <p14:creationId xmlns:p14="http://schemas.microsoft.com/office/powerpoint/2010/main" val="563672713"/>
       </p:ext>
     </p:extLst>
   </p:cSld>
@@ -3830,7 +3828,7 @@
           <p:cNvPr id="1" name="">
             <a:extLst xmlns:a="http://schemas.openxmlformats.org/drawingml/2006/main">
               <a:ext uri="{FF2B5EF4-FFF2-40B4-BE49-F238E27FC236}">
-                <a16:creationId xmlns:a16="http://schemas.microsoft.com/office/drawing/2014/main" id="{09226916-52FF-49C9-848B-BA91BD2BBB3C}"/>
+                <a16:creationId xmlns:a16="http://schemas.microsoft.com/office/drawing/2014/main" id="{02969056-A164-4173-BEF3-FC499CF00835}"/>
               </a:ext>
             </a:extLst>
           </p:cNvPr>
@@ -3861,7 +3859,7 @@
           <p:cNvPr id="2" name="">
             <a:extLst xmlns:a="http://schemas.openxmlformats.org/drawingml/2006/main">
               <a:ext uri="{FF2B5EF4-FFF2-40B4-BE49-F238E27FC236}">
-                <a16:creationId xmlns:a16="http://schemas.microsoft.com/office/drawing/2014/main" id="{7897CFCC-883A-4F5D-9633-910BE9B2C1A7}"/>
+                <a16:creationId xmlns:a16="http://schemas.microsoft.com/office/drawing/2014/main" id="{9BC85F7C-57F7-4F91-AE7F-6634894E1C84}"/>
               </a:ext>
             </a:extLst>
           </p:cNvPr>
@@ -3892,7 +3890,7 @@
           <p:cNvPr id="3" name="">
             <a:extLst xmlns:a="http://schemas.openxmlformats.org/drawingml/2006/main">
               <a:ext uri="{FF2B5EF4-FFF2-40B4-BE49-F238E27FC236}">
-                <a16:creationId xmlns:a16="http://schemas.microsoft.com/office/drawing/2014/main" id="{0500C0C7-81CF-42F8-9D60-F91535B1D21C}"/>
+                <a16:creationId xmlns:a16="http://schemas.microsoft.com/office/drawing/2014/main" id="{F7AB482D-C3D8-406B-B9A4-C9F895EE9AFA}"/>
               </a:ext>
             </a:extLst>
           </p:cNvPr>
@@ -3923,7 +3921,7 @@
           <p:cNvPr id="4" name="">
             <a:extLst xmlns:a="http://schemas.openxmlformats.org/drawingml/2006/main">
               <a:ext uri="{FF2B5EF4-FFF2-40B4-BE49-F238E27FC236}">
-                <a16:creationId xmlns:a16="http://schemas.microsoft.com/office/drawing/2014/main" id="{C2C0FA4B-675D-4363-90DD-B4F6F8FBD95D}"/>
+                <a16:creationId xmlns:a16="http://schemas.microsoft.com/office/drawing/2014/main" id="{9648BC2F-03A6-4948-AB82-ECF569959A4D}"/>
               </a:ext>
             </a:extLst>
           </p:cNvPr>
@@ -3954,7 +3952,7 @@
           <p:cNvPr id="5" name="">
             <a:extLst xmlns:a="http://schemas.openxmlformats.org/drawingml/2006/main">
               <a:ext uri="{FF2B5EF4-FFF2-40B4-BE49-F238E27FC236}">
-                <a16:creationId xmlns:a16="http://schemas.microsoft.com/office/drawing/2014/main" id="{50D80090-C4BA-47C2-99DF-85AB15CF0326}"/>
+                <a16:creationId xmlns:a16="http://schemas.microsoft.com/office/drawing/2014/main" id="{03BFD25A-34D2-4DC5-B85A-F0084D3C7B07}"/>
               </a:ext>
             </a:extLst>
           </p:cNvPr>
@@ -3985,7 +3983,7 @@
           <p:cNvPr id="6" name="">
             <a:extLst xmlns:a="http://schemas.openxmlformats.org/drawingml/2006/main">
               <a:ext uri="{FF2B5EF4-FFF2-40B4-BE49-F238E27FC236}">
-                <a16:creationId xmlns:a16="http://schemas.microsoft.com/office/drawing/2014/main" id="{CC0C4E34-394D-4AA2-8536-9B8395DE55AC}"/>
+                <a16:creationId xmlns:a16="http://schemas.microsoft.com/office/drawing/2014/main" id="{E5A4FB09-D0D6-41E8-81F9-752484399084}"/>
               </a:ext>
             </a:extLst>
           </p:cNvPr>
@@ -4016,7 +4014,7 @@
           <p:cNvPr id="7" name="">
             <a:extLst xmlns:a="http://schemas.openxmlformats.org/drawingml/2006/main">
               <a:ext uri="{FF2B5EF4-FFF2-40B4-BE49-F238E27FC236}">
-                <a16:creationId xmlns:a16="http://schemas.microsoft.com/office/drawing/2014/main" id="{448C61AD-1AA3-473D-AAB7-C383FE915DE0}"/>
+                <a16:creationId xmlns:a16="http://schemas.microsoft.com/office/drawing/2014/main" id="{672628A8-E7B5-4294-81AD-C7404485ED34}"/>
               </a:ext>
             </a:extLst>
           </p:cNvPr>
@@ -4047,7 +4045,7 @@
           <p:cNvPr id="8" name="">
             <a:extLst xmlns:a="http://schemas.openxmlformats.org/drawingml/2006/main">
               <a:ext uri="{FF2B5EF4-FFF2-40B4-BE49-F238E27FC236}">
-                <a16:creationId xmlns:a16="http://schemas.microsoft.com/office/drawing/2014/main" id="{97DB5D24-4742-49A6-801A-5A3A6706D51D}"/>
+                <a16:creationId xmlns:a16="http://schemas.microsoft.com/office/drawing/2014/main" id="{0FFC8661-59F6-4505-AC86-FDC291111831}"/>
               </a:ext>
             </a:extLst>
           </p:cNvPr>
@@ -4078,7 +4076,7 @@
           <p:cNvPr id="9" name="">
             <a:extLst xmlns:a="http://schemas.openxmlformats.org/drawingml/2006/main">
               <a:ext uri="{FF2B5EF4-FFF2-40B4-BE49-F238E27FC236}">
-                <a16:creationId xmlns:a16="http://schemas.microsoft.com/office/drawing/2014/main" id="{DA1B00BC-BEF0-4C84-9D0C-885F2C148D35}"/>
+                <a16:creationId xmlns:a16="http://schemas.microsoft.com/office/drawing/2014/main" id="{2238A6DB-42DE-4A39-9705-134623EE4C09}"/>
               </a:ext>
             </a:extLst>
           </p:cNvPr>
@@ -4109,7 +4107,7 @@
           <p:cNvPr id="10" name="">
             <a:extLst xmlns:a="http://schemas.openxmlformats.org/drawingml/2006/main">
               <a:ext uri="{FF2B5EF4-FFF2-40B4-BE49-F238E27FC236}">
-                <a16:creationId xmlns:a16="http://schemas.microsoft.com/office/drawing/2014/main" id="{F6853299-EA09-47EC-AE7A-8CD1D72F6503}"/>
+                <a16:creationId xmlns:a16="http://schemas.microsoft.com/office/drawing/2014/main" id="{791DAE06-3902-4C97-ACAB-B81FE04C99D9}"/>
               </a:ext>
             </a:extLst>
           </p:cNvPr>
@@ -4140,7 +4138,7 @@
           <p:cNvPr id="11" name="">
             <a:extLst xmlns:a="http://schemas.openxmlformats.org/drawingml/2006/main">
               <a:ext uri="{FF2B5EF4-FFF2-40B4-BE49-F238E27FC236}">
-                <a16:creationId xmlns:a16="http://schemas.microsoft.com/office/drawing/2014/main" id="{657032CB-2D76-495F-9FE3-0AF2BD68F9A8}"/>
+                <a16:creationId xmlns:a16="http://schemas.microsoft.com/office/drawing/2014/main" id="{A30C506E-A930-4135-B0E2-A040DEDC74EC}"/>
               </a:ext>
             </a:extLst>
           </p:cNvPr>
@@ -4171,7 +4169,7 @@
           <p:cNvPr id="12" name="">
             <a:extLst xmlns:a="http://schemas.openxmlformats.org/drawingml/2006/main">
               <a:ext uri="{FF2B5EF4-FFF2-40B4-BE49-F238E27FC236}">
-                <a16:creationId xmlns:a16="http://schemas.microsoft.com/office/drawing/2014/main" id="{7407AEF1-4F06-400B-B046-C1EB707C859D}"/>
+                <a16:creationId xmlns:a16="http://schemas.microsoft.com/office/drawing/2014/main" id="{0D0CAD2C-DACE-4717-89E1-920AD87A3D0C}"/>
               </a:ext>
             </a:extLst>
           </p:cNvPr>
@@ -4202,7 +4200,7 @@
           <p:cNvPr id="13" name="">
             <a:extLst xmlns:a="http://schemas.openxmlformats.org/drawingml/2006/main">
               <a:ext uri="{FF2B5EF4-FFF2-40B4-BE49-F238E27FC236}">
-                <a16:creationId xmlns:a16="http://schemas.microsoft.com/office/drawing/2014/main" id="{5CFDE541-8189-45BE-B6EA-D619246CE31A}"/>
+                <a16:creationId xmlns:a16="http://schemas.microsoft.com/office/drawing/2014/main" id="{30AFBCE2-3EC1-4EB3-B7F0-DDACA588A960}"/>
               </a:ext>
             </a:extLst>
           </p:cNvPr>
@@ -4258,7 +4256,7 @@
           <p:cNvPr id="14" name="">
             <a:extLst xmlns:a="http://schemas.openxmlformats.org/drawingml/2006/main">
               <a:ext uri="{FF2B5EF4-FFF2-40B4-BE49-F238E27FC236}">
-                <a16:creationId xmlns:a16="http://schemas.microsoft.com/office/drawing/2014/main" id="{4387ABFA-027C-41B2-B3D1-DC6C7BD47CD7}"/>
+                <a16:creationId xmlns:a16="http://schemas.microsoft.com/office/drawing/2014/main" id="{5D454834-1C53-4EFF-83A3-5B8C181AE967}"/>
               </a:ext>
             </a:extLst>
           </p:cNvPr>
@@ -4289,7 +4287,7 @@
           <p:cNvPr id="15" name="">
             <a:extLst xmlns:a="http://schemas.openxmlformats.org/drawingml/2006/main">
               <a:ext uri="{FF2B5EF4-FFF2-40B4-BE49-F238E27FC236}">
-                <a16:creationId xmlns:a16="http://schemas.microsoft.com/office/drawing/2014/main" id="{AD143E5B-F768-4CF6-A90F-F93F96F5AA4F}"/>
+                <a16:creationId xmlns:a16="http://schemas.microsoft.com/office/drawing/2014/main" id="{12B89D19-2865-493A-BA62-B4B2C451B381}"/>
               </a:ext>
             </a:extLst>
           </p:cNvPr>
@@ -4345,7 +4343,7 @@
           <p:cNvPr id="16" name="">
             <a:extLst xmlns:a="http://schemas.openxmlformats.org/drawingml/2006/main">
               <a:ext uri="{FF2B5EF4-FFF2-40B4-BE49-F238E27FC236}">
-                <a16:creationId xmlns:a16="http://schemas.microsoft.com/office/drawing/2014/main" id="{86812D3F-A706-4CF1-BD80-CA0A14BD5948}"/>
+                <a16:creationId xmlns:a16="http://schemas.microsoft.com/office/drawing/2014/main" id="{59112C3A-5985-44D4-BDD0-CFA968011A01}"/>
               </a:ext>
             </a:extLst>
           </p:cNvPr>
@@ -4384,7 +4382,7 @@
           <p:cNvPr id="17" name="">
             <a:extLst xmlns:a="http://schemas.openxmlformats.org/drawingml/2006/main">
               <a:ext uri="{FF2B5EF4-FFF2-40B4-BE49-F238E27FC236}">
-                <a16:creationId xmlns:a16="http://schemas.microsoft.com/office/drawing/2014/main" id="{55BD5FD5-559F-44C6-A514-41D55C4AC184}"/>
+                <a16:creationId xmlns:a16="http://schemas.microsoft.com/office/drawing/2014/main" id="{A6F69F4F-BA7F-4E3D-99BB-62BB1D27B6F2}"/>
               </a:ext>
             </a:extLst>
           </p:cNvPr>
@@ -4440,7 +4438,7 @@
           <p:cNvPr id="18" name="">
             <a:extLst xmlns:a="http://schemas.openxmlformats.org/drawingml/2006/main">
               <a:ext uri="{FF2B5EF4-FFF2-40B4-BE49-F238E27FC236}">
-                <a16:creationId xmlns:a16="http://schemas.microsoft.com/office/drawing/2014/main" id="{E7B6B89C-15A5-4FB9-9B88-92F945530C7D}"/>
+                <a16:creationId xmlns:a16="http://schemas.microsoft.com/office/drawing/2014/main" id="{BAB11529-C5F6-45F7-88A7-D3D4B79086DC}"/>
               </a:ext>
             </a:extLst>
           </p:cNvPr>
@@ -4471,7 +4469,7 @@
           <p:cNvPr id="19" name="">
             <a:extLst xmlns:a="http://schemas.openxmlformats.org/drawingml/2006/main">
               <a:ext uri="{FF2B5EF4-FFF2-40B4-BE49-F238E27FC236}">
-                <a16:creationId xmlns:a16="http://schemas.microsoft.com/office/drawing/2014/main" id="{3D7A81A8-FCEA-4E65-AC49-505DB738FAC8}"/>
+                <a16:creationId xmlns:a16="http://schemas.microsoft.com/office/drawing/2014/main" id="{159A1091-E068-4384-A2E8-215595AE4139}"/>
               </a:ext>
             </a:extLst>
           </p:cNvPr>
@@ -4527,7 +4525,7 @@
           <p:cNvPr id="20" name="">
             <a:extLst xmlns:a="http://schemas.openxmlformats.org/drawingml/2006/main">
               <a:ext uri="{FF2B5EF4-FFF2-40B4-BE49-F238E27FC236}">
-                <a16:creationId xmlns:a16="http://schemas.microsoft.com/office/drawing/2014/main" id="{31B80706-0AA9-499C-92EF-C8DE6AF0292E}"/>
+                <a16:creationId xmlns:a16="http://schemas.microsoft.com/office/drawing/2014/main" id="{7C029836-C16C-47C7-9FF5-ED1EAAA0C952}"/>
               </a:ext>
             </a:extLst>
           </p:cNvPr>
@@ -4566,7 +4564,7 @@
           <p:cNvPr id="21" name="">
             <a:extLst xmlns:a="http://schemas.openxmlformats.org/drawingml/2006/main">
               <a:ext uri="{FF2B5EF4-FFF2-40B4-BE49-F238E27FC236}">
-                <a16:creationId xmlns:a16="http://schemas.microsoft.com/office/drawing/2014/main" id="{401B8BA6-87D1-46CD-89ED-4576B38DF49A}"/>
+                <a16:creationId xmlns:a16="http://schemas.microsoft.com/office/drawing/2014/main" id="{40A0F41D-C5F6-4754-A30D-997202B4A560}"/>
               </a:ext>
             </a:extLst>
           </p:cNvPr>
@@ -4622,7 +4620,7 @@
           <p:cNvPr id="22" name="">
             <a:extLst xmlns:a="http://schemas.openxmlformats.org/drawingml/2006/main">
               <a:ext uri="{FF2B5EF4-FFF2-40B4-BE49-F238E27FC236}">
-                <a16:creationId xmlns:a16="http://schemas.microsoft.com/office/drawing/2014/main" id="{27FA70D8-63B8-41CD-9465-F3625E1963A7}"/>
+                <a16:creationId xmlns:a16="http://schemas.microsoft.com/office/drawing/2014/main" id="{9F434D27-92BA-4F4E-A794-FFAE7D7AFE17}"/>
               </a:ext>
             </a:extLst>
           </p:cNvPr>
@@ -4653,7 +4651,7 @@
           <p:cNvPr id="23" name="">
             <a:extLst xmlns:a="http://schemas.openxmlformats.org/drawingml/2006/main">
               <a:ext uri="{FF2B5EF4-FFF2-40B4-BE49-F238E27FC236}">
-                <a16:creationId xmlns:a16="http://schemas.microsoft.com/office/drawing/2014/main" id="{FB8B2D20-0EA1-46EF-A246-EBE6C41FE5E6}"/>
+                <a16:creationId xmlns:a16="http://schemas.microsoft.com/office/drawing/2014/main" id="{7154C66A-4940-4320-B939-723DE4D69D1D}"/>
               </a:ext>
             </a:extLst>
           </p:cNvPr>
@@ -4709,7 +4707,7 @@
           <p:cNvPr id="24" name="">
             <a:extLst xmlns:a="http://schemas.openxmlformats.org/drawingml/2006/main">
               <a:ext uri="{FF2B5EF4-FFF2-40B4-BE49-F238E27FC236}">
-                <a16:creationId xmlns:a16="http://schemas.microsoft.com/office/drawing/2014/main" id="{80855976-0730-4DDC-871A-4F8EFD00ED6D}"/>
+                <a16:creationId xmlns:a16="http://schemas.microsoft.com/office/drawing/2014/main" id="{F119727B-3AD0-4B0F-9B1E-D723D64337E5}"/>
               </a:ext>
             </a:extLst>
           </p:cNvPr>
@@ -4748,7 +4746,7 @@
           <p:cNvPr id="25" name="">
             <a:extLst xmlns:a="http://schemas.openxmlformats.org/drawingml/2006/main">
               <a:ext uri="{FF2B5EF4-FFF2-40B4-BE49-F238E27FC236}">
-                <a16:creationId xmlns:a16="http://schemas.microsoft.com/office/drawing/2014/main" id="{069AB0D4-DC29-4242-BE28-B014366C689D}"/>
+                <a16:creationId xmlns:a16="http://schemas.microsoft.com/office/drawing/2014/main" id="{159F9AC9-7457-41AF-8DAA-65781493605C}"/>
               </a:ext>
             </a:extLst>
           </p:cNvPr>
@@ -4804,7 +4802,7 @@
           <p:cNvPr id="26" name="">
             <a:extLst xmlns:a="http://schemas.openxmlformats.org/drawingml/2006/main">
               <a:ext uri="{FF2B5EF4-FFF2-40B4-BE49-F238E27FC236}">
-                <a16:creationId xmlns:a16="http://schemas.microsoft.com/office/drawing/2014/main" id="{322039B0-E809-4A97-BB55-9F97D70FD71C}"/>
+                <a16:creationId xmlns:a16="http://schemas.microsoft.com/office/drawing/2014/main" id="{545236D9-B915-4DF1-B3F4-FF08EA41AA67}"/>
               </a:ext>
             </a:extLst>
           </p:cNvPr>
@@ -4835,7 +4833,7 @@
           <p:cNvPr id="27" name="">
             <a:extLst xmlns:a="http://schemas.openxmlformats.org/drawingml/2006/main">
               <a:ext uri="{FF2B5EF4-FFF2-40B4-BE49-F238E27FC236}">
-                <a16:creationId xmlns:a16="http://schemas.microsoft.com/office/drawing/2014/main" id="{ADB71514-ECE2-4944-8CE1-F5265668F927}"/>
+                <a16:creationId xmlns:a16="http://schemas.microsoft.com/office/drawing/2014/main" id="{F949DB26-5BB9-4C99-B65F-FD09E8C1DBE9}"/>
               </a:ext>
             </a:extLst>
           </p:cNvPr>
@@ -4891,7 +4889,7 @@
           <p:cNvPr id="28" name="">
             <a:extLst xmlns:a="http://schemas.openxmlformats.org/drawingml/2006/main">
               <a:ext uri="{FF2B5EF4-FFF2-40B4-BE49-F238E27FC236}">
-                <a16:creationId xmlns:a16="http://schemas.microsoft.com/office/drawing/2014/main" id="{C4608FD0-B508-4AC2-9160-8B67CB0BE7EE}"/>
+                <a16:creationId xmlns:a16="http://schemas.microsoft.com/office/drawing/2014/main" id="{58B025BD-3403-4371-9480-20B8A8D9F2DF}"/>
               </a:ext>
             </a:extLst>
           </p:cNvPr>
@@ -4930,7 +4928,7 @@
           <p:cNvPr id="29" name="">
             <a:extLst xmlns:a="http://schemas.openxmlformats.org/drawingml/2006/main">
               <a:ext uri="{FF2B5EF4-FFF2-40B4-BE49-F238E27FC236}">
-                <a16:creationId xmlns:a16="http://schemas.microsoft.com/office/drawing/2014/main" id="{732E500E-5E65-4320-8C14-0588F011A7A0}"/>
+                <a16:creationId xmlns:a16="http://schemas.microsoft.com/office/drawing/2014/main" id="{BF5C96C6-7822-4DEA-9868-57F953F23630}"/>
               </a:ext>
             </a:extLst>
           </p:cNvPr>
@@ -4986,7 +4984,7 @@
           <p:cNvPr id="30" name="">
             <a:extLst xmlns:a="http://schemas.openxmlformats.org/drawingml/2006/main">
               <a:ext uri="{FF2B5EF4-FFF2-40B4-BE49-F238E27FC236}">
-                <a16:creationId xmlns:a16="http://schemas.microsoft.com/office/drawing/2014/main" id="{398CF8DB-1789-49A9-9759-18F77DB1AF5B}"/>
+                <a16:creationId xmlns:a16="http://schemas.microsoft.com/office/drawing/2014/main" id="{5E712D31-802C-475F-A81D-FA477990D575}"/>
               </a:ext>
             </a:extLst>
           </p:cNvPr>
@@ -5040,7 +5038,7 @@
     </p:spTree>
     <p:extLst>
       <p:ext uri="{BB962C8B-B14F-4D97-AF65-F5344CB8AC3E}">
-        <p14:creationId xmlns:p14="http://schemas.microsoft.com/office/powerpoint/2010/main" val="325159846"/>
+        <p14:creationId xmlns:p14="http://schemas.microsoft.com/office/powerpoint/2010/main" val="1329642175"/>
       </p:ext>
     </p:extLst>
   </p:cSld>
@@ -5071,7 +5069,7 @@
           <p:cNvPr id="1" name="">
             <a:extLst xmlns:a="http://schemas.openxmlformats.org/drawingml/2006/main">
               <a:ext uri="{FF2B5EF4-FFF2-40B4-BE49-F238E27FC236}">
-                <a16:creationId xmlns:a16="http://schemas.microsoft.com/office/drawing/2014/main" id="{A99AE649-64CD-4966-A5AB-05CE574D29F1}"/>
+                <a16:creationId xmlns:a16="http://schemas.microsoft.com/office/drawing/2014/main" id="{0B6ABCA1-2513-476F-8CC4-0539A25D4F8D}"/>
               </a:ext>
             </a:extLst>
           </p:cNvPr>
@@ -5102,7 +5100,7 @@
           <p:cNvPr id="2" name="">
             <a:extLst xmlns:a="http://schemas.openxmlformats.org/drawingml/2006/main">
               <a:ext uri="{FF2B5EF4-FFF2-40B4-BE49-F238E27FC236}">
-                <a16:creationId xmlns:a16="http://schemas.microsoft.com/office/drawing/2014/main" id="{0F467019-2F13-422E-9EB2-B91A37EAEDD4}"/>
+                <a16:creationId xmlns:a16="http://schemas.microsoft.com/office/drawing/2014/main" id="{60015598-C356-4A5E-AC1D-5DE1FE870658}"/>
               </a:ext>
             </a:extLst>
           </p:cNvPr>
@@ -5133,7 +5131,7 @@
           <p:cNvPr id="3" name="">
             <a:extLst xmlns:a="http://schemas.openxmlformats.org/drawingml/2006/main">
               <a:ext uri="{FF2B5EF4-FFF2-40B4-BE49-F238E27FC236}">
-                <a16:creationId xmlns:a16="http://schemas.microsoft.com/office/drawing/2014/main" id="{2683FF68-A755-4E87-B04A-A632E49FEB46}"/>
+                <a16:creationId xmlns:a16="http://schemas.microsoft.com/office/drawing/2014/main" id="{EDCFF0B0-AB66-4509-A934-AAF3E7925B03}"/>
               </a:ext>
             </a:extLst>
           </p:cNvPr>
@@ -5164,7 +5162,7 @@
           <p:cNvPr id="4" name="">
             <a:extLst xmlns:a="http://schemas.openxmlformats.org/drawingml/2006/main">
               <a:ext uri="{FF2B5EF4-FFF2-40B4-BE49-F238E27FC236}">
-                <a16:creationId xmlns:a16="http://schemas.microsoft.com/office/drawing/2014/main" id="{5FA79F40-EA16-489E-AB65-4E86F59C4161}"/>
+                <a16:creationId xmlns:a16="http://schemas.microsoft.com/office/drawing/2014/main" id="{AD4709F7-F36D-4662-811D-312CF1A05C1E}"/>
               </a:ext>
             </a:extLst>
           </p:cNvPr>
@@ -5195,7 +5193,7 @@
           <p:cNvPr id="5" name="">
             <a:extLst xmlns:a="http://schemas.openxmlformats.org/drawingml/2006/main">
               <a:ext uri="{FF2B5EF4-FFF2-40B4-BE49-F238E27FC236}">
-                <a16:creationId xmlns:a16="http://schemas.microsoft.com/office/drawing/2014/main" id="{3E60EB2C-7230-403A-8CB8-D28CD11A3D9D}"/>
+                <a16:creationId xmlns:a16="http://schemas.microsoft.com/office/drawing/2014/main" id="{AC668C53-C89A-48B9-8EF5-5CC5647A686A}"/>
               </a:ext>
             </a:extLst>
           </p:cNvPr>
@@ -5226,7 +5224,7 @@
           <p:cNvPr id="6" name="">
             <a:extLst xmlns:a="http://schemas.openxmlformats.org/drawingml/2006/main">
               <a:ext uri="{FF2B5EF4-FFF2-40B4-BE49-F238E27FC236}">
-                <a16:creationId xmlns:a16="http://schemas.microsoft.com/office/drawing/2014/main" id="{5D552A14-A0F2-4FFB-A7DB-1EE37422D2E6}"/>
+                <a16:creationId xmlns:a16="http://schemas.microsoft.com/office/drawing/2014/main" id="{66BA00D0-DE85-4187-B74F-592BF3DE341B}"/>
               </a:ext>
             </a:extLst>
           </p:cNvPr>
@@ -5257,7 +5255,7 @@
           <p:cNvPr id="7" name="">
             <a:extLst xmlns:a="http://schemas.openxmlformats.org/drawingml/2006/main">
               <a:ext uri="{FF2B5EF4-FFF2-40B4-BE49-F238E27FC236}">
-                <a16:creationId xmlns:a16="http://schemas.microsoft.com/office/drawing/2014/main" id="{B7B18E35-B9B8-4806-8FA9-E6864EC1FB31}"/>
+                <a16:creationId xmlns:a16="http://schemas.microsoft.com/office/drawing/2014/main" id="{90ABE46A-C4D7-46E8-8A8E-CD9EB6224A1A}"/>
               </a:ext>
             </a:extLst>
           </p:cNvPr>
@@ -5288,7 +5286,7 @@
           <p:cNvPr id="8" name="">
             <a:extLst xmlns:a="http://schemas.openxmlformats.org/drawingml/2006/main">
               <a:ext uri="{FF2B5EF4-FFF2-40B4-BE49-F238E27FC236}">
-                <a16:creationId xmlns:a16="http://schemas.microsoft.com/office/drawing/2014/main" id="{35D65569-271B-4B22-BE4B-4CBB46280AB3}"/>
+                <a16:creationId xmlns:a16="http://schemas.microsoft.com/office/drawing/2014/main" id="{88292338-1415-47E4-845E-955D6764BA24}"/>
               </a:ext>
             </a:extLst>
           </p:cNvPr>
@@ -5319,7 +5317,7 @@
           <p:cNvPr id="9" name="">
             <a:extLst xmlns:a="http://schemas.openxmlformats.org/drawingml/2006/main">
               <a:ext uri="{FF2B5EF4-FFF2-40B4-BE49-F238E27FC236}">
-                <a16:creationId xmlns:a16="http://schemas.microsoft.com/office/drawing/2014/main" id="{13F4847D-AE64-49B7-87B2-5D7CF96DDE88}"/>
+                <a16:creationId xmlns:a16="http://schemas.microsoft.com/office/drawing/2014/main" id="{61C593A7-0604-4257-9E96-C85A5F817DC2}"/>
               </a:ext>
             </a:extLst>
           </p:cNvPr>
@@ -5350,7 +5348,7 @@
           <p:cNvPr id="10" name="">
             <a:extLst xmlns:a="http://schemas.openxmlformats.org/drawingml/2006/main">
               <a:ext uri="{FF2B5EF4-FFF2-40B4-BE49-F238E27FC236}">
-                <a16:creationId xmlns:a16="http://schemas.microsoft.com/office/drawing/2014/main" id="{7F50C704-8194-4F0B-98A3-E29CB693099D}"/>
+                <a16:creationId xmlns:a16="http://schemas.microsoft.com/office/drawing/2014/main" id="{4E5CFA68-81F9-4C20-97D2-CA7BAF1251FE}"/>
               </a:ext>
             </a:extLst>
           </p:cNvPr>
@@ -5381,7 +5379,7 @@
           <p:cNvPr id="11" name="">
             <a:extLst xmlns:a="http://schemas.openxmlformats.org/drawingml/2006/main">
               <a:ext uri="{FF2B5EF4-FFF2-40B4-BE49-F238E27FC236}">
-                <a16:creationId xmlns:a16="http://schemas.microsoft.com/office/drawing/2014/main" id="{A056FFCD-19DC-4100-AD63-F35190F33CA8}"/>
+                <a16:creationId xmlns:a16="http://schemas.microsoft.com/office/drawing/2014/main" id="{16C9D946-2D12-489F-8D06-6CCC710BAB9B}"/>
               </a:ext>
             </a:extLst>
           </p:cNvPr>
@@ -5412,7 +5410,7 @@
           <p:cNvPr id="12" name="">
             <a:extLst xmlns:a="http://schemas.openxmlformats.org/drawingml/2006/main">
               <a:ext uri="{FF2B5EF4-FFF2-40B4-BE49-F238E27FC236}">
-                <a16:creationId xmlns:a16="http://schemas.microsoft.com/office/drawing/2014/main" id="{75BEBBBB-5256-4231-A5D4-E82A7C9C3D9F}"/>
+                <a16:creationId xmlns:a16="http://schemas.microsoft.com/office/drawing/2014/main" id="{F475380C-8C2B-4AE3-A4C6-E80C5B32E281}"/>
               </a:ext>
             </a:extLst>
           </p:cNvPr>
@@ -5443,7 +5441,7 @@
           <p:cNvPr id="13" name="">
             <a:extLst xmlns:a="http://schemas.openxmlformats.org/drawingml/2006/main">
               <a:ext uri="{FF2B5EF4-FFF2-40B4-BE49-F238E27FC236}">
-                <a16:creationId xmlns:a16="http://schemas.microsoft.com/office/drawing/2014/main" id="{B603688C-36C7-4D98-BDF6-2FC87138F178}"/>
+                <a16:creationId xmlns:a16="http://schemas.microsoft.com/office/drawing/2014/main" id="{AD8F88BF-92FE-4170-BE44-4790438962CF}"/>
               </a:ext>
             </a:extLst>
           </p:cNvPr>
@@ -5499,7 +5497,7 @@
           <p:cNvPr id="14" name="">
             <a:extLst xmlns:a="http://schemas.openxmlformats.org/drawingml/2006/main">
               <a:ext uri="{FF2B5EF4-FFF2-40B4-BE49-F238E27FC236}">
-                <a16:creationId xmlns:a16="http://schemas.microsoft.com/office/drawing/2014/main" id="{161C0A23-AC5E-4700-938D-2BDB33DA277D}"/>
+                <a16:creationId xmlns:a16="http://schemas.microsoft.com/office/drawing/2014/main" id="{4C8BD96E-B6AA-4914-B1AB-9130F313B55C}"/>
               </a:ext>
             </a:extLst>
           </p:cNvPr>
@@ -5538,7 +5536,7 @@
           <p:cNvPr id="15" name="">
             <a:extLst xmlns:a="http://schemas.openxmlformats.org/drawingml/2006/main">
               <a:ext uri="{FF2B5EF4-FFF2-40B4-BE49-F238E27FC236}">
-                <a16:creationId xmlns:a16="http://schemas.microsoft.com/office/drawing/2014/main" id="{9BC1B1BB-BDAA-44C8-803B-FEE430C01EB9}"/>
+                <a16:creationId xmlns:a16="http://schemas.microsoft.com/office/drawing/2014/main" id="{CFB8AD80-2A73-4CB6-8AEE-35F3A4E8D6BA}"/>
               </a:ext>
             </a:extLst>
           </p:cNvPr>
@@ -5617,7 +5615,7 @@
           <p:cNvPr id="16" name="">
             <a:extLst xmlns:a="http://schemas.openxmlformats.org/drawingml/2006/main">
               <a:ext uri="{FF2B5EF4-FFF2-40B4-BE49-F238E27FC236}">
-                <a16:creationId xmlns:a16="http://schemas.microsoft.com/office/drawing/2014/main" id="{49C045D9-8366-449F-B66D-B8D7A604B248}"/>
+                <a16:creationId xmlns:a16="http://schemas.microsoft.com/office/drawing/2014/main" id="{A8B77A27-1A07-42A3-86FA-78B8D14CAD13}"/>
               </a:ext>
             </a:extLst>
           </p:cNvPr>
@@ -5673,7 +5671,7 @@
           <p:cNvPr id="17" name="">
             <a:extLst xmlns:a="http://schemas.openxmlformats.org/drawingml/2006/main">
               <a:ext uri="{FF2B5EF4-FFF2-40B4-BE49-F238E27FC236}">
-                <a16:creationId xmlns:a16="http://schemas.microsoft.com/office/drawing/2014/main" id="{5844178C-8410-4CEC-8FD6-1006103E4D45}"/>
+                <a16:creationId xmlns:a16="http://schemas.microsoft.com/office/drawing/2014/main" id="{2C19A781-0E54-4691-8DD1-2D998B2476C7}"/>
               </a:ext>
             </a:extLst>
           </p:cNvPr>
@@ -5712,7 +5710,7 @@
           <p:cNvPr id="18" name="">
             <a:extLst xmlns:a="http://schemas.openxmlformats.org/drawingml/2006/main">
               <a:ext uri="{FF2B5EF4-FFF2-40B4-BE49-F238E27FC236}">
-                <a16:creationId xmlns:a16="http://schemas.microsoft.com/office/drawing/2014/main" id="{1BED7050-B7A8-496C-AD43-908F64C9842E}"/>
+                <a16:creationId xmlns:a16="http://schemas.microsoft.com/office/drawing/2014/main" id="{4688234C-1202-4033-9A01-DD1CFC4E2BE8}"/>
               </a:ext>
             </a:extLst>
           </p:cNvPr>
@@ -5772,18 +5770,16 @@
           <p:nvPr/>
         </p:nvPicPr>
         <p:blipFill>
-          <a:blip xmlns:r="http://schemas.openxmlformats.org/officeDocument/2006/relationships" xmlns:a="http://schemas.openxmlformats.org/drawingml/2006/main" r:embed="R50ad4de0d7594424"/>
+          <a:blip xmlns:r="http://schemas.openxmlformats.org/officeDocument/2006/relationships" xmlns:a="http://schemas.openxmlformats.org/drawingml/2006/main" r:embed="R675bd4404c244a20"/>
           <a:stretch xmlns:a="http://schemas.openxmlformats.org/drawingml/2006/main"/>
         </p:blipFill>
         <p:spPr>
           <a:xfrm xmlns:a="http://schemas.openxmlformats.org/drawingml/2006/main">
-            <a:off x="8286750" y="2019927"/>
-            <a:ext cx="2476500" cy="3046747"/>
-          </a:xfrm>
-          <a:prstGeom xmlns:a="http://schemas.openxmlformats.org/drawingml/2006/main" prst="roundRect">
-            <a:avLst>
-              <a:gd name="adj" fmla="val 9231"/>
-            </a:avLst>
+            <a:off x="8293100" y="1695450"/>
+            <a:ext cx="2463800" cy="3695700"/>
+          </a:xfrm>
+          <a:prstGeom xmlns:a="http://schemas.openxmlformats.org/drawingml/2006/main" prst="rect">
+            <a:avLst/>
           </a:prstGeom>
         </p:spPr>
       </p:pic>
@@ -5792,7 +5788,7 @@
           <p:cNvPr id="20" name="">
             <a:extLst xmlns:a="http://schemas.openxmlformats.org/drawingml/2006/main">
               <a:ext uri="{FF2B5EF4-FFF2-40B4-BE49-F238E27FC236}">
-                <a16:creationId xmlns:a16="http://schemas.microsoft.com/office/drawing/2014/main" id="{2FFE2DBC-89C2-4C09-BF4F-EBD1F3ED6AC1}"/>
+                <a16:creationId xmlns:a16="http://schemas.microsoft.com/office/drawing/2014/main" id="{6C29B901-9D94-4743-B469-7DB93E7AD851}"/>
               </a:ext>
             </a:extLst>
           </p:cNvPr>
@@ -5846,7 +5842,7 @@
     </p:spTree>
     <p:extLst>
       <p:ext uri="{BB962C8B-B14F-4D97-AF65-F5344CB8AC3E}">
-        <p14:creationId xmlns:p14="http://schemas.microsoft.com/office/powerpoint/2010/main" val="1273024857"/>
+        <p14:creationId xmlns:p14="http://schemas.microsoft.com/office/powerpoint/2010/main" val="1390550391"/>
       </p:ext>
     </p:extLst>
   </p:cSld>
@@ -5877,7 +5873,7 @@
           <p:cNvPr id="1" name="">
             <a:extLst xmlns:a="http://schemas.openxmlformats.org/drawingml/2006/main">
               <a:ext uri="{FF2B5EF4-FFF2-40B4-BE49-F238E27FC236}">
-                <a16:creationId xmlns:a16="http://schemas.microsoft.com/office/drawing/2014/main" id="{FA40000C-008D-4EB1-AFB0-7461AA1FB4E8}"/>
+                <a16:creationId xmlns:a16="http://schemas.microsoft.com/office/drawing/2014/main" id="{4159A353-8F04-40D7-AA7A-40A56D4EE8E4}"/>
               </a:ext>
             </a:extLst>
           </p:cNvPr>
@@ -5908,7 +5904,7 @@
           <p:cNvPr id="2" name="">
             <a:extLst xmlns:a="http://schemas.openxmlformats.org/drawingml/2006/main">
               <a:ext uri="{FF2B5EF4-FFF2-40B4-BE49-F238E27FC236}">
-                <a16:creationId xmlns:a16="http://schemas.microsoft.com/office/drawing/2014/main" id="{7319DA34-10E0-4A6E-886F-6E0912859485}"/>
+                <a16:creationId xmlns:a16="http://schemas.microsoft.com/office/drawing/2014/main" id="{623734F2-DDF1-4AC7-9187-D6DAFF76BABF}"/>
               </a:ext>
             </a:extLst>
           </p:cNvPr>
@@ -5939,7 +5935,7 @@
           <p:cNvPr id="3" name="">
             <a:extLst xmlns:a="http://schemas.openxmlformats.org/drawingml/2006/main">
               <a:ext uri="{FF2B5EF4-FFF2-40B4-BE49-F238E27FC236}">
-                <a16:creationId xmlns:a16="http://schemas.microsoft.com/office/drawing/2014/main" id="{6B1726CE-3394-42FC-A8AA-FB3485AF3A3E}"/>
+                <a16:creationId xmlns:a16="http://schemas.microsoft.com/office/drawing/2014/main" id="{B4F7A95C-57DF-4E20-A45E-B2B59693651C}"/>
               </a:ext>
             </a:extLst>
           </p:cNvPr>
@@ -5970,7 +5966,7 @@
           <p:cNvPr id="4" name="">
             <a:extLst xmlns:a="http://schemas.openxmlformats.org/drawingml/2006/main">
               <a:ext uri="{FF2B5EF4-FFF2-40B4-BE49-F238E27FC236}">
-                <a16:creationId xmlns:a16="http://schemas.microsoft.com/office/drawing/2014/main" id="{91B9E9F1-0628-4BA7-AE8F-62ED8009D452}"/>
+                <a16:creationId xmlns:a16="http://schemas.microsoft.com/office/drawing/2014/main" id="{F5E9FEC0-0D5C-4E12-A2DD-ED15F7D06CF1}"/>
               </a:ext>
             </a:extLst>
           </p:cNvPr>
@@ -6001,7 +5997,7 @@
           <p:cNvPr id="5" name="">
             <a:extLst xmlns:a="http://schemas.openxmlformats.org/drawingml/2006/main">
               <a:ext uri="{FF2B5EF4-FFF2-40B4-BE49-F238E27FC236}">
-                <a16:creationId xmlns:a16="http://schemas.microsoft.com/office/drawing/2014/main" id="{E712DF2F-47D1-409B-8C0A-566637AB3892}"/>
+                <a16:creationId xmlns:a16="http://schemas.microsoft.com/office/drawing/2014/main" id="{7AFE7852-FD94-4659-B8C8-B3715E6ABA96}"/>
               </a:ext>
             </a:extLst>
           </p:cNvPr>
@@ -6032,7 +6028,7 @@
           <p:cNvPr id="6" name="">
             <a:extLst xmlns:a="http://schemas.openxmlformats.org/drawingml/2006/main">
               <a:ext uri="{FF2B5EF4-FFF2-40B4-BE49-F238E27FC236}">
-                <a16:creationId xmlns:a16="http://schemas.microsoft.com/office/drawing/2014/main" id="{61A7DB0B-B31E-4102-B716-F9BD74005244}"/>
+                <a16:creationId xmlns:a16="http://schemas.microsoft.com/office/drawing/2014/main" id="{79D880F4-9F41-492B-A68D-933AEDC1B37D}"/>
               </a:ext>
             </a:extLst>
           </p:cNvPr>
@@ -6063,7 +6059,7 @@
           <p:cNvPr id="7" name="">
             <a:extLst xmlns:a="http://schemas.openxmlformats.org/drawingml/2006/main">
               <a:ext uri="{FF2B5EF4-FFF2-40B4-BE49-F238E27FC236}">
-                <a16:creationId xmlns:a16="http://schemas.microsoft.com/office/drawing/2014/main" id="{C5BED9D5-2131-410B-B526-1F7A434211F5}"/>
+                <a16:creationId xmlns:a16="http://schemas.microsoft.com/office/drawing/2014/main" id="{125E0BC3-5E8D-4E78-8C04-0F81B56AB98E}"/>
               </a:ext>
             </a:extLst>
           </p:cNvPr>
@@ -6094,7 +6090,7 @@
           <p:cNvPr id="8" name="">
             <a:extLst xmlns:a="http://schemas.openxmlformats.org/drawingml/2006/main">
               <a:ext uri="{FF2B5EF4-FFF2-40B4-BE49-F238E27FC236}">
-                <a16:creationId xmlns:a16="http://schemas.microsoft.com/office/drawing/2014/main" id="{369B0B78-344D-4683-8B5C-005657E57FC1}"/>
+                <a16:creationId xmlns:a16="http://schemas.microsoft.com/office/drawing/2014/main" id="{E4097B0F-B709-4A85-B6C0-845F6B5058E9}"/>
               </a:ext>
             </a:extLst>
           </p:cNvPr>
@@ -6125,7 +6121,7 @@
           <p:cNvPr id="9" name="">
             <a:extLst xmlns:a="http://schemas.openxmlformats.org/drawingml/2006/main">
               <a:ext uri="{FF2B5EF4-FFF2-40B4-BE49-F238E27FC236}">
-                <a16:creationId xmlns:a16="http://schemas.microsoft.com/office/drawing/2014/main" id="{82890601-9AEA-420E-B612-469AE2AA1D82}"/>
+                <a16:creationId xmlns:a16="http://schemas.microsoft.com/office/drawing/2014/main" id="{368A0C3C-D0C3-4574-A2BC-D20D3E331486}"/>
               </a:ext>
             </a:extLst>
           </p:cNvPr>
@@ -6156,7 +6152,7 @@
           <p:cNvPr id="10" name="">
             <a:extLst xmlns:a="http://schemas.openxmlformats.org/drawingml/2006/main">
               <a:ext uri="{FF2B5EF4-FFF2-40B4-BE49-F238E27FC236}">
-                <a16:creationId xmlns:a16="http://schemas.microsoft.com/office/drawing/2014/main" id="{F61996A1-B215-4814-8286-F62E322EEDF8}"/>
+                <a16:creationId xmlns:a16="http://schemas.microsoft.com/office/drawing/2014/main" id="{BF6F82C0-F3B5-49CE-8655-BFF4097B4131}"/>
               </a:ext>
             </a:extLst>
           </p:cNvPr>
@@ -6187,7 +6183,7 @@
           <p:cNvPr id="11" name="">
             <a:extLst xmlns:a="http://schemas.openxmlformats.org/drawingml/2006/main">
               <a:ext uri="{FF2B5EF4-FFF2-40B4-BE49-F238E27FC236}">
-                <a16:creationId xmlns:a16="http://schemas.microsoft.com/office/drawing/2014/main" id="{33832B39-7CBB-4CFF-BA74-E8F840EBAD38}"/>
+                <a16:creationId xmlns:a16="http://schemas.microsoft.com/office/drawing/2014/main" id="{29F1D74F-73C7-4525-8E42-800AB20AAC86}"/>
               </a:ext>
             </a:extLst>
           </p:cNvPr>
@@ -6218,7 +6214,7 @@
           <p:cNvPr id="12" name="">
             <a:extLst xmlns:a="http://schemas.openxmlformats.org/drawingml/2006/main">
               <a:ext uri="{FF2B5EF4-FFF2-40B4-BE49-F238E27FC236}">
-                <a16:creationId xmlns:a16="http://schemas.microsoft.com/office/drawing/2014/main" id="{CD4F9766-0B4E-44C6-87C0-BE1B5A21E16B}"/>
+                <a16:creationId xmlns:a16="http://schemas.microsoft.com/office/drawing/2014/main" id="{9EE5D02D-2CCD-44F7-B252-DF70C5F01D92}"/>
               </a:ext>
             </a:extLst>
           </p:cNvPr>
@@ -6249,7 +6245,7 @@
           <p:cNvPr id="13" name="">
             <a:extLst xmlns:a="http://schemas.openxmlformats.org/drawingml/2006/main">
               <a:ext uri="{FF2B5EF4-FFF2-40B4-BE49-F238E27FC236}">
-                <a16:creationId xmlns:a16="http://schemas.microsoft.com/office/drawing/2014/main" id="{F2728B42-7821-4BB7-B94B-EFF6785B7D01}"/>
+                <a16:creationId xmlns:a16="http://schemas.microsoft.com/office/drawing/2014/main" id="{DBE491C0-2C98-427B-91A1-93EC4FCB6278}"/>
               </a:ext>
             </a:extLst>
           </p:cNvPr>
@@ -6305,7 +6301,7 @@
           <p:cNvPr id="14" name="">
             <a:extLst xmlns:a="http://schemas.openxmlformats.org/drawingml/2006/main">
               <a:ext uri="{FF2B5EF4-FFF2-40B4-BE49-F238E27FC236}">
-                <a16:creationId xmlns:a16="http://schemas.microsoft.com/office/drawing/2014/main" id="{43BA5F7E-3C75-463B-916D-C03226D80D82}"/>
+                <a16:creationId xmlns:a16="http://schemas.microsoft.com/office/drawing/2014/main" id="{E7E53B63-9E16-4EE6-A683-BEA5E7911A2E}"/>
               </a:ext>
             </a:extLst>
           </p:cNvPr>
@@ -6361,7 +6357,7 @@
           <p:cNvPr id="15" name="">
             <a:extLst xmlns:a="http://schemas.openxmlformats.org/drawingml/2006/main">
               <a:ext uri="{FF2B5EF4-FFF2-40B4-BE49-F238E27FC236}">
-                <a16:creationId xmlns:a16="http://schemas.microsoft.com/office/drawing/2014/main" id="{E6B8AC27-406B-44CF-AE13-729107887319}"/>
+                <a16:creationId xmlns:a16="http://schemas.microsoft.com/office/drawing/2014/main" id="{541F3385-4BDA-4FCE-ABF9-32EAC6717BBC}"/>
               </a:ext>
             </a:extLst>
           </p:cNvPr>
@@ -6400,7 +6396,7 @@
           <p:cNvPr id="16" name="">
             <a:extLst xmlns:a="http://schemas.openxmlformats.org/drawingml/2006/main">
               <a:ext uri="{FF2B5EF4-FFF2-40B4-BE49-F238E27FC236}">
-                <a16:creationId xmlns:a16="http://schemas.microsoft.com/office/drawing/2014/main" id="{831F91AE-E8EB-4298-AE11-274DFF0A2301}"/>
+                <a16:creationId xmlns:a16="http://schemas.microsoft.com/office/drawing/2014/main" id="{39AB80CF-C4F4-48DD-8527-DA252E307026}"/>
               </a:ext>
             </a:extLst>
           </p:cNvPr>
@@ -6502,7 +6498,7 @@
           <p:cNvPr id="17" name="">
             <a:extLst xmlns:a="http://schemas.openxmlformats.org/drawingml/2006/main">
               <a:ext uri="{FF2B5EF4-FFF2-40B4-BE49-F238E27FC236}">
-                <a16:creationId xmlns:a16="http://schemas.microsoft.com/office/drawing/2014/main" id="{482639EF-B052-4BA9-B463-9B902841B8A8}"/>
+                <a16:creationId xmlns:a16="http://schemas.microsoft.com/office/drawing/2014/main" id="{AC3A5DE7-BD70-4859-9ABF-E51F8E2EC6DE}"/>
               </a:ext>
             </a:extLst>
           </p:cNvPr>
@@ -6558,7 +6554,7 @@
           <p:cNvPr id="18" name="">
             <a:extLst xmlns:a="http://schemas.openxmlformats.org/drawingml/2006/main">
               <a:ext uri="{FF2B5EF4-FFF2-40B4-BE49-F238E27FC236}">
-                <a16:creationId xmlns:a16="http://schemas.microsoft.com/office/drawing/2014/main" id="{5340232C-E748-47C9-BD75-5F9CCAB9C90C}"/>
+                <a16:creationId xmlns:a16="http://schemas.microsoft.com/office/drawing/2014/main" id="{42C4601D-A3A3-48FE-A3A4-E50FE24635FD}"/>
               </a:ext>
             </a:extLst>
           </p:cNvPr>
@@ -6597,7 +6593,7 @@
           <p:cNvPr id="19" name="">
             <a:extLst xmlns:a="http://schemas.openxmlformats.org/drawingml/2006/main">
               <a:ext uri="{FF2B5EF4-FFF2-40B4-BE49-F238E27FC236}">
-                <a16:creationId xmlns:a16="http://schemas.microsoft.com/office/drawing/2014/main" id="{19C35B2E-E676-47F0-A32B-C72B216B4883}"/>
+                <a16:creationId xmlns:a16="http://schemas.microsoft.com/office/drawing/2014/main" id="{B348E883-9317-45F0-BA15-AA7F1482CCF5}"/>
               </a:ext>
             </a:extLst>
           </p:cNvPr>
@@ -6653,7 +6649,7 @@
           <p:cNvPr id="20" name="">
             <a:extLst xmlns:a="http://schemas.openxmlformats.org/drawingml/2006/main">
               <a:ext uri="{FF2B5EF4-FFF2-40B4-BE49-F238E27FC236}">
-                <a16:creationId xmlns:a16="http://schemas.microsoft.com/office/drawing/2014/main" id="{DF411B4C-AF05-47C2-BFD7-C449BD107B62}"/>
+                <a16:creationId xmlns:a16="http://schemas.microsoft.com/office/drawing/2014/main" id="{C863EA40-975C-4C8F-AF7D-0304E0C93AFF}"/>
               </a:ext>
             </a:extLst>
           </p:cNvPr>
@@ -6707,7 +6703,7 @@
     </p:spTree>
     <p:extLst>
       <p:ext uri="{BB962C8B-B14F-4D97-AF65-F5344CB8AC3E}">
-        <p14:creationId xmlns:p14="http://schemas.microsoft.com/office/powerpoint/2010/main" val="1712841570"/>
+        <p14:creationId xmlns:p14="http://schemas.microsoft.com/office/powerpoint/2010/main" val="975989194"/>
       </p:ext>
     </p:extLst>
   </p:cSld>
@@ -6738,7 +6734,7 @@
           <p:cNvPr id="1" name="">
             <a:extLst xmlns:a="http://schemas.openxmlformats.org/drawingml/2006/main">
               <a:ext uri="{FF2B5EF4-FFF2-40B4-BE49-F238E27FC236}">
-                <a16:creationId xmlns:a16="http://schemas.microsoft.com/office/drawing/2014/main" id="{B082D05B-5AE7-41EF-900B-2954CF2BDE75}"/>
+                <a16:creationId xmlns:a16="http://schemas.microsoft.com/office/drawing/2014/main" id="{2063BB0B-29AB-4B80-82E8-94572CE2BEA9}"/>
               </a:ext>
             </a:extLst>
           </p:cNvPr>
@@ -6769,7 +6765,7 @@
           <p:cNvPr id="2" name="">
             <a:extLst xmlns:a="http://schemas.openxmlformats.org/drawingml/2006/main">
               <a:ext uri="{FF2B5EF4-FFF2-40B4-BE49-F238E27FC236}">
-                <a16:creationId xmlns:a16="http://schemas.microsoft.com/office/drawing/2014/main" id="{0EA3B9C4-C640-4940-8D3E-E013399309F9}"/>
+                <a16:creationId xmlns:a16="http://schemas.microsoft.com/office/drawing/2014/main" id="{22FD3ACB-D1B7-4D39-B060-AC9A783B1391}"/>
               </a:ext>
             </a:extLst>
           </p:cNvPr>
@@ -6800,7 +6796,7 @@
           <p:cNvPr id="3" name="">
             <a:extLst xmlns:a="http://schemas.openxmlformats.org/drawingml/2006/main">
               <a:ext uri="{FF2B5EF4-FFF2-40B4-BE49-F238E27FC236}">
-                <a16:creationId xmlns:a16="http://schemas.microsoft.com/office/drawing/2014/main" id="{6128D982-6BA7-4F8B-BF13-95F90F1B9EC5}"/>
+                <a16:creationId xmlns:a16="http://schemas.microsoft.com/office/drawing/2014/main" id="{BD3E6B17-0D99-41B0-8CC6-A17A6B5A6141}"/>
               </a:ext>
             </a:extLst>
           </p:cNvPr>
@@ -6831,7 +6827,7 @@
           <p:cNvPr id="4" name="">
             <a:extLst xmlns:a="http://schemas.openxmlformats.org/drawingml/2006/main">
               <a:ext uri="{FF2B5EF4-FFF2-40B4-BE49-F238E27FC236}">
-                <a16:creationId xmlns:a16="http://schemas.microsoft.com/office/drawing/2014/main" id="{57D51FD4-6BFE-46DA-8497-E2DF137D7C97}"/>
+                <a16:creationId xmlns:a16="http://schemas.microsoft.com/office/drawing/2014/main" id="{8D615F34-C342-455A-B1B4-868C3A8EEDDD}"/>
               </a:ext>
             </a:extLst>
           </p:cNvPr>
@@ -6862,7 +6858,7 @@
           <p:cNvPr id="5" name="">
             <a:extLst xmlns:a="http://schemas.openxmlformats.org/drawingml/2006/main">
               <a:ext uri="{FF2B5EF4-FFF2-40B4-BE49-F238E27FC236}">
-                <a16:creationId xmlns:a16="http://schemas.microsoft.com/office/drawing/2014/main" id="{3AABF67E-3408-4D35-9DAC-4229D82068F5}"/>
+                <a16:creationId xmlns:a16="http://schemas.microsoft.com/office/drawing/2014/main" id="{4AD2C501-903D-4DEF-B46A-0ED44A74A08B}"/>
               </a:ext>
             </a:extLst>
           </p:cNvPr>
@@ -6893,7 +6889,7 @@
           <p:cNvPr id="6" name="">
             <a:extLst xmlns:a="http://schemas.openxmlformats.org/drawingml/2006/main">
               <a:ext uri="{FF2B5EF4-FFF2-40B4-BE49-F238E27FC236}">
-                <a16:creationId xmlns:a16="http://schemas.microsoft.com/office/drawing/2014/main" id="{9E9E5FCE-3CD4-4E8A-8054-EEBC1393DE48}"/>
+                <a16:creationId xmlns:a16="http://schemas.microsoft.com/office/drawing/2014/main" id="{F1F1199A-0DA6-4A04-BB1F-5E37D4CBF803}"/>
               </a:ext>
             </a:extLst>
           </p:cNvPr>
@@ -6924,7 +6920,7 @@
           <p:cNvPr id="7" name="">
             <a:extLst xmlns:a="http://schemas.openxmlformats.org/drawingml/2006/main">
               <a:ext uri="{FF2B5EF4-FFF2-40B4-BE49-F238E27FC236}">
-                <a16:creationId xmlns:a16="http://schemas.microsoft.com/office/drawing/2014/main" id="{8B1BAAEA-EDA9-4437-8F8F-4484553EB666}"/>
+                <a16:creationId xmlns:a16="http://schemas.microsoft.com/office/drawing/2014/main" id="{B862FC70-9FEC-448F-86D8-F33D63993E63}"/>
               </a:ext>
             </a:extLst>
           </p:cNvPr>
@@ -6955,7 +6951,7 @@
           <p:cNvPr id="8" name="">
             <a:extLst xmlns:a="http://schemas.openxmlformats.org/drawingml/2006/main">
               <a:ext uri="{FF2B5EF4-FFF2-40B4-BE49-F238E27FC236}">
-                <a16:creationId xmlns:a16="http://schemas.microsoft.com/office/drawing/2014/main" id="{7984D91C-D6F7-4AFE-BE70-A2D6EDDFA79F}"/>
+                <a16:creationId xmlns:a16="http://schemas.microsoft.com/office/drawing/2014/main" id="{EBDC157B-0ADE-4559-B228-2E8968CE1579}"/>
               </a:ext>
             </a:extLst>
           </p:cNvPr>
@@ -6986,7 +6982,7 @@
           <p:cNvPr id="9" name="">
             <a:extLst xmlns:a="http://schemas.openxmlformats.org/drawingml/2006/main">
               <a:ext uri="{FF2B5EF4-FFF2-40B4-BE49-F238E27FC236}">
-                <a16:creationId xmlns:a16="http://schemas.microsoft.com/office/drawing/2014/main" id="{508A5A0F-35AE-4EC3-BD7A-9E9106AB8477}"/>
+                <a16:creationId xmlns:a16="http://schemas.microsoft.com/office/drawing/2014/main" id="{208A0AF9-50E7-43E3-BF0D-CD3E390E06B5}"/>
               </a:ext>
             </a:extLst>
           </p:cNvPr>
@@ -7017,7 +7013,7 @@
           <p:cNvPr id="10" name="">
             <a:extLst xmlns:a="http://schemas.openxmlformats.org/drawingml/2006/main">
               <a:ext uri="{FF2B5EF4-FFF2-40B4-BE49-F238E27FC236}">
-                <a16:creationId xmlns:a16="http://schemas.microsoft.com/office/drawing/2014/main" id="{8EC55332-9307-4214-AD7C-B6176F8C1B5A}"/>
+                <a16:creationId xmlns:a16="http://schemas.microsoft.com/office/drawing/2014/main" id="{94F93439-1B6F-4D11-B63C-0E7108580D03}"/>
               </a:ext>
             </a:extLst>
           </p:cNvPr>
@@ -7048,7 +7044,7 @@
           <p:cNvPr id="11" name="">
             <a:extLst xmlns:a="http://schemas.openxmlformats.org/drawingml/2006/main">
               <a:ext uri="{FF2B5EF4-FFF2-40B4-BE49-F238E27FC236}">
-                <a16:creationId xmlns:a16="http://schemas.microsoft.com/office/drawing/2014/main" id="{D519CBB0-83CF-4FF6-92D4-12E4CE68FCF3}"/>
+                <a16:creationId xmlns:a16="http://schemas.microsoft.com/office/drawing/2014/main" id="{F928214A-B1DD-4CB1-ADED-69AE7CADD61A}"/>
               </a:ext>
             </a:extLst>
           </p:cNvPr>
@@ -7079,7 +7075,7 @@
           <p:cNvPr id="12" name="">
             <a:extLst xmlns:a="http://schemas.openxmlformats.org/drawingml/2006/main">
               <a:ext uri="{FF2B5EF4-FFF2-40B4-BE49-F238E27FC236}">
-                <a16:creationId xmlns:a16="http://schemas.microsoft.com/office/drawing/2014/main" id="{68EA410F-2159-4507-80C8-C4596AEFD559}"/>
+                <a16:creationId xmlns:a16="http://schemas.microsoft.com/office/drawing/2014/main" id="{2D1CF6D1-CBDF-4B17-B6B5-0F882D91047D}"/>
               </a:ext>
             </a:extLst>
           </p:cNvPr>
@@ -7110,7 +7106,7 @@
           <p:cNvPr id="13" name="">
             <a:extLst xmlns:a="http://schemas.openxmlformats.org/drawingml/2006/main">
               <a:ext uri="{FF2B5EF4-FFF2-40B4-BE49-F238E27FC236}">
-                <a16:creationId xmlns:a16="http://schemas.microsoft.com/office/drawing/2014/main" id="{8EB02042-1C1E-4A19-BD57-23F90281D115}"/>
+                <a16:creationId xmlns:a16="http://schemas.microsoft.com/office/drawing/2014/main" id="{4BC6F796-8368-4938-A9C5-9F13F7BC3A8D}"/>
               </a:ext>
             </a:extLst>
           </p:cNvPr>
@@ -7166,7 +7162,7 @@
           <p:cNvPr id="14" name="">
             <a:extLst xmlns:a="http://schemas.openxmlformats.org/drawingml/2006/main">
               <a:ext uri="{FF2B5EF4-FFF2-40B4-BE49-F238E27FC236}">
-                <a16:creationId xmlns:a16="http://schemas.microsoft.com/office/drawing/2014/main" id="{CA5CDEF9-4B48-4C24-94FD-4E16C476B736}"/>
+                <a16:creationId xmlns:a16="http://schemas.microsoft.com/office/drawing/2014/main" id="{AA92EB2B-32E8-4E98-B556-18CB5749DEAD}"/>
               </a:ext>
             </a:extLst>
           </p:cNvPr>
@@ -7205,7 +7201,7 @@
           <p:cNvPr id="15" name="">
             <a:extLst xmlns:a="http://schemas.openxmlformats.org/drawingml/2006/main">
               <a:ext uri="{FF2B5EF4-FFF2-40B4-BE49-F238E27FC236}">
-                <a16:creationId xmlns:a16="http://schemas.microsoft.com/office/drawing/2014/main" id="{51BBAA29-7C40-433B-9A1A-85C131C03822}"/>
+                <a16:creationId xmlns:a16="http://schemas.microsoft.com/office/drawing/2014/main" id="{E07AD922-656E-4A00-BF3F-9144CA6763CF}"/>
               </a:ext>
             </a:extLst>
           </p:cNvPr>
@@ -7236,7 +7232,7 @@
           <p:cNvPr id="16" name="">
             <a:extLst xmlns:a="http://schemas.openxmlformats.org/drawingml/2006/main">
               <a:ext uri="{FF2B5EF4-FFF2-40B4-BE49-F238E27FC236}">
-                <a16:creationId xmlns:a16="http://schemas.microsoft.com/office/drawing/2014/main" id="{2E9ECAB1-86CF-4061-BD86-928F340DEEEF}"/>
+                <a16:creationId xmlns:a16="http://schemas.microsoft.com/office/drawing/2014/main" id="{A0188406-9CBB-4606-B23B-E2690DC63D8B}"/>
               </a:ext>
             </a:extLst>
           </p:cNvPr>
@@ -7292,7 +7288,7 @@
           <p:cNvPr id="17" name="">
             <a:extLst xmlns:a="http://schemas.openxmlformats.org/drawingml/2006/main">
               <a:ext uri="{FF2B5EF4-FFF2-40B4-BE49-F238E27FC236}">
-                <a16:creationId xmlns:a16="http://schemas.microsoft.com/office/drawing/2014/main" id="{F15689F1-70CC-4585-A3AF-65A54962B14D}"/>
+                <a16:creationId xmlns:a16="http://schemas.microsoft.com/office/drawing/2014/main" id="{F2FA0478-2959-4D18-889B-BA7B034680BA}"/>
               </a:ext>
             </a:extLst>
           </p:cNvPr>
@@ -7348,7 +7344,7 @@
           <p:cNvPr id="18" name="">
             <a:extLst xmlns:a="http://schemas.openxmlformats.org/drawingml/2006/main">
               <a:ext uri="{FF2B5EF4-FFF2-40B4-BE49-F238E27FC236}">
-                <a16:creationId xmlns:a16="http://schemas.microsoft.com/office/drawing/2014/main" id="{5192C68B-F2C8-4FFA-B416-202A316879BA}"/>
+                <a16:creationId xmlns:a16="http://schemas.microsoft.com/office/drawing/2014/main" id="{171AE70A-00CD-4251-ABB1-9D7BDB0470F9}"/>
               </a:ext>
             </a:extLst>
           </p:cNvPr>
@@ -7404,7 +7400,7 @@
           <p:cNvPr id="19" name="">
             <a:extLst xmlns:a="http://schemas.openxmlformats.org/drawingml/2006/main">
               <a:ext uri="{FF2B5EF4-FFF2-40B4-BE49-F238E27FC236}">
-                <a16:creationId xmlns:a16="http://schemas.microsoft.com/office/drawing/2014/main" id="{3C1F66CC-727F-4271-9AEB-19148B708FEC}"/>
+                <a16:creationId xmlns:a16="http://schemas.microsoft.com/office/drawing/2014/main" id="{155D21EA-EC9F-4106-8E14-AAA6E79053B2}"/>
               </a:ext>
             </a:extLst>
           </p:cNvPr>
@@ -7443,7 +7439,7 @@
           <p:cNvPr id="20" name="">
             <a:extLst xmlns:a="http://schemas.openxmlformats.org/drawingml/2006/main">
               <a:ext uri="{FF2B5EF4-FFF2-40B4-BE49-F238E27FC236}">
-                <a16:creationId xmlns:a16="http://schemas.microsoft.com/office/drawing/2014/main" id="{BBDAC30A-79B2-408E-B7D4-16F8B1031F60}"/>
+                <a16:creationId xmlns:a16="http://schemas.microsoft.com/office/drawing/2014/main" id="{780A0E47-A298-4CDB-B089-08199EF20924}"/>
               </a:ext>
             </a:extLst>
           </p:cNvPr>
@@ -7474,7 +7470,7 @@
           <p:cNvPr id="21" name="">
             <a:extLst xmlns:a="http://schemas.openxmlformats.org/drawingml/2006/main">
               <a:ext uri="{FF2B5EF4-FFF2-40B4-BE49-F238E27FC236}">
-                <a16:creationId xmlns:a16="http://schemas.microsoft.com/office/drawing/2014/main" id="{BAA49EF9-900A-4617-BF8D-45F8874C801A}"/>
+                <a16:creationId xmlns:a16="http://schemas.microsoft.com/office/drawing/2014/main" id="{072560CF-92B5-497C-8B8F-A7E5E77D85B7}"/>
               </a:ext>
             </a:extLst>
           </p:cNvPr>
@@ -7530,7 +7526,7 @@
           <p:cNvPr id="22" name="">
             <a:extLst xmlns:a="http://schemas.openxmlformats.org/drawingml/2006/main">
               <a:ext uri="{FF2B5EF4-FFF2-40B4-BE49-F238E27FC236}">
-                <a16:creationId xmlns:a16="http://schemas.microsoft.com/office/drawing/2014/main" id="{08B74462-16BC-47EF-8D01-DAA5AC75E160}"/>
+                <a16:creationId xmlns:a16="http://schemas.microsoft.com/office/drawing/2014/main" id="{1A07B93A-0C1B-475C-9474-1F07C8EDE4B6}"/>
               </a:ext>
             </a:extLst>
           </p:cNvPr>
@@ -7586,7 +7582,7 @@
           <p:cNvPr id="23" name="">
             <a:extLst xmlns:a="http://schemas.openxmlformats.org/drawingml/2006/main">
               <a:ext uri="{FF2B5EF4-FFF2-40B4-BE49-F238E27FC236}">
-                <a16:creationId xmlns:a16="http://schemas.microsoft.com/office/drawing/2014/main" id="{3E58667F-EBC4-4EF7-A603-0B149BFE3CC9}"/>
+                <a16:creationId xmlns:a16="http://schemas.microsoft.com/office/drawing/2014/main" id="{E23C7737-74CF-48A3-86A7-811CA148A0AB}"/>
               </a:ext>
             </a:extLst>
           </p:cNvPr>
@@ -7642,7 +7638,7 @@
           <p:cNvPr id="24" name="">
             <a:extLst xmlns:a="http://schemas.openxmlformats.org/drawingml/2006/main">
               <a:ext uri="{FF2B5EF4-FFF2-40B4-BE49-F238E27FC236}">
-                <a16:creationId xmlns:a16="http://schemas.microsoft.com/office/drawing/2014/main" id="{2C978A64-FE0F-4C4E-91CD-4BE9CE3508BC}"/>
+                <a16:creationId xmlns:a16="http://schemas.microsoft.com/office/drawing/2014/main" id="{0E7BE51C-A494-486A-B236-FCC27791DAA9}"/>
               </a:ext>
             </a:extLst>
           </p:cNvPr>
@@ -7681,7 +7677,7 @@
           <p:cNvPr id="25" name="">
             <a:extLst xmlns:a="http://schemas.openxmlformats.org/drawingml/2006/main">
               <a:ext uri="{FF2B5EF4-FFF2-40B4-BE49-F238E27FC236}">
-                <a16:creationId xmlns:a16="http://schemas.microsoft.com/office/drawing/2014/main" id="{3B49E314-5EC8-476A-AC39-CCB185127989}"/>
+                <a16:creationId xmlns:a16="http://schemas.microsoft.com/office/drawing/2014/main" id="{62279977-F020-4FCB-B31D-1AC0C4211956}"/>
               </a:ext>
             </a:extLst>
           </p:cNvPr>
@@ -7741,7 +7737,7 @@
           <p:nvPr/>
         </p:nvPicPr>
         <p:blipFill>
-          <a:blip xmlns:r="http://schemas.openxmlformats.org/officeDocument/2006/relationships" xmlns:a="http://schemas.openxmlformats.org/drawingml/2006/main" r:embed="R9b2521224e084aae"/>
+          <a:blip xmlns:r="http://schemas.openxmlformats.org/officeDocument/2006/relationships" xmlns:a="http://schemas.openxmlformats.org/drawingml/2006/main" r:embed="R65b2d6b5a3644098"/>
           <a:stretch xmlns:a="http://schemas.openxmlformats.org/drawingml/2006/main"/>
         </p:blipFill>
         <p:spPr>
@@ -7759,7 +7755,7 @@
           <p:cNvPr id="27" name="">
             <a:extLst xmlns:a="http://schemas.openxmlformats.org/drawingml/2006/main">
               <a:ext uri="{FF2B5EF4-FFF2-40B4-BE49-F238E27FC236}">
-                <a16:creationId xmlns:a16="http://schemas.microsoft.com/office/drawing/2014/main" id="{1CBC3323-0278-45E7-8B4E-0FA294C21A72}"/>
+                <a16:creationId xmlns:a16="http://schemas.microsoft.com/office/drawing/2014/main" id="{84C7547D-B2A1-4798-9BBE-0D9AB8CC28E9}"/>
               </a:ext>
             </a:extLst>
           </p:cNvPr>
@@ -7813,7 +7809,7 @@
     </p:spTree>
     <p:extLst>
       <p:ext uri="{BB962C8B-B14F-4D97-AF65-F5344CB8AC3E}">
-        <p14:creationId xmlns:p14="http://schemas.microsoft.com/office/powerpoint/2010/main" val="1469974068"/>
+        <p14:creationId xmlns:p14="http://schemas.microsoft.com/office/powerpoint/2010/main" val="1196028902"/>
       </p:ext>
     </p:extLst>
   </p:cSld>
@@ -7844,7 +7840,7 @@
           <p:cNvPr id="1" name="">
             <a:extLst xmlns:a="http://schemas.openxmlformats.org/drawingml/2006/main">
               <a:ext uri="{FF2B5EF4-FFF2-40B4-BE49-F238E27FC236}">
-                <a16:creationId xmlns:a16="http://schemas.microsoft.com/office/drawing/2014/main" id="{8E77D52E-4A79-43A9-A3B3-73ED5227EDB1}"/>
+                <a16:creationId xmlns:a16="http://schemas.microsoft.com/office/drawing/2014/main" id="{04260B7D-104C-4628-AE13-139E309073CA}"/>
               </a:ext>
             </a:extLst>
           </p:cNvPr>
@@ -7875,7 +7871,7 @@
           <p:cNvPr id="2" name="">
             <a:extLst xmlns:a="http://schemas.openxmlformats.org/drawingml/2006/main">
               <a:ext uri="{FF2B5EF4-FFF2-40B4-BE49-F238E27FC236}">
-                <a16:creationId xmlns:a16="http://schemas.microsoft.com/office/drawing/2014/main" id="{367FDCFA-2F56-4C26-A158-A0CA2F8F4A55}"/>
+                <a16:creationId xmlns:a16="http://schemas.microsoft.com/office/drawing/2014/main" id="{8AEA82CE-8A8B-4962-935E-8DA0C6020CE7}"/>
               </a:ext>
             </a:extLst>
           </p:cNvPr>
@@ -7906,7 +7902,7 @@
           <p:cNvPr id="3" name="">
             <a:extLst xmlns:a="http://schemas.openxmlformats.org/drawingml/2006/main">
               <a:ext uri="{FF2B5EF4-FFF2-40B4-BE49-F238E27FC236}">
-                <a16:creationId xmlns:a16="http://schemas.microsoft.com/office/drawing/2014/main" id="{3EA3C6A1-F7DA-4FCC-80FA-6F55AB0CF926}"/>
+                <a16:creationId xmlns:a16="http://schemas.microsoft.com/office/drawing/2014/main" id="{B8C456E8-5ACA-4EBF-BCBD-7241E2675A97}"/>
               </a:ext>
             </a:extLst>
           </p:cNvPr>
@@ -7937,7 +7933,7 @@
           <p:cNvPr id="4" name="">
             <a:extLst xmlns:a="http://schemas.openxmlformats.org/drawingml/2006/main">
               <a:ext uri="{FF2B5EF4-FFF2-40B4-BE49-F238E27FC236}">
-                <a16:creationId xmlns:a16="http://schemas.microsoft.com/office/drawing/2014/main" id="{B0FB6311-9E7F-47B2-9D70-ED76E92D1E06}"/>
+                <a16:creationId xmlns:a16="http://schemas.microsoft.com/office/drawing/2014/main" id="{4EED175C-BC95-4121-80B2-D695C2E59184}"/>
               </a:ext>
             </a:extLst>
           </p:cNvPr>
@@ -7968,7 +7964,7 @@
           <p:cNvPr id="5" name="">
             <a:extLst xmlns:a="http://schemas.openxmlformats.org/drawingml/2006/main">
               <a:ext uri="{FF2B5EF4-FFF2-40B4-BE49-F238E27FC236}">
-                <a16:creationId xmlns:a16="http://schemas.microsoft.com/office/drawing/2014/main" id="{CBD1B97C-0FC5-4E6E-945C-73C55BB2E570}"/>
+                <a16:creationId xmlns:a16="http://schemas.microsoft.com/office/drawing/2014/main" id="{4F2F76EA-14F5-479B-B733-27AAD77DF398}"/>
               </a:ext>
             </a:extLst>
           </p:cNvPr>
@@ -7999,7 +7995,7 @@
           <p:cNvPr id="6" name="">
             <a:extLst xmlns:a="http://schemas.openxmlformats.org/drawingml/2006/main">
               <a:ext uri="{FF2B5EF4-FFF2-40B4-BE49-F238E27FC236}">
-                <a16:creationId xmlns:a16="http://schemas.microsoft.com/office/drawing/2014/main" id="{2A230B09-DBFB-4C50-AED1-7E97F1D14B81}"/>
+                <a16:creationId xmlns:a16="http://schemas.microsoft.com/office/drawing/2014/main" id="{895EA6D9-1F48-4FA3-B3AA-F446332F57F7}"/>
               </a:ext>
             </a:extLst>
           </p:cNvPr>
@@ -8030,7 +8026,7 @@
           <p:cNvPr id="7" name="">
             <a:extLst xmlns:a="http://schemas.openxmlformats.org/drawingml/2006/main">
               <a:ext uri="{FF2B5EF4-FFF2-40B4-BE49-F238E27FC236}">
-                <a16:creationId xmlns:a16="http://schemas.microsoft.com/office/drawing/2014/main" id="{8FF28629-7CE8-44C1-BD04-62AFE679DFC4}"/>
+                <a16:creationId xmlns:a16="http://schemas.microsoft.com/office/drawing/2014/main" id="{C27D8921-C298-48ED-8447-D11B9461C03C}"/>
               </a:ext>
             </a:extLst>
           </p:cNvPr>
@@ -8061,7 +8057,7 @@
           <p:cNvPr id="8" name="">
             <a:extLst xmlns:a="http://schemas.openxmlformats.org/drawingml/2006/main">
               <a:ext uri="{FF2B5EF4-FFF2-40B4-BE49-F238E27FC236}">
-                <a16:creationId xmlns:a16="http://schemas.microsoft.com/office/drawing/2014/main" id="{6AF7745E-E786-47C0-B741-515BBA396C1D}"/>
+                <a16:creationId xmlns:a16="http://schemas.microsoft.com/office/drawing/2014/main" id="{48983BFA-1DE9-4E3C-9C17-C1A1298AC856}"/>
               </a:ext>
             </a:extLst>
           </p:cNvPr>
@@ -8092,7 +8088,7 @@
           <p:cNvPr id="9" name="">
             <a:extLst xmlns:a="http://schemas.openxmlformats.org/drawingml/2006/main">
               <a:ext uri="{FF2B5EF4-FFF2-40B4-BE49-F238E27FC236}">
-                <a16:creationId xmlns:a16="http://schemas.microsoft.com/office/drawing/2014/main" id="{0FE59EFF-D573-442D-A188-A531A3586A35}"/>
+                <a16:creationId xmlns:a16="http://schemas.microsoft.com/office/drawing/2014/main" id="{E4CDADFB-5FE7-4383-94B7-92CE0A975DB9}"/>
               </a:ext>
             </a:extLst>
           </p:cNvPr>
@@ -8123,7 +8119,7 @@
           <p:cNvPr id="10" name="">
             <a:extLst xmlns:a="http://schemas.openxmlformats.org/drawingml/2006/main">
               <a:ext uri="{FF2B5EF4-FFF2-40B4-BE49-F238E27FC236}">
-                <a16:creationId xmlns:a16="http://schemas.microsoft.com/office/drawing/2014/main" id="{BF31CFB0-B101-4D70-AB0E-34255D58D0BF}"/>
+                <a16:creationId xmlns:a16="http://schemas.microsoft.com/office/drawing/2014/main" id="{2DF0F764-F673-4036-B2A2-F0407825C16B}"/>
               </a:ext>
             </a:extLst>
           </p:cNvPr>
@@ -8154,7 +8150,7 @@
           <p:cNvPr id="11" name="">
             <a:extLst xmlns:a="http://schemas.openxmlformats.org/drawingml/2006/main">
               <a:ext uri="{FF2B5EF4-FFF2-40B4-BE49-F238E27FC236}">
-                <a16:creationId xmlns:a16="http://schemas.microsoft.com/office/drawing/2014/main" id="{B70BB8F8-885C-4E40-8D23-1A0F007EDD4E}"/>
+                <a16:creationId xmlns:a16="http://schemas.microsoft.com/office/drawing/2014/main" id="{DD046DED-2530-404E-9BB6-999D793DB112}"/>
               </a:ext>
             </a:extLst>
           </p:cNvPr>
@@ -8185,7 +8181,7 @@
           <p:cNvPr id="12" name="">
             <a:extLst xmlns:a="http://schemas.openxmlformats.org/drawingml/2006/main">
               <a:ext uri="{FF2B5EF4-FFF2-40B4-BE49-F238E27FC236}">
-                <a16:creationId xmlns:a16="http://schemas.microsoft.com/office/drawing/2014/main" id="{29F8CAA7-F18C-4414-BE4F-C65009E66EF1}"/>
+                <a16:creationId xmlns:a16="http://schemas.microsoft.com/office/drawing/2014/main" id="{A10D5A0B-2FDA-4BBC-A4FC-9D07BB3B41AB}"/>
               </a:ext>
             </a:extLst>
           </p:cNvPr>
@@ -8216,7 +8212,7 @@
           <p:cNvPr id="13" name="">
             <a:extLst xmlns:a="http://schemas.openxmlformats.org/drawingml/2006/main">
               <a:ext uri="{FF2B5EF4-FFF2-40B4-BE49-F238E27FC236}">
-                <a16:creationId xmlns:a16="http://schemas.microsoft.com/office/drawing/2014/main" id="{6D0C2F18-926A-497A-AF40-077C85818FB0}"/>
+                <a16:creationId xmlns:a16="http://schemas.microsoft.com/office/drawing/2014/main" id="{105CAEA7-4637-44D7-A1F6-DB30B7286158}"/>
               </a:ext>
             </a:extLst>
           </p:cNvPr>
@@ -8272,7 +8268,7 @@
           <p:cNvPr id="14" name="">
             <a:extLst xmlns:a="http://schemas.openxmlformats.org/drawingml/2006/main">
               <a:ext uri="{FF2B5EF4-FFF2-40B4-BE49-F238E27FC236}">
-                <a16:creationId xmlns:a16="http://schemas.microsoft.com/office/drawing/2014/main" id="{8C44AAEC-E3BA-4929-8076-DCAF8C39968B}"/>
+                <a16:creationId xmlns:a16="http://schemas.microsoft.com/office/drawing/2014/main" id="{EE727AC1-DFE5-4F5C-A0E8-D16E34A8659A}"/>
               </a:ext>
             </a:extLst>
           </p:cNvPr>
@@ -8311,7 +8307,7 @@
           <p:cNvPr id="15" name="">
             <a:extLst xmlns:a="http://schemas.openxmlformats.org/drawingml/2006/main">
               <a:ext uri="{FF2B5EF4-FFF2-40B4-BE49-F238E27FC236}">
-                <a16:creationId xmlns:a16="http://schemas.microsoft.com/office/drawing/2014/main" id="{976EBBE4-9C38-4DA6-8BD3-8FFE4981A78E}"/>
+                <a16:creationId xmlns:a16="http://schemas.microsoft.com/office/drawing/2014/main" id="{3960B902-2E5F-48F8-961F-3FC3F4F24AD3}"/>
               </a:ext>
             </a:extLst>
           </p:cNvPr>
@@ -8367,7 +8363,7 @@
           <p:cNvPr id="16" name="">
             <a:extLst xmlns:a="http://schemas.openxmlformats.org/drawingml/2006/main">
               <a:ext uri="{FF2B5EF4-FFF2-40B4-BE49-F238E27FC236}">
-                <a16:creationId xmlns:a16="http://schemas.microsoft.com/office/drawing/2014/main" id="{E90E8362-2120-407D-8CF3-BDAF8AEF79C4}"/>
+                <a16:creationId xmlns:a16="http://schemas.microsoft.com/office/drawing/2014/main" id="{EB51802A-22A7-466D-BC55-6852E0351405}"/>
               </a:ext>
             </a:extLst>
           </p:cNvPr>
@@ -8423,7 +8419,7 @@
           <p:cNvPr id="17" name="">
             <a:extLst xmlns:a="http://schemas.openxmlformats.org/drawingml/2006/main">
               <a:ext uri="{FF2B5EF4-FFF2-40B4-BE49-F238E27FC236}">
-                <a16:creationId xmlns:a16="http://schemas.microsoft.com/office/drawing/2014/main" id="{5F41DD9C-D591-437E-901B-93A3BCBB71C2}"/>
+                <a16:creationId xmlns:a16="http://schemas.microsoft.com/office/drawing/2014/main" id="{644F5D2A-C77D-4B94-B817-16E37FC34244}"/>
               </a:ext>
             </a:extLst>
           </p:cNvPr>
@@ -8462,7 +8458,7 @@
           <p:cNvPr id="18" name="">
             <a:extLst xmlns:a="http://schemas.openxmlformats.org/drawingml/2006/main">
               <a:ext uri="{FF2B5EF4-FFF2-40B4-BE49-F238E27FC236}">
-                <a16:creationId xmlns:a16="http://schemas.microsoft.com/office/drawing/2014/main" id="{F5857FA8-D9F3-429D-8E41-43066AA433A4}"/>
+                <a16:creationId xmlns:a16="http://schemas.microsoft.com/office/drawing/2014/main" id="{66174FA0-DD81-44B4-BC2F-B4A1C6C6BC1F}"/>
               </a:ext>
             </a:extLst>
           </p:cNvPr>
@@ -8522,7 +8518,7 @@
           <p:nvPr/>
         </p:nvPicPr>
         <p:blipFill>
-          <a:blip xmlns:r="http://schemas.openxmlformats.org/officeDocument/2006/relationships" xmlns:a="http://schemas.openxmlformats.org/drawingml/2006/main" r:embed="Rd0bc53c56c78451a"/>
+          <a:blip xmlns:r="http://schemas.openxmlformats.org/officeDocument/2006/relationships" xmlns:a="http://schemas.openxmlformats.org/drawingml/2006/main" r:embed="R90f0c4c86f9b49dd"/>
           <a:stretch xmlns:a="http://schemas.openxmlformats.org/drawingml/2006/main"/>
         </p:blipFill>
         <p:spPr>
@@ -8540,7 +8536,7 @@
           <p:cNvPr id="20" name="">
             <a:extLst xmlns:a="http://schemas.openxmlformats.org/drawingml/2006/main">
               <a:ext uri="{FF2B5EF4-FFF2-40B4-BE49-F238E27FC236}">
-                <a16:creationId xmlns:a16="http://schemas.microsoft.com/office/drawing/2014/main" id="{42C2CA26-FC4E-425D-8DFE-11FCDCFABA21}"/>
+                <a16:creationId xmlns:a16="http://schemas.microsoft.com/office/drawing/2014/main" id="{AD53864D-49D0-4FFE-847C-54FDB0128640}"/>
               </a:ext>
             </a:extLst>
           </p:cNvPr>
@@ -8594,7 +8590,7 @@
     </p:spTree>
     <p:extLst>
       <p:ext uri="{BB962C8B-B14F-4D97-AF65-F5344CB8AC3E}">
-        <p14:creationId xmlns:p14="http://schemas.microsoft.com/office/powerpoint/2010/main" val="1676631460"/>
+        <p14:creationId xmlns:p14="http://schemas.microsoft.com/office/powerpoint/2010/main" val="1546660929"/>
       </p:ext>
     </p:extLst>
   </p:cSld>
@@ -8625,7 +8621,7 @@
           <p:cNvPr id="1" name="">
             <a:extLst xmlns:a="http://schemas.openxmlformats.org/drawingml/2006/main">
               <a:ext uri="{FF2B5EF4-FFF2-40B4-BE49-F238E27FC236}">
-                <a16:creationId xmlns:a16="http://schemas.microsoft.com/office/drawing/2014/main" id="{29C18D88-92BD-44FA-9CA8-E7D1038012E1}"/>
+                <a16:creationId xmlns:a16="http://schemas.microsoft.com/office/drawing/2014/main" id="{E280CC31-B9C0-46CD-A4B9-EDFBB0AE18E5}"/>
               </a:ext>
             </a:extLst>
           </p:cNvPr>
@@ -8656,7 +8652,7 @@
           <p:cNvPr id="2" name="">
             <a:extLst xmlns:a="http://schemas.openxmlformats.org/drawingml/2006/main">
               <a:ext uri="{FF2B5EF4-FFF2-40B4-BE49-F238E27FC236}">
-                <a16:creationId xmlns:a16="http://schemas.microsoft.com/office/drawing/2014/main" id="{9343804D-6CBE-44B4-9B92-C238D09C0587}"/>
+                <a16:creationId xmlns:a16="http://schemas.microsoft.com/office/drawing/2014/main" id="{89B193CA-5AFD-484A-8CCD-ACE3BF3EB832}"/>
               </a:ext>
             </a:extLst>
           </p:cNvPr>
@@ -8687,7 +8683,7 @@
           <p:cNvPr id="3" name="">
             <a:extLst xmlns:a="http://schemas.openxmlformats.org/drawingml/2006/main">
               <a:ext uri="{FF2B5EF4-FFF2-40B4-BE49-F238E27FC236}">
-                <a16:creationId xmlns:a16="http://schemas.microsoft.com/office/drawing/2014/main" id="{7EBE8915-A532-45F5-80A5-A0878A72F590}"/>
+                <a16:creationId xmlns:a16="http://schemas.microsoft.com/office/drawing/2014/main" id="{C8B1F12A-2387-4416-8BCC-E29A7BE08697}"/>
               </a:ext>
             </a:extLst>
           </p:cNvPr>
@@ -8718,7 +8714,7 @@
           <p:cNvPr id="4" name="">
             <a:extLst xmlns:a="http://schemas.openxmlformats.org/drawingml/2006/main">
               <a:ext uri="{FF2B5EF4-FFF2-40B4-BE49-F238E27FC236}">
-                <a16:creationId xmlns:a16="http://schemas.microsoft.com/office/drawing/2014/main" id="{C3981B1F-FD54-4948-852E-14EA727FFCFC}"/>
+                <a16:creationId xmlns:a16="http://schemas.microsoft.com/office/drawing/2014/main" id="{FD73F348-CA8F-4BF2-A9F1-4CA0850DA127}"/>
               </a:ext>
             </a:extLst>
           </p:cNvPr>
@@ -8749,7 +8745,7 @@
           <p:cNvPr id="5" name="">
             <a:extLst xmlns:a="http://schemas.openxmlformats.org/drawingml/2006/main">
               <a:ext uri="{FF2B5EF4-FFF2-40B4-BE49-F238E27FC236}">
-                <a16:creationId xmlns:a16="http://schemas.microsoft.com/office/drawing/2014/main" id="{E2E84D28-09CC-4314-A5DA-B9E9578B35CF}"/>
+                <a16:creationId xmlns:a16="http://schemas.microsoft.com/office/drawing/2014/main" id="{45495794-4B52-4DFD-AEA7-61238CF6ADAA}"/>
               </a:ext>
             </a:extLst>
           </p:cNvPr>
@@ -8780,7 +8776,7 @@
           <p:cNvPr id="6" name="">
             <a:extLst xmlns:a="http://schemas.openxmlformats.org/drawingml/2006/main">
               <a:ext uri="{FF2B5EF4-FFF2-40B4-BE49-F238E27FC236}">
-                <a16:creationId xmlns:a16="http://schemas.microsoft.com/office/drawing/2014/main" id="{2EB15CD8-62AE-48DB-B336-E4542C11E0EB}"/>
+                <a16:creationId xmlns:a16="http://schemas.microsoft.com/office/drawing/2014/main" id="{C4119F4B-A93E-4F76-B4C1-1F1EEE7867EE}"/>
               </a:ext>
             </a:extLst>
           </p:cNvPr>
@@ -8811,7 +8807,7 @@
           <p:cNvPr id="7" name="">
             <a:extLst xmlns:a="http://schemas.openxmlformats.org/drawingml/2006/main">
               <a:ext uri="{FF2B5EF4-FFF2-40B4-BE49-F238E27FC236}">
-                <a16:creationId xmlns:a16="http://schemas.microsoft.com/office/drawing/2014/main" id="{21F21390-FB7D-44D5-A7F0-A1370410D8DA}"/>
+                <a16:creationId xmlns:a16="http://schemas.microsoft.com/office/drawing/2014/main" id="{0DE7B9EA-3A81-45D1-8317-07D3CE773BAC}"/>
               </a:ext>
             </a:extLst>
           </p:cNvPr>
@@ -8842,7 +8838,7 @@
           <p:cNvPr id="8" name="">
             <a:extLst xmlns:a="http://schemas.openxmlformats.org/drawingml/2006/main">
               <a:ext uri="{FF2B5EF4-FFF2-40B4-BE49-F238E27FC236}">
-                <a16:creationId xmlns:a16="http://schemas.microsoft.com/office/drawing/2014/main" id="{00F753C3-4AAB-44EB-90B7-041C320E0FCE}"/>
+                <a16:creationId xmlns:a16="http://schemas.microsoft.com/office/drawing/2014/main" id="{BEA286B9-9028-4BBF-9A33-DB64ABB47B2C}"/>
               </a:ext>
             </a:extLst>
           </p:cNvPr>
@@ -8873,7 +8869,7 @@
           <p:cNvPr id="9" name="">
             <a:extLst xmlns:a="http://schemas.openxmlformats.org/drawingml/2006/main">
               <a:ext uri="{FF2B5EF4-FFF2-40B4-BE49-F238E27FC236}">
-                <a16:creationId xmlns:a16="http://schemas.microsoft.com/office/drawing/2014/main" id="{EFC8E32B-6AE5-4887-9190-7FC20992A1F3}"/>
+                <a16:creationId xmlns:a16="http://schemas.microsoft.com/office/drawing/2014/main" id="{8376D179-4A93-4620-857D-7279EEEAED49}"/>
               </a:ext>
             </a:extLst>
           </p:cNvPr>
@@ -8904,7 +8900,7 @@
           <p:cNvPr id="10" name="">
             <a:extLst xmlns:a="http://schemas.openxmlformats.org/drawingml/2006/main">
               <a:ext uri="{FF2B5EF4-FFF2-40B4-BE49-F238E27FC236}">
-                <a16:creationId xmlns:a16="http://schemas.microsoft.com/office/drawing/2014/main" id="{6FE03975-5877-48E3-BDD7-B98AC572B957}"/>
+                <a16:creationId xmlns:a16="http://schemas.microsoft.com/office/drawing/2014/main" id="{C3919950-512B-47B2-ACF3-6216F3DDBFD9}"/>
               </a:ext>
             </a:extLst>
           </p:cNvPr>
@@ -8935,7 +8931,7 @@
           <p:cNvPr id="11" name="">
             <a:extLst xmlns:a="http://schemas.openxmlformats.org/drawingml/2006/main">
               <a:ext uri="{FF2B5EF4-FFF2-40B4-BE49-F238E27FC236}">
-                <a16:creationId xmlns:a16="http://schemas.microsoft.com/office/drawing/2014/main" id="{17559637-0E92-4EAD-83A6-0BC110A0FAD0}"/>
+                <a16:creationId xmlns:a16="http://schemas.microsoft.com/office/drawing/2014/main" id="{6C9A0E6A-7EB3-44D0-A061-3380424AE9BA}"/>
               </a:ext>
             </a:extLst>
           </p:cNvPr>
@@ -8966,7 +8962,7 @@
           <p:cNvPr id="12" name="">
             <a:extLst xmlns:a="http://schemas.openxmlformats.org/drawingml/2006/main">
               <a:ext uri="{FF2B5EF4-FFF2-40B4-BE49-F238E27FC236}">
-                <a16:creationId xmlns:a16="http://schemas.microsoft.com/office/drawing/2014/main" id="{F44D7518-09F9-4555-913C-CD944D36F90F}"/>
+                <a16:creationId xmlns:a16="http://schemas.microsoft.com/office/drawing/2014/main" id="{53824C41-038F-4356-BBE7-888C662ACF5C}"/>
               </a:ext>
             </a:extLst>
           </p:cNvPr>
@@ -8997,7 +8993,7 @@
           <p:cNvPr id="13" name="">
             <a:extLst xmlns:a="http://schemas.openxmlformats.org/drawingml/2006/main">
               <a:ext uri="{FF2B5EF4-FFF2-40B4-BE49-F238E27FC236}">
-                <a16:creationId xmlns:a16="http://schemas.microsoft.com/office/drawing/2014/main" id="{51B580D0-5BAD-457F-A7D0-888D52416FEB}"/>
+                <a16:creationId xmlns:a16="http://schemas.microsoft.com/office/drawing/2014/main" id="{4741426B-B9A5-433C-973E-1F74A593C6B7}"/>
               </a:ext>
             </a:extLst>
           </p:cNvPr>
@@ -9053,7 +9049,7 @@
           <p:cNvPr id="14" name="">
             <a:extLst xmlns:a="http://schemas.openxmlformats.org/drawingml/2006/main">
               <a:ext uri="{FF2B5EF4-FFF2-40B4-BE49-F238E27FC236}">
-                <a16:creationId xmlns:a16="http://schemas.microsoft.com/office/drawing/2014/main" id="{D2BDDA4C-92B6-4FA7-9CE0-26DA170B1C02}"/>
+                <a16:creationId xmlns:a16="http://schemas.microsoft.com/office/drawing/2014/main" id="{D4207724-5ADB-4E43-9BE5-BEDE985F2B88}"/>
               </a:ext>
             </a:extLst>
           </p:cNvPr>
@@ -9109,7 +9105,7 @@
           <p:cNvPr id="15" name="">
             <a:extLst xmlns:a="http://schemas.openxmlformats.org/drawingml/2006/main">
               <a:ext uri="{FF2B5EF4-FFF2-40B4-BE49-F238E27FC236}">
-                <a16:creationId xmlns:a16="http://schemas.microsoft.com/office/drawing/2014/main" id="{BD8878C5-1955-4ADD-A8A6-F0898841B049}"/>
+                <a16:creationId xmlns:a16="http://schemas.microsoft.com/office/drawing/2014/main" id="{6DF9F0E7-2124-470F-A96F-B558F1AEFC9A}"/>
               </a:ext>
             </a:extLst>
           </p:cNvPr>
@@ -9148,7 +9144,7 @@
           <p:cNvPr id="16" name="">
             <a:extLst xmlns:a="http://schemas.openxmlformats.org/drawingml/2006/main">
               <a:ext uri="{FF2B5EF4-FFF2-40B4-BE49-F238E27FC236}">
-                <a16:creationId xmlns:a16="http://schemas.microsoft.com/office/drawing/2014/main" id="{004E778F-D0E9-4144-B582-A57F24068AFB}"/>
+                <a16:creationId xmlns:a16="http://schemas.microsoft.com/office/drawing/2014/main" id="{F63DB24E-3C62-4F6F-B75A-EA89105A890A}"/>
               </a:ext>
             </a:extLst>
           </p:cNvPr>
@@ -9204,7 +9200,7 @@
           <p:cNvPr id="17" name="">
             <a:extLst xmlns:a="http://schemas.openxmlformats.org/drawingml/2006/main">
               <a:ext uri="{FF2B5EF4-FFF2-40B4-BE49-F238E27FC236}">
-                <a16:creationId xmlns:a16="http://schemas.microsoft.com/office/drawing/2014/main" id="{CF79243C-4A4D-4644-A31D-3395AF226850}"/>
+                <a16:creationId xmlns:a16="http://schemas.microsoft.com/office/drawing/2014/main" id="{B28FA78D-EC33-409A-B50D-DEB1C982F070}"/>
               </a:ext>
             </a:extLst>
           </p:cNvPr>
@@ -9241,7 +9237,7 @@
           <p:cNvPr id="18" name="">
             <a:extLst xmlns:a="http://schemas.openxmlformats.org/drawingml/2006/main">
               <a:ext uri="{FF2B5EF4-FFF2-40B4-BE49-F238E27FC236}">
-                <a16:creationId xmlns:a16="http://schemas.microsoft.com/office/drawing/2014/main" id="{CDC63341-4CEC-44F3-B5D5-A316797F7284}"/>
+                <a16:creationId xmlns:a16="http://schemas.microsoft.com/office/drawing/2014/main" id="{A6059965-2BE1-4DC9-857F-8EF8F798D563}"/>
               </a:ext>
             </a:extLst>
           </p:cNvPr>
@@ -9297,7 +9293,7 @@
           <p:cNvPr id="19" name="">
             <a:extLst xmlns:a="http://schemas.openxmlformats.org/drawingml/2006/main">
               <a:ext uri="{FF2B5EF4-FFF2-40B4-BE49-F238E27FC236}">
-                <a16:creationId xmlns:a16="http://schemas.microsoft.com/office/drawing/2014/main" id="{2BA22958-E00B-4889-B9E6-F94959BF249C}"/>
+                <a16:creationId xmlns:a16="http://schemas.microsoft.com/office/drawing/2014/main" id="{067BA3FC-5A9C-4BEF-94AA-4D017DB107C3}"/>
               </a:ext>
             </a:extLst>
           </p:cNvPr>
@@ -9336,7 +9332,7 @@
           <p:cNvPr id="20" name="">
             <a:extLst xmlns:a="http://schemas.openxmlformats.org/drawingml/2006/main">
               <a:ext uri="{FF2B5EF4-FFF2-40B4-BE49-F238E27FC236}">
-                <a16:creationId xmlns:a16="http://schemas.microsoft.com/office/drawing/2014/main" id="{EFB1A2E8-7C61-489F-96AB-F3BDEFABE611}"/>
+                <a16:creationId xmlns:a16="http://schemas.microsoft.com/office/drawing/2014/main" id="{CE48A14E-2D6B-43C7-8FB3-98FDDB88F1A1}"/>
               </a:ext>
             </a:extLst>
           </p:cNvPr>
@@ -9392,7 +9388,7 @@
           <p:cNvPr id="21" name="">
             <a:extLst xmlns:a="http://schemas.openxmlformats.org/drawingml/2006/main">
               <a:ext uri="{FF2B5EF4-FFF2-40B4-BE49-F238E27FC236}">
-                <a16:creationId xmlns:a16="http://schemas.microsoft.com/office/drawing/2014/main" id="{6660B6AF-5B6D-4FFC-AB57-6A890094EF38}"/>
+                <a16:creationId xmlns:a16="http://schemas.microsoft.com/office/drawing/2014/main" id="{ECA1FA7E-C9D5-488B-87F6-CB0CE2C61126}"/>
               </a:ext>
             </a:extLst>
           </p:cNvPr>
@@ -9446,7 +9442,7 @@
     </p:spTree>
     <p:extLst>
       <p:ext uri="{BB962C8B-B14F-4D97-AF65-F5344CB8AC3E}">
-        <p14:creationId xmlns:p14="http://schemas.microsoft.com/office/powerpoint/2010/main" val="815153161"/>
+        <p14:creationId xmlns:p14="http://schemas.microsoft.com/office/powerpoint/2010/main" val="1130139567"/>
       </p:ext>
     </p:extLst>
   </p:cSld>
@@ -9477,7 +9473,7 @@
           <p:cNvPr id="1" name="">
             <a:extLst xmlns:a="http://schemas.openxmlformats.org/drawingml/2006/main">
               <a:ext uri="{FF2B5EF4-FFF2-40B4-BE49-F238E27FC236}">
-                <a16:creationId xmlns:a16="http://schemas.microsoft.com/office/drawing/2014/main" id="{9389A8EF-7E82-48F4-9952-B02F7B63B492}"/>
+                <a16:creationId xmlns:a16="http://schemas.microsoft.com/office/drawing/2014/main" id="{8237896C-0C02-427A-A06F-6668BC2CD99D}"/>
               </a:ext>
             </a:extLst>
           </p:cNvPr>
@@ -9508,7 +9504,7 @@
           <p:cNvPr id="2" name="">
             <a:extLst xmlns:a="http://schemas.openxmlformats.org/drawingml/2006/main">
               <a:ext uri="{FF2B5EF4-FFF2-40B4-BE49-F238E27FC236}">
-                <a16:creationId xmlns:a16="http://schemas.microsoft.com/office/drawing/2014/main" id="{7D29FCA5-A9CB-42D2-9BE3-2A13BE334B83}"/>
+                <a16:creationId xmlns:a16="http://schemas.microsoft.com/office/drawing/2014/main" id="{E9B1CB47-11E8-43DD-BF3A-BF9B1C191BC9}"/>
               </a:ext>
             </a:extLst>
           </p:cNvPr>
@@ -9539,7 +9535,7 @@
           <p:cNvPr id="3" name="">
             <a:extLst xmlns:a="http://schemas.openxmlformats.org/drawingml/2006/main">
               <a:ext uri="{FF2B5EF4-FFF2-40B4-BE49-F238E27FC236}">
-                <a16:creationId xmlns:a16="http://schemas.microsoft.com/office/drawing/2014/main" id="{038B7F01-920A-4078-90CB-B18DA0166FC4}"/>
+                <a16:creationId xmlns:a16="http://schemas.microsoft.com/office/drawing/2014/main" id="{5187EC9A-091E-4609-B8B1-3C6C89D8854E}"/>
               </a:ext>
             </a:extLst>
           </p:cNvPr>
@@ -9570,7 +9566,7 @@
           <p:cNvPr id="4" name="">
             <a:extLst xmlns:a="http://schemas.openxmlformats.org/drawingml/2006/main">
               <a:ext uri="{FF2B5EF4-FFF2-40B4-BE49-F238E27FC236}">
-                <a16:creationId xmlns:a16="http://schemas.microsoft.com/office/drawing/2014/main" id="{D83BBF96-35E6-4774-BCEF-551E58089900}"/>
+                <a16:creationId xmlns:a16="http://schemas.microsoft.com/office/drawing/2014/main" id="{9C89DCCC-592E-4158-8264-160D76C628E9}"/>
               </a:ext>
             </a:extLst>
           </p:cNvPr>
@@ -9601,7 +9597,7 @@
           <p:cNvPr id="5" name="">
             <a:extLst xmlns:a="http://schemas.openxmlformats.org/drawingml/2006/main">
               <a:ext uri="{FF2B5EF4-FFF2-40B4-BE49-F238E27FC236}">
-                <a16:creationId xmlns:a16="http://schemas.microsoft.com/office/drawing/2014/main" id="{6D7DE509-FC7D-4D2A-87AE-12769C315614}"/>
+                <a16:creationId xmlns:a16="http://schemas.microsoft.com/office/drawing/2014/main" id="{A15A3008-0B30-4B14-B5FD-F90F88F814BC}"/>
               </a:ext>
             </a:extLst>
           </p:cNvPr>
@@ -9632,7 +9628,7 @@
           <p:cNvPr id="6" name="">
             <a:extLst xmlns:a="http://schemas.openxmlformats.org/drawingml/2006/main">
               <a:ext uri="{FF2B5EF4-FFF2-40B4-BE49-F238E27FC236}">
-                <a16:creationId xmlns:a16="http://schemas.microsoft.com/office/drawing/2014/main" id="{3F6B20F8-5561-40AE-9BE8-4DD546A21A5A}"/>
+                <a16:creationId xmlns:a16="http://schemas.microsoft.com/office/drawing/2014/main" id="{4272F860-4EF8-45F9-86C8-0402465D77C5}"/>
               </a:ext>
             </a:extLst>
           </p:cNvPr>
@@ -9663,7 +9659,7 @@
           <p:cNvPr id="7" name="">
             <a:extLst xmlns:a="http://schemas.openxmlformats.org/drawingml/2006/main">
               <a:ext uri="{FF2B5EF4-FFF2-40B4-BE49-F238E27FC236}">
-                <a16:creationId xmlns:a16="http://schemas.microsoft.com/office/drawing/2014/main" id="{B2F757C2-E6F5-4AE7-AC22-1C35B112A549}"/>
+                <a16:creationId xmlns:a16="http://schemas.microsoft.com/office/drawing/2014/main" id="{11E0B82E-02C3-4E10-B893-4AF8D81B0F7C}"/>
               </a:ext>
             </a:extLst>
           </p:cNvPr>
@@ -9694,7 +9690,7 @@
           <p:cNvPr id="8" name="">
             <a:extLst xmlns:a="http://schemas.openxmlformats.org/drawingml/2006/main">
               <a:ext uri="{FF2B5EF4-FFF2-40B4-BE49-F238E27FC236}">
-                <a16:creationId xmlns:a16="http://schemas.microsoft.com/office/drawing/2014/main" id="{9D686795-E3EF-40CC-B9F0-241AB308B482}"/>
+                <a16:creationId xmlns:a16="http://schemas.microsoft.com/office/drawing/2014/main" id="{6DB3042A-2550-4905-BB00-5203D447C021}"/>
               </a:ext>
             </a:extLst>
           </p:cNvPr>
@@ -9725,7 +9721,7 @@
           <p:cNvPr id="9" name="">
             <a:extLst xmlns:a="http://schemas.openxmlformats.org/drawingml/2006/main">
               <a:ext uri="{FF2B5EF4-FFF2-40B4-BE49-F238E27FC236}">
-                <a16:creationId xmlns:a16="http://schemas.microsoft.com/office/drawing/2014/main" id="{3D78F3F5-E2A8-402D-840A-A046B8FFADE1}"/>
+                <a16:creationId xmlns:a16="http://schemas.microsoft.com/office/drawing/2014/main" id="{2C99DFBB-C144-4DF2-A8B1-F157278184C9}"/>
               </a:ext>
             </a:extLst>
           </p:cNvPr>
@@ -9756,7 +9752,7 @@
           <p:cNvPr id="10" name="">
             <a:extLst xmlns:a="http://schemas.openxmlformats.org/drawingml/2006/main">
               <a:ext uri="{FF2B5EF4-FFF2-40B4-BE49-F238E27FC236}">
-                <a16:creationId xmlns:a16="http://schemas.microsoft.com/office/drawing/2014/main" id="{D75DDFAF-0F34-46C7-A1B4-FC8D23F0260B}"/>
+                <a16:creationId xmlns:a16="http://schemas.microsoft.com/office/drawing/2014/main" id="{E5ABD765-27F8-43A1-93AC-52E42965C611}"/>
               </a:ext>
             </a:extLst>
           </p:cNvPr>
@@ -9787,7 +9783,7 @@
           <p:cNvPr id="11" name="">
             <a:extLst xmlns:a="http://schemas.openxmlformats.org/drawingml/2006/main">
               <a:ext uri="{FF2B5EF4-FFF2-40B4-BE49-F238E27FC236}">
-                <a16:creationId xmlns:a16="http://schemas.microsoft.com/office/drawing/2014/main" id="{080643FA-E2B4-4051-AFCC-84A43EC7F202}"/>
+                <a16:creationId xmlns:a16="http://schemas.microsoft.com/office/drawing/2014/main" id="{34EDF556-2E7A-4FF8-938E-84D1FD86E9E3}"/>
               </a:ext>
             </a:extLst>
           </p:cNvPr>
@@ -9818,7 +9814,7 @@
           <p:cNvPr id="12" name="">
             <a:extLst xmlns:a="http://schemas.openxmlformats.org/drawingml/2006/main">
               <a:ext uri="{FF2B5EF4-FFF2-40B4-BE49-F238E27FC236}">
-                <a16:creationId xmlns:a16="http://schemas.microsoft.com/office/drawing/2014/main" id="{A319D381-AA3E-4587-A413-070582AD0EC2}"/>
+                <a16:creationId xmlns:a16="http://schemas.microsoft.com/office/drawing/2014/main" id="{80BE235B-149D-4EFC-9FC4-CB8AF2A72063}"/>
               </a:ext>
             </a:extLst>
           </p:cNvPr>
@@ -9849,7 +9845,7 @@
           <p:cNvPr id="13" name="">
             <a:extLst xmlns:a="http://schemas.openxmlformats.org/drawingml/2006/main">
               <a:ext uri="{FF2B5EF4-FFF2-40B4-BE49-F238E27FC236}">
-                <a16:creationId xmlns:a16="http://schemas.microsoft.com/office/drawing/2014/main" id="{263CEBC9-FC2C-48A7-841F-2F5B30220E1F}"/>
+                <a16:creationId xmlns:a16="http://schemas.microsoft.com/office/drawing/2014/main" id="{D05E426F-2C52-458F-9FDD-301A342BC3EE}"/>
               </a:ext>
             </a:extLst>
           </p:cNvPr>
@@ -9905,7 +9901,7 @@
           <p:cNvPr id="14" name="">
             <a:extLst xmlns:a="http://schemas.openxmlformats.org/drawingml/2006/main">
               <a:ext uri="{FF2B5EF4-FFF2-40B4-BE49-F238E27FC236}">
-                <a16:creationId xmlns:a16="http://schemas.microsoft.com/office/drawing/2014/main" id="{5140E423-F6AE-4984-ADA2-EF495DAAE757}"/>
+                <a16:creationId xmlns:a16="http://schemas.microsoft.com/office/drawing/2014/main" id="{9BDF5026-1F0B-4D9E-A84B-ED7944B0A48F}"/>
               </a:ext>
             </a:extLst>
           </p:cNvPr>
@@ -9944,7 +9940,7 @@
           <p:cNvPr id="15" name="">
             <a:extLst xmlns:a="http://schemas.openxmlformats.org/drawingml/2006/main">
               <a:ext uri="{FF2B5EF4-FFF2-40B4-BE49-F238E27FC236}">
-                <a16:creationId xmlns:a16="http://schemas.microsoft.com/office/drawing/2014/main" id="{15783021-57A9-4755-8D7A-A7E474C56F49}"/>
+                <a16:creationId xmlns:a16="http://schemas.microsoft.com/office/drawing/2014/main" id="{11B8CE5D-ADED-4181-82FF-8C0FB1120BE2}"/>
               </a:ext>
             </a:extLst>
           </p:cNvPr>
@@ -10000,7 +9996,7 @@
           <p:cNvPr id="16" name="">
             <a:extLst xmlns:a="http://schemas.openxmlformats.org/drawingml/2006/main">
               <a:ext uri="{FF2B5EF4-FFF2-40B4-BE49-F238E27FC236}">
-                <a16:creationId xmlns:a16="http://schemas.microsoft.com/office/drawing/2014/main" id="{64328C4C-9DA4-46AA-8CD5-32B220FA7DE0}"/>
+                <a16:creationId xmlns:a16="http://schemas.microsoft.com/office/drawing/2014/main" id="{FBA6CEAF-8E84-432D-BF3D-0E51EF8EADA5}"/>
               </a:ext>
             </a:extLst>
           </p:cNvPr>
@@ -10016,7 +10012,7 @@
           </a:xfrm>
           <a:prstGeom xmlns:a="http://schemas.openxmlformats.org/drawingml/2006/main" prst="roundRect">
             <a:avLst>
-              <a:gd name="adj" fmla="val 48276"/>
+              <a:gd name="adj" fmla="val 50000"/>
             </a:avLst>
           </a:prstGeom>
           <a:solidFill xmlns:a="http://schemas.openxmlformats.org/drawingml/2006/main">
@@ -10039,7 +10035,7 @@
           <p:cNvPr id="17" name="">
             <a:extLst xmlns:a="http://schemas.openxmlformats.org/drawingml/2006/main">
               <a:ext uri="{FF2B5EF4-FFF2-40B4-BE49-F238E27FC236}">
-                <a16:creationId xmlns:a16="http://schemas.microsoft.com/office/drawing/2014/main" id="{C3A6B085-7679-4CCD-836A-8A19588E9398}"/>
+                <a16:creationId xmlns:a16="http://schemas.microsoft.com/office/drawing/2014/main" id="{4E3B5349-2970-4D0A-8989-F36202CA32B1}"/>
               </a:ext>
             </a:extLst>
           </p:cNvPr>
@@ -10051,7 +10047,7 @@
         <p:spPr>
           <a:xfrm xmlns:a="http://schemas.openxmlformats.org/drawingml/2006/main">
             <a:off x="1123950" y="4019550"/>
-            <a:ext cx="1562100" cy="400050"/>
+            <a:ext cx="1562100" cy="438150"/>
           </a:xfrm>
           <a:prstGeom xmlns:a="http://schemas.openxmlformats.org/drawingml/2006/main" prst="rect">
             <a:avLst/>
@@ -10095,7 +10091,7 @@
           <p:cNvPr id="18" name="">
             <a:extLst xmlns:a="http://schemas.openxmlformats.org/drawingml/2006/main">
               <a:ext uri="{FF2B5EF4-FFF2-40B4-BE49-F238E27FC236}">
-                <a16:creationId xmlns:a16="http://schemas.microsoft.com/office/drawing/2014/main" id="{B91E3C95-B3A8-409F-B9CD-1873FE9D3774}"/>
+                <a16:creationId xmlns:a16="http://schemas.microsoft.com/office/drawing/2014/main" id="{259DE03E-F8C8-4F37-9013-86F00AB2A5E3}"/>
               </a:ext>
             </a:extLst>
           </p:cNvPr>
@@ -10111,7 +10107,7 @@
           </a:xfrm>
           <a:prstGeom xmlns:a="http://schemas.openxmlformats.org/drawingml/2006/main" prst="roundRect">
             <a:avLst>
-              <a:gd name="adj" fmla="val 48276"/>
+              <a:gd name="adj" fmla="val 50000"/>
             </a:avLst>
           </a:prstGeom>
           <a:solidFill xmlns:a="http://schemas.openxmlformats.org/drawingml/2006/main">
@@ -10134,7 +10130,7 @@
           <p:cNvPr id="19" name="">
             <a:extLst xmlns:a="http://schemas.openxmlformats.org/drawingml/2006/main">
               <a:ext uri="{FF2B5EF4-FFF2-40B4-BE49-F238E27FC236}">
-                <a16:creationId xmlns:a16="http://schemas.microsoft.com/office/drawing/2014/main" id="{DE1454F8-330A-47BC-9E38-30F4D4FAEEF9}"/>
+                <a16:creationId xmlns:a16="http://schemas.microsoft.com/office/drawing/2014/main" id="{8E9128B3-A1FF-49D2-BF5B-C0EEE7B9F510}"/>
               </a:ext>
             </a:extLst>
           </p:cNvPr>
@@ -10146,7 +10142,7 @@
         <p:spPr>
           <a:xfrm xmlns:a="http://schemas.openxmlformats.org/drawingml/2006/main">
             <a:off x="3181350" y="4019550"/>
-            <a:ext cx="1943100" cy="400050"/>
+            <a:ext cx="1943100" cy="438150"/>
           </a:xfrm>
           <a:prstGeom xmlns:a="http://schemas.openxmlformats.org/drawingml/2006/main" prst="rect">
             <a:avLst/>
@@ -10190,7 +10186,7 @@
           <p:cNvPr id="20" name="">
             <a:extLst xmlns:a="http://schemas.openxmlformats.org/drawingml/2006/main">
               <a:ext uri="{FF2B5EF4-FFF2-40B4-BE49-F238E27FC236}">
-                <a16:creationId xmlns:a16="http://schemas.microsoft.com/office/drawing/2014/main" id="{412FBFA1-7D94-422F-9B60-F5C699CEB356}"/>
+                <a16:creationId xmlns:a16="http://schemas.microsoft.com/office/drawing/2014/main" id="{3E267447-3DD2-4A3D-B046-717AA88E6577}"/>
               </a:ext>
             </a:extLst>
           </p:cNvPr>
@@ -10206,7 +10202,7 @@
           </a:xfrm>
           <a:prstGeom xmlns:a="http://schemas.openxmlformats.org/drawingml/2006/main" prst="roundRect">
             <a:avLst>
-              <a:gd name="adj" fmla="val 48276"/>
+              <a:gd name="adj" fmla="val 50000"/>
             </a:avLst>
           </a:prstGeom>
           <a:solidFill xmlns:a="http://schemas.openxmlformats.org/drawingml/2006/main">
@@ -10229,7 +10225,7 @@
           <p:cNvPr id="21" name="">
             <a:extLst xmlns:a="http://schemas.openxmlformats.org/drawingml/2006/main">
               <a:ext uri="{FF2B5EF4-FFF2-40B4-BE49-F238E27FC236}">
-                <a16:creationId xmlns:a16="http://schemas.microsoft.com/office/drawing/2014/main" id="{ECB551CA-EA38-4CA3-8667-630721439570}"/>
+                <a16:creationId xmlns:a16="http://schemas.microsoft.com/office/drawing/2014/main" id="{08FB9B57-BCE8-46D9-BD83-4ED7D857EB55}"/>
               </a:ext>
             </a:extLst>
           </p:cNvPr>
@@ -10241,7 +10237,7 @@
         <p:spPr>
           <a:xfrm xmlns:a="http://schemas.openxmlformats.org/drawingml/2006/main">
             <a:off x="5619750" y="4019550"/>
-            <a:ext cx="2324100" cy="400050"/>
+            <a:ext cx="2324100" cy="438150"/>
           </a:xfrm>
           <a:prstGeom xmlns:a="http://schemas.openxmlformats.org/drawingml/2006/main" prst="rect">
             <a:avLst/>
@@ -10285,7 +10281,7 @@
           <p:cNvPr id="22" name="">
             <a:extLst xmlns:a="http://schemas.openxmlformats.org/drawingml/2006/main">
               <a:ext uri="{FF2B5EF4-FFF2-40B4-BE49-F238E27FC236}">
-                <a16:creationId xmlns:a16="http://schemas.microsoft.com/office/drawing/2014/main" id="{DF573508-76AD-4999-BCE6-7011CED7D882}"/>
+                <a16:creationId xmlns:a16="http://schemas.microsoft.com/office/drawing/2014/main" id="{BD8603F8-F8DF-49AE-AB84-21B1293CC7AA}"/>
               </a:ext>
             </a:extLst>
           </p:cNvPr>
@@ -10324,7 +10320,7 @@
           <p:cNvPr id="23" name="">
             <a:extLst xmlns:a="http://schemas.openxmlformats.org/drawingml/2006/main">
               <a:ext uri="{FF2B5EF4-FFF2-40B4-BE49-F238E27FC236}">
-                <a16:creationId xmlns:a16="http://schemas.microsoft.com/office/drawing/2014/main" id="{FE548C73-6D52-4EC0-A97C-8B2B13B4DF3B}"/>
+                <a16:creationId xmlns:a16="http://schemas.microsoft.com/office/drawing/2014/main" id="{6A4819FC-89BF-47BD-903C-90B666803DFB}"/>
               </a:ext>
             </a:extLst>
           </p:cNvPr>
@@ -10384,18 +10380,16 @@
           <p:nvPr/>
         </p:nvPicPr>
         <p:blipFill>
-          <a:blip xmlns:r="http://schemas.openxmlformats.org/officeDocument/2006/relationships" xmlns:a="http://schemas.openxmlformats.org/drawingml/2006/main" r:embed="Re99a359b0abf4000"/>
+          <a:blip xmlns:r="http://schemas.openxmlformats.org/officeDocument/2006/relationships" xmlns:a="http://schemas.openxmlformats.org/drawingml/2006/main" r:embed="R150ccc0ea7e34a6f"/>
           <a:stretch xmlns:a="http://schemas.openxmlformats.org/drawingml/2006/main"/>
         </p:blipFill>
         <p:spPr>
           <a:xfrm xmlns:a="http://schemas.openxmlformats.org/drawingml/2006/main">
-            <a:off x="8334375" y="2063854"/>
-            <a:ext cx="2343150" cy="2882691"/>
-          </a:xfrm>
-          <a:prstGeom xmlns:a="http://schemas.openxmlformats.org/drawingml/2006/main" prst="roundRect">
-            <a:avLst>
-              <a:gd name="adj" fmla="val 9756"/>
-            </a:avLst>
+            <a:off x="8362950" y="1790700"/>
+            <a:ext cx="2286000" cy="3429000"/>
+          </a:xfrm>
+          <a:prstGeom xmlns:a="http://schemas.openxmlformats.org/drawingml/2006/main" prst="rect">
+            <a:avLst/>
           </a:prstGeom>
         </p:spPr>
       </p:pic>
@@ -10404,7 +10398,7 @@
           <p:cNvPr id="25" name="">
             <a:extLst xmlns:a="http://schemas.openxmlformats.org/drawingml/2006/main">
               <a:ext uri="{FF2B5EF4-FFF2-40B4-BE49-F238E27FC236}">
-                <a16:creationId xmlns:a16="http://schemas.microsoft.com/office/drawing/2014/main" id="{9D2B70DA-8944-44B3-8CB1-483207E1D71F}"/>
+                <a16:creationId xmlns:a16="http://schemas.microsoft.com/office/drawing/2014/main" id="{B1ED3299-D36A-415C-BCDF-01775866C9A4}"/>
               </a:ext>
             </a:extLst>
           </p:cNvPr>
@@ -10458,7 +10452,7 @@
     </p:spTree>
     <p:extLst>
       <p:ext uri="{BB962C8B-B14F-4D97-AF65-F5344CB8AC3E}">
-        <p14:creationId xmlns:p14="http://schemas.microsoft.com/office/powerpoint/2010/main" val="657283816"/>
+        <p14:creationId xmlns:p14="http://schemas.microsoft.com/office/powerpoint/2010/main" val="2070265287"/>
       </p:ext>
     </p:extLst>
   </p:cSld>
@@ -10489,7 +10483,7 @@
           <p:cNvPr id="1" name="">
             <a:extLst xmlns:a="http://schemas.openxmlformats.org/drawingml/2006/main">
               <a:ext uri="{FF2B5EF4-FFF2-40B4-BE49-F238E27FC236}">
-                <a16:creationId xmlns:a16="http://schemas.microsoft.com/office/drawing/2014/main" id="{202ABD0B-EE10-4367-B21D-E1AB74A4D846}"/>
+                <a16:creationId xmlns:a16="http://schemas.microsoft.com/office/drawing/2014/main" id="{A4CAADB5-A222-4682-B13C-56ABD9AA89FA}"/>
               </a:ext>
             </a:extLst>
           </p:cNvPr>
@@ -10520,7 +10514,7 @@
           <p:cNvPr id="2" name="">
             <a:extLst xmlns:a="http://schemas.openxmlformats.org/drawingml/2006/main">
               <a:ext uri="{FF2B5EF4-FFF2-40B4-BE49-F238E27FC236}">
-                <a16:creationId xmlns:a16="http://schemas.microsoft.com/office/drawing/2014/main" id="{7CF56120-B61A-414D-9600-18DE6E763E74}"/>
+                <a16:creationId xmlns:a16="http://schemas.microsoft.com/office/drawing/2014/main" id="{ADC17522-1D67-4AFC-9E0C-3032AABC4B81}"/>
               </a:ext>
             </a:extLst>
           </p:cNvPr>
@@ -10551,7 +10545,7 @@
           <p:cNvPr id="3" name="">
             <a:extLst xmlns:a="http://schemas.openxmlformats.org/drawingml/2006/main">
               <a:ext uri="{FF2B5EF4-FFF2-40B4-BE49-F238E27FC236}">
-                <a16:creationId xmlns:a16="http://schemas.microsoft.com/office/drawing/2014/main" id="{7C65291B-5D9B-4591-8CC3-B62AD8EF04F6}"/>
+                <a16:creationId xmlns:a16="http://schemas.microsoft.com/office/drawing/2014/main" id="{98C35CED-0E93-407A-8CCC-37E4C9B9EFE1}"/>
               </a:ext>
             </a:extLst>
           </p:cNvPr>
@@ -10582,7 +10576,7 @@
           <p:cNvPr id="4" name="">
             <a:extLst xmlns:a="http://schemas.openxmlformats.org/drawingml/2006/main">
               <a:ext uri="{FF2B5EF4-FFF2-40B4-BE49-F238E27FC236}">
-                <a16:creationId xmlns:a16="http://schemas.microsoft.com/office/drawing/2014/main" id="{039D6AFB-B93C-4B00-8196-2CF25BEFF199}"/>
+                <a16:creationId xmlns:a16="http://schemas.microsoft.com/office/drawing/2014/main" id="{133D42A9-836E-4053-BF05-46B6F6EC34CD}"/>
               </a:ext>
             </a:extLst>
           </p:cNvPr>
@@ -10613,7 +10607,7 @@
           <p:cNvPr id="5" name="">
             <a:extLst xmlns:a="http://schemas.openxmlformats.org/drawingml/2006/main">
               <a:ext uri="{FF2B5EF4-FFF2-40B4-BE49-F238E27FC236}">
-                <a16:creationId xmlns:a16="http://schemas.microsoft.com/office/drawing/2014/main" id="{D344D2EF-349F-4179-A7C5-974E8AAAF5F7}"/>
+                <a16:creationId xmlns:a16="http://schemas.microsoft.com/office/drawing/2014/main" id="{F1A1392A-BA36-418F-8F20-3C19658C94BB}"/>
               </a:ext>
             </a:extLst>
           </p:cNvPr>
@@ -10644,7 +10638,7 @@
           <p:cNvPr id="6" name="">
             <a:extLst xmlns:a="http://schemas.openxmlformats.org/drawingml/2006/main">
               <a:ext uri="{FF2B5EF4-FFF2-40B4-BE49-F238E27FC236}">
-                <a16:creationId xmlns:a16="http://schemas.microsoft.com/office/drawing/2014/main" id="{B76075F6-5539-47E4-96F3-683E9BA03384}"/>
+                <a16:creationId xmlns:a16="http://schemas.microsoft.com/office/drawing/2014/main" id="{4CDA807A-0CD4-4F45-A112-D00D79A0856E}"/>
               </a:ext>
             </a:extLst>
           </p:cNvPr>
@@ -10675,7 +10669,7 @@
           <p:cNvPr id="7" name="">
             <a:extLst xmlns:a="http://schemas.openxmlformats.org/drawingml/2006/main">
               <a:ext uri="{FF2B5EF4-FFF2-40B4-BE49-F238E27FC236}">
-                <a16:creationId xmlns:a16="http://schemas.microsoft.com/office/drawing/2014/main" id="{C975ADEC-665A-4FC1-979F-A181CEFAF345}"/>
+                <a16:creationId xmlns:a16="http://schemas.microsoft.com/office/drawing/2014/main" id="{967449B9-87AD-43A5-ADF3-BD79D3F3C247}"/>
               </a:ext>
             </a:extLst>
           </p:cNvPr>
@@ -10706,7 +10700,7 @@
           <p:cNvPr id="8" name="">
             <a:extLst xmlns:a="http://schemas.openxmlformats.org/drawingml/2006/main">
               <a:ext uri="{FF2B5EF4-FFF2-40B4-BE49-F238E27FC236}">
-                <a16:creationId xmlns:a16="http://schemas.microsoft.com/office/drawing/2014/main" id="{A7B27DCD-CFD0-4C9A-B22A-33E1A2BACA6D}"/>
+                <a16:creationId xmlns:a16="http://schemas.microsoft.com/office/drawing/2014/main" id="{D98E331D-9418-4EBD-9990-2A9A9D4B5805}"/>
               </a:ext>
             </a:extLst>
           </p:cNvPr>
@@ -10737,7 +10731,7 @@
           <p:cNvPr id="9" name="">
             <a:extLst xmlns:a="http://schemas.openxmlformats.org/drawingml/2006/main">
               <a:ext uri="{FF2B5EF4-FFF2-40B4-BE49-F238E27FC236}">
-                <a16:creationId xmlns:a16="http://schemas.microsoft.com/office/drawing/2014/main" id="{7E2993CE-D39D-4D60-89B4-E530FADB8098}"/>
+                <a16:creationId xmlns:a16="http://schemas.microsoft.com/office/drawing/2014/main" id="{6BBE6DB3-294F-420A-B5F0-A8F06E47994C}"/>
               </a:ext>
             </a:extLst>
           </p:cNvPr>
@@ -10768,7 +10762,7 @@
           <p:cNvPr id="10" name="">
             <a:extLst xmlns:a="http://schemas.openxmlformats.org/drawingml/2006/main">
               <a:ext uri="{FF2B5EF4-FFF2-40B4-BE49-F238E27FC236}">
-                <a16:creationId xmlns:a16="http://schemas.microsoft.com/office/drawing/2014/main" id="{14F34D1F-946D-4EED-9937-E38901A4B2E3}"/>
+                <a16:creationId xmlns:a16="http://schemas.microsoft.com/office/drawing/2014/main" id="{3E89D69F-7CD4-4223-B7DD-EB5D438672E5}"/>
               </a:ext>
             </a:extLst>
           </p:cNvPr>
@@ -10799,7 +10793,7 @@
           <p:cNvPr id="11" name="">
             <a:extLst xmlns:a="http://schemas.openxmlformats.org/drawingml/2006/main">
               <a:ext uri="{FF2B5EF4-FFF2-40B4-BE49-F238E27FC236}">
-                <a16:creationId xmlns:a16="http://schemas.microsoft.com/office/drawing/2014/main" id="{7A5ACF35-08F9-4014-91B5-79E962B86EE5}"/>
+                <a16:creationId xmlns:a16="http://schemas.microsoft.com/office/drawing/2014/main" id="{B262A997-0616-432D-82E9-30E1728BF8C6}"/>
               </a:ext>
             </a:extLst>
           </p:cNvPr>
@@ -10830,7 +10824,7 @@
           <p:cNvPr id="12" name="">
             <a:extLst xmlns:a="http://schemas.openxmlformats.org/drawingml/2006/main">
               <a:ext uri="{FF2B5EF4-FFF2-40B4-BE49-F238E27FC236}">
-                <a16:creationId xmlns:a16="http://schemas.microsoft.com/office/drawing/2014/main" id="{0D6188CE-8FC5-436C-B189-BDDBC4C541BF}"/>
+                <a16:creationId xmlns:a16="http://schemas.microsoft.com/office/drawing/2014/main" id="{9492C83F-D358-4336-B049-AEB78075F8A9}"/>
               </a:ext>
             </a:extLst>
           </p:cNvPr>
@@ -10861,7 +10855,7 @@
           <p:cNvPr id="13" name="">
             <a:extLst xmlns:a="http://schemas.openxmlformats.org/drawingml/2006/main">
               <a:ext uri="{FF2B5EF4-FFF2-40B4-BE49-F238E27FC236}">
-                <a16:creationId xmlns:a16="http://schemas.microsoft.com/office/drawing/2014/main" id="{2ACEDE47-9DE8-495D-B1D3-543CE8794CA4}"/>
+                <a16:creationId xmlns:a16="http://schemas.microsoft.com/office/drawing/2014/main" id="{B249DC29-1A00-4871-A2E3-E6CA11AD8D17}"/>
               </a:ext>
             </a:extLst>
           </p:cNvPr>
@@ -10917,7 +10911,7 @@
           <p:cNvPr id="14" name="">
             <a:extLst xmlns:a="http://schemas.openxmlformats.org/drawingml/2006/main">
               <a:ext uri="{FF2B5EF4-FFF2-40B4-BE49-F238E27FC236}">
-                <a16:creationId xmlns:a16="http://schemas.microsoft.com/office/drawing/2014/main" id="{05F3D699-99B6-46F6-8BD0-E24FD874B29B}"/>
+                <a16:creationId xmlns:a16="http://schemas.microsoft.com/office/drawing/2014/main" id="{6580CE3D-FAB2-41CA-9DCD-2C53E93BD36B}"/>
               </a:ext>
             </a:extLst>
           </p:cNvPr>
@@ -10973,7 +10967,7 @@
           <p:cNvPr id="15" name="">
             <a:extLst xmlns:a="http://schemas.openxmlformats.org/drawingml/2006/main">
               <a:ext uri="{FF2B5EF4-FFF2-40B4-BE49-F238E27FC236}">
-                <a16:creationId xmlns:a16="http://schemas.microsoft.com/office/drawing/2014/main" id="{223E85E5-FDA9-46EF-8E41-A0034D9D259F}"/>
+                <a16:creationId xmlns:a16="http://schemas.microsoft.com/office/drawing/2014/main" id="{B6455233-2885-43CA-8421-EC931D134DBB}"/>
               </a:ext>
             </a:extLst>
           </p:cNvPr>
@@ -11012,7 +11006,7 @@
           <p:cNvPr id="16" name="">
             <a:extLst xmlns:a="http://schemas.openxmlformats.org/drawingml/2006/main">
               <a:ext uri="{FF2B5EF4-FFF2-40B4-BE49-F238E27FC236}">
-                <a16:creationId xmlns:a16="http://schemas.microsoft.com/office/drawing/2014/main" id="{9F73DBE0-8A12-46B9-9C88-A64E5B8A110C}"/>
+                <a16:creationId xmlns:a16="http://schemas.microsoft.com/office/drawing/2014/main" id="{F93020B8-CF61-4916-9A6A-6835D816CFCE}"/>
               </a:ext>
             </a:extLst>
           </p:cNvPr>
@@ -11068,7 +11062,7 @@
           <p:cNvPr id="17" name="">
             <a:extLst xmlns:a="http://schemas.openxmlformats.org/drawingml/2006/main">
               <a:ext uri="{FF2B5EF4-FFF2-40B4-BE49-F238E27FC236}">
-                <a16:creationId xmlns:a16="http://schemas.microsoft.com/office/drawing/2014/main" id="{F6D3ADD5-4780-44F6-A96C-E9538B4DC803}"/>
+                <a16:creationId xmlns:a16="http://schemas.microsoft.com/office/drawing/2014/main" id="{C4A58700-3E2A-4834-8AA2-22B9CEFECA5D}"/>
               </a:ext>
             </a:extLst>
           </p:cNvPr>
@@ -11080,11 +11074,11 @@
         <p:spPr>
           <a:xfrm xmlns:a="http://schemas.openxmlformats.org/drawingml/2006/main">
             <a:off x="3219450" y="1809750"/>
-            <a:ext cx="2000250" cy="552450"/>
+            <a:ext cx="2000250" cy="800100"/>
           </a:xfrm>
           <a:prstGeom xmlns:a="http://schemas.openxmlformats.org/drawingml/2006/main" prst="roundRect">
             <a:avLst>
-              <a:gd name="adj" fmla="val 48276"/>
+              <a:gd name="adj" fmla="val 50000"/>
             </a:avLst>
           </a:prstGeom>
           <a:solidFill xmlns:a="http://schemas.openxmlformats.org/drawingml/2006/main">
@@ -11107,7 +11101,7 @@
           <p:cNvPr id="18" name="">
             <a:extLst xmlns:a="http://schemas.openxmlformats.org/drawingml/2006/main">
               <a:ext uri="{FF2B5EF4-FFF2-40B4-BE49-F238E27FC236}">
-                <a16:creationId xmlns:a16="http://schemas.microsoft.com/office/drawing/2014/main" id="{21905A39-3F85-45CC-A6CD-70D447427073}"/>
+                <a16:creationId xmlns:a16="http://schemas.microsoft.com/office/drawing/2014/main" id="{AAB33582-9555-4BA8-94B2-876C268D2ACE}"/>
               </a:ext>
             </a:extLst>
           </p:cNvPr>
@@ -11119,7 +11113,7 @@
         <p:spPr>
           <a:xfrm xmlns:a="http://schemas.openxmlformats.org/drawingml/2006/main">
             <a:off x="3295650" y="1866900"/>
-            <a:ext cx="1847850" cy="400050"/>
+            <a:ext cx="1847850" cy="685800"/>
           </a:xfrm>
           <a:prstGeom xmlns:a="http://schemas.openxmlformats.org/drawingml/2006/main" prst="rect">
             <a:avLst/>
@@ -11163,7 +11157,7 @@
           <p:cNvPr id="19" name="">
             <a:extLst xmlns:a="http://schemas.openxmlformats.org/drawingml/2006/main">
               <a:ext uri="{FF2B5EF4-FFF2-40B4-BE49-F238E27FC236}">
-                <a16:creationId xmlns:a16="http://schemas.microsoft.com/office/drawing/2014/main" id="{D2C00A6F-6213-46E6-9C50-83DAEA52EC7B}"/>
+                <a16:creationId xmlns:a16="http://schemas.microsoft.com/office/drawing/2014/main" id="{7DCF1458-3E94-40CB-A64B-AF3512891E19}"/>
               </a:ext>
             </a:extLst>
           </p:cNvPr>
@@ -11175,11 +11169,11 @@
         <p:spPr>
           <a:xfrm xmlns:a="http://schemas.openxmlformats.org/drawingml/2006/main">
             <a:off x="5619750" y="1809750"/>
-            <a:ext cx="2000250" cy="552450"/>
+            <a:ext cx="2000250" cy="800100"/>
           </a:xfrm>
           <a:prstGeom xmlns:a="http://schemas.openxmlformats.org/drawingml/2006/main" prst="roundRect">
             <a:avLst>
-              <a:gd name="adj" fmla="val 48276"/>
+              <a:gd name="adj" fmla="val 50000"/>
             </a:avLst>
           </a:prstGeom>
           <a:solidFill xmlns:a="http://schemas.openxmlformats.org/drawingml/2006/main">
@@ -11202,7 +11196,7 @@
           <p:cNvPr id="20" name="">
             <a:extLst xmlns:a="http://schemas.openxmlformats.org/drawingml/2006/main">
               <a:ext uri="{FF2B5EF4-FFF2-40B4-BE49-F238E27FC236}">
-                <a16:creationId xmlns:a16="http://schemas.microsoft.com/office/drawing/2014/main" id="{B2881077-6548-4829-9BE9-98E842E62423}"/>
+                <a16:creationId xmlns:a16="http://schemas.microsoft.com/office/drawing/2014/main" id="{46076ECF-C436-4939-B3D5-EE3273E9ECEB}"/>
               </a:ext>
             </a:extLst>
           </p:cNvPr>
@@ -11214,7 +11208,7 @@
         <p:spPr>
           <a:xfrm xmlns:a="http://schemas.openxmlformats.org/drawingml/2006/main">
             <a:off x="5695950" y="1866900"/>
-            <a:ext cx="1847850" cy="400050"/>
+            <a:ext cx="1847850" cy="685800"/>
           </a:xfrm>
           <a:prstGeom xmlns:a="http://schemas.openxmlformats.org/drawingml/2006/main" prst="rect">
             <a:avLst/>
@@ -11258,7 +11252,7 @@
           <p:cNvPr id="21" name="">
             <a:extLst xmlns:a="http://schemas.openxmlformats.org/drawingml/2006/main">
               <a:ext uri="{FF2B5EF4-FFF2-40B4-BE49-F238E27FC236}">
-                <a16:creationId xmlns:a16="http://schemas.microsoft.com/office/drawing/2014/main" id="{533FF711-AEF6-41A8-BE5A-962B84D78FD9}"/>
+                <a16:creationId xmlns:a16="http://schemas.microsoft.com/office/drawing/2014/main" id="{CCFE000D-D4A7-41C6-8974-402008568FBF}"/>
               </a:ext>
             </a:extLst>
           </p:cNvPr>
@@ -11270,11 +11264,11 @@
         <p:spPr>
           <a:xfrm xmlns:a="http://schemas.openxmlformats.org/drawingml/2006/main">
             <a:off x="7810500" y="1809750"/>
-            <a:ext cx="2457450" cy="552450"/>
+            <a:ext cx="2457450" cy="800100"/>
           </a:xfrm>
           <a:prstGeom xmlns:a="http://schemas.openxmlformats.org/drawingml/2006/main" prst="roundRect">
             <a:avLst>
-              <a:gd name="adj" fmla="val 48276"/>
+              <a:gd name="adj" fmla="val 50000"/>
             </a:avLst>
           </a:prstGeom>
           <a:solidFill xmlns:a="http://schemas.openxmlformats.org/drawingml/2006/main">
@@ -11297,7 +11291,7 @@
           <p:cNvPr id="22" name="">
             <a:extLst xmlns:a="http://schemas.openxmlformats.org/drawingml/2006/main">
               <a:ext uri="{FF2B5EF4-FFF2-40B4-BE49-F238E27FC236}">
-                <a16:creationId xmlns:a16="http://schemas.microsoft.com/office/drawing/2014/main" id="{AF0F62E9-DACC-49CF-88EA-CF8C211EEEBE}"/>
+                <a16:creationId xmlns:a16="http://schemas.microsoft.com/office/drawing/2014/main" id="{A1A61AAE-AFA5-4ED3-BBF2-068C5043AC62}"/>
               </a:ext>
             </a:extLst>
           </p:cNvPr>
@@ -11309,7 +11303,7 @@
         <p:spPr>
           <a:xfrm xmlns:a="http://schemas.openxmlformats.org/drawingml/2006/main">
             <a:off x="7886700" y="1866900"/>
-            <a:ext cx="2305050" cy="400050"/>
+            <a:ext cx="2305050" cy="685800"/>
           </a:xfrm>
           <a:prstGeom xmlns:a="http://schemas.openxmlformats.org/drawingml/2006/main" prst="rect">
             <a:avLst/>
@@ -11353,7 +11347,7 @@
           <p:cNvPr id="23" name="">
             <a:extLst xmlns:a="http://schemas.openxmlformats.org/drawingml/2006/main">
               <a:ext uri="{FF2B5EF4-FFF2-40B4-BE49-F238E27FC236}">
-                <a16:creationId xmlns:a16="http://schemas.microsoft.com/office/drawing/2014/main" id="{4F8C5217-CA83-4CDE-84F7-809EB0269F83}"/>
+                <a16:creationId xmlns:a16="http://schemas.microsoft.com/office/drawing/2014/main" id="{2697CF7A-8469-4BFB-B1E0-D37890D5F7AC}"/>
               </a:ext>
             </a:extLst>
           </p:cNvPr>
@@ -11365,11 +11359,11 @@
         <p:spPr>
           <a:xfrm xmlns:a="http://schemas.openxmlformats.org/drawingml/2006/main">
             <a:off x="3219450" y="3105150"/>
-            <a:ext cx="2000250" cy="552450"/>
+            <a:ext cx="2000250" cy="800100"/>
           </a:xfrm>
           <a:prstGeom xmlns:a="http://schemas.openxmlformats.org/drawingml/2006/main" prst="roundRect">
             <a:avLst>
-              <a:gd name="adj" fmla="val 48276"/>
+              <a:gd name="adj" fmla="val 50000"/>
             </a:avLst>
           </a:prstGeom>
           <a:solidFill xmlns:a="http://schemas.openxmlformats.org/drawingml/2006/main">
@@ -11392,7 +11386,7 @@
           <p:cNvPr id="24" name="">
             <a:extLst xmlns:a="http://schemas.openxmlformats.org/drawingml/2006/main">
               <a:ext uri="{FF2B5EF4-FFF2-40B4-BE49-F238E27FC236}">
-                <a16:creationId xmlns:a16="http://schemas.microsoft.com/office/drawing/2014/main" id="{6DB3B12C-63B5-4CC0-AC8E-BD1E9E12C35D}"/>
+                <a16:creationId xmlns:a16="http://schemas.microsoft.com/office/drawing/2014/main" id="{8B40A7DF-6AD8-499D-885F-CEBA55B8C4B2}"/>
               </a:ext>
             </a:extLst>
           </p:cNvPr>
@@ -11404,7 +11398,7 @@
         <p:spPr>
           <a:xfrm xmlns:a="http://schemas.openxmlformats.org/drawingml/2006/main">
             <a:off x="3295650" y="3162300"/>
-            <a:ext cx="1847850" cy="400050"/>
+            <a:ext cx="1847850" cy="685800"/>
           </a:xfrm>
           <a:prstGeom xmlns:a="http://schemas.openxmlformats.org/drawingml/2006/main" prst="rect">
             <a:avLst/>
@@ -11448,7 +11442,7 @@
           <p:cNvPr id="25" name="">
             <a:extLst xmlns:a="http://schemas.openxmlformats.org/drawingml/2006/main">
               <a:ext uri="{FF2B5EF4-FFF2-40B4-BE49-F238E27FC236}">
-                <a16:creationId xmlns:a16="http://schemas.microsoft.com/office/drawing/2014/main" id="{ADF17AEB-C05D-465D-A543-0CD733D57B17}"/>
+                <a16:creationId xmlns:a16="http://schemas.microsoft.com/office/drawing/2014/main" id="{5C11A772-D32E-4278-AF74-5D43AA154056}"/>
               </a:ext>
             </a:extLst>
           </p:cNvPr>
@@ -11460,11 +11454,11 @@
         <p:spPr>
           <a:xfrm xmlns:a="http://schemas.openxmlformats.org/drawingml/2006/main">
             <a:off x="5619750" y="3105150"/>
-            <a:ext cx="2000250" cy="552450"/>
+            <a:ext cx="2000250" cy="800100"/>
           </a:xfrm>
           <a:prstGeom xmlns:a="http://schemas.openxmlformats.org/drawingml/2006/main" prst="roundRect">
             <a:avLst>
-              <a:gd name="adj" fmla="val 48276"/>
+              <a:gd name="adj" fmla="val 50000"/>
             </a:avLst>
           </a:prstGeom>
           <a:solidFill xmlns:a="http://schemas.openxmlformats.org/drawingml/2006/main">
@@ -11487,7 +11481,7 @@
           <p:cNvPr id="26" name="">
             <a:extLst xmlns:a="http://schemas.openxmlformats.org/drawingml/2006/main">
               <a:ext uri="{FF2B5EF4-FFF2-40B4-BE49-F238E27FC236}">
-                <a16:creationId xmlns:a16="http://schemas.microsoft.com/office/drawing/2014/main" id="{61E68D3D-1D5B-4A6F-B29A-75122D871B61}"/>
+                <a16:creationId xmlns:a16="http://schemas.microsoft.com/office/drawing/2014/main" id="{1BD3B188-EF71-4721-B33C-1FBB2EA89AC2}"/>
               </a:ext>
             </a:extLst>
           </p:cNvPr>
@@ -11499,7 +11493,7 @@
         <p:spPr>
           <a:xfrm xmlns:a="http://schemas.openxmlformats.org/drawingml/2006/main">
             <a:off x="5695950" y="3162300"/>
-            <a:ext cx="1847850" cy="400050"/>
+            <a:ext cx="1847850" cy="685800"/>
           </a:xfrm>
           <a:prstGeom xmlns:a="http://schemas.openxmlformats.org/drawingml/2006/main" prst="rect">
             <a:avLst/>
@@ -11543,7 +11537,7 @@
           <p:cNvPr id="27" name="">
             <a:extLst xmlns:a="http://schemas.openxmlformats.org/drawingml/2006/main">
               <a:ext uri="{FF2B5EF4-FFF2-40B4-BE49-F238E27FC236}">
-                <a16:creationId xmlns:a16="http://schemas.microsoft.com/office/drawing/2014/main" id="{80B58D6A-EB02-46DF-A72C-7D87E0E07EBD}"/>
+                <a16:creationId xmlns:a16="http://schemas.microsoft.com/office/drawing/2014/main" id="{87CD70EF-7C57-431D-9740-3774CD630DEF}"/>
               </a:ext>
             </a:extLst>
           </p:cNvPr>
@@ -11555,11 +11549,11 @@
         <p:spPr>
           <a:xfrm xmlns:a="http://schemas.openxmlformats.org/drawingml/2006/main">
             <a:off x="8020050" y="3105150"/>
-            <a:ext cx="2000250" cy="552450"/>
+            <a:ext cx="2000250" cy="800100"/>
           </a:xfrm>
           <a:prstGeom xmlns:a="http://schemas.openxmlformats.org/drawingml/2006/main" prst="roundRect">
             <a:avLst>
-              <a:gd name="adj" fmla="val 48276"/>
+              <a:gd name="adj" fmla="val 50000"/>
             </a:avLst>
           </a:prstGeom>
           <a:solidFill xmlns:a="http://schemas.openxmlformats.org/drawingml/2006/main">
@@ -11582,7 +11576,7 @@
           <p:cNvPr id="28" name="">
             <a:extLst xmlns:a="http://schemas.openxmlformats.org/drawingml/2006/main">
               <a:ext uri="{FF2B5EF4-FFF2-40B4-BE49-F238E27FC236}">
-                <a16:creationId xmlns:a16="http://schemas.microsoft.com/office/drawing/2014/main" id="{2E4892C4-B427-4439-9F86-EB29DAA1C6AA}"/>
+                <a16:creationId xmlns:a16="http://schemas.microsoft.com/office/drawing/2014/main" id="{69AEA171-FB67-4605-BC49-01FC34C0A65B}"/>
               </a:ext>
             </a:extLst>
           </p:cNvPr>
@@ -11594,7 +11588,7 @@
         <p:spPr>
           <a:xfrm xmlns:a="http://schemas.openxmlformats.org/drawingml/2006/main">
             <a:off x="8096250" y="3162300"/>
-            <a:ext cx="1847850" cy="400050"/>
+            <a:ext cx="1847850" cy="685800"/>
           </a:xfrm>
           <a:prstGeom xmlns:a="http://schemas.openxmlformats.org/drawingml/2006/main" prst="rect">
             <a:avLst/>
@@ -11638,7 +11632,7 @@
           <p:cNvPr id="29" name="">
             <a:extLst xmlns:a="http://schemas.openxmlformats.org/drawingml/2006/main">
               <a:ext uri="{FF2B5EF4-FFF2-40B4-BE49-F238E27FC236}">
-                <a16:creationId xmlns:a16="http://schemas.microsoft.com/office/drawing/2014/main" id="{CBDEE1F7-BB73-4524-9D78-1A0BE5EA5FAB}"/>
+                <a16:creationId xmlns:a16="http://schemas.microsoft.com/office/drawing/2014/main" id="{CF80377F-83E1-4A92-B5D0-89D6B7531782}"/>
               </a:ext>
             </a:extLst>
           </p:cNvPr>
@@ -11677,7 +11671,7 @@
           <p:cNvPr id="30" name="">
             <a:extLst xmlns:a="http://schemas.openxmlformats.org/drawingml/2006/main">
               <a:ext uri="{FF2B5EF4-FFF2-40B4-BE49-F238E27FC236}">
-                <a16:creationId xmlns:a16="http://schemas.microsoft.com/office/drawing/2014/main" id="{871F94BD-42F7-4DAD-A0AE-53D4CF927593}"/>
+                <a16:creationId xmlns:a16="http://schemas.microsoft.com/office/drawing/2014/main" id="{F66FBA89-984B-4CE7-A296-68EB2657DF10}"/>
               </a:ext>
             </a:extLst>
           </p:cNvPr>
@@ -11733,7 +11727,7 @@
           <p:cNvPr id="31" name="">
             <a:extLst xmlns:a="http://schemas.openxmlformats.org/drawingml/2006/main">
               <a:ext uri="{FF2B5EF4-FFF2-40B4-BE49-F238E27FC236}">
-                <a16:creationId xmlns:a16="http://schemas.microsoft.com/office/drawing/2014/main" id="{B0EF7941-719C-43A2-8408-0A978BD3307C}"/>
+                <a16:creationId xmlns:a16="http://schemas.microsoft.com/office/drawing/2014/main" id="{0C822F80-C40D-44F9-ABF6-171169BFA4C5}"/>
               </a:ext>
             </a:extLst>
           </p:cNvPr>
@@ -11787,7 +11781,7 @@
     </p:spTree>
     <p:extLst>
       <p:ext uri="{BB962C8B-B14F-4D97-AF65-F5344CB8AC3E}">
-        <p14:creationId xmlns:p14="http://schemas.microsoft.com/office/powerpoint/2010/main" val="562346092"/>
+        <p14:creationId xmlns:p14="http://schemas.microsoft.com/office/powerpoint/2010/main" val="173910884"/>
       </p:ext>
     </p:extLst>
   </p:cSld>
@@ -11818,7 +11812,7 @@
           <p:cNvPr id="1" name="">
             <a:extLst xmlns:a="http://schemas.openxmlformats.org/drawingml/2006/main">
               <a:ext uri="{FF2B5EF4-FFF2-40B4-BE49-F238E27FC236}">
-                <a16:creationId xmlns:a16="http://schemas.microsoft.com/office/drawing/2014/main" id="{6D86D714-1963-4386-B5EE-09FB1E9D0FE7}"/>
+                <a16:creationId xmlns:a16="http://schemas.microsoft.com/office/drawing/2014/main" id="{B11F199D-93E8-4EA6-86F1-CFA9A9959553}"/>
               </a:ext>
             </a:extLst>
           </p:cNvPr>
@@ -11849,7 +11843,7 @@
           <p:cNvPr id="2" name="">
             <a:extLst xmlns:a="http://schemas.openxmlformats.org/drawingml/2006/main">
               <a:ext uri="{FF2B5EF4-FFF2-40B4-BE49-F238E27FC236}">
-                <a16:creationId xmlns:a16="http://schemas.microsoft.com/office/drawing/2014/main" id="{0474508F-B7C4-46E7-8036-ECD59FD100CD}"/>
+                <a16:creationId xmlns:a16="http://schemas.microsoft.com/office/drawing/2014/main" id="{A4DD6016-7D00-445F-BE32-51B3D8068578}"/>
               </a:ext>
             </a:extLst>
           </p:cNvPr>
@@ -11880,7 +11874,7 @@
           <p:cNvPr id="3" name="">
             <a:extLst xmlns:a="http://schemas.openxmlformats.org/drawingml/2006/main">
               <a:ext uri="{FF2B5EF4-FFF2-40B4-BE49-F238E27FC236}">
-                <a16:creationId xmlns:a16="http://schemas.microsoft.com/office/drawing/2014/main" id="{C9CC2D78-F508-4364-A4E9-A9EEC5BEA80E}"/>
+                <a16:creationId xmlns:a16="http://schemas.microsoft.com/office/drawing/2014/main" id="{0347BEBD-480A-428F-BAF2-D7B03FEBA5D6}"/>
               </a:ext>
             </a:extLst>
           </p:cNvPr>
@@ -11911,7 +11905,7 @@
           <p:cNvPr id="4" name="">
             <a:extLst xmlns:a="http://schemas.openxmlformats.org/drawingml/2006/main">
               <a:ext uri="{FF2B5EF4-FFF2-40B4-BE49-F238E27FC236}">
-                <a16:creationId xmlns:a16="http://schemas.microsoft.com/office/drawing/2014/main" id="{D4CCA8B3-D3BE-4127-9EBB-C6B835FF2D00}"/>
+                <a16:creationId xmlns:a16="http://schemas.microsoft.com/office/drawing/2014/main" id="{60534809-D470-484C-8FC5-FF31E863F60E}"/>
               </a:ext>
             </a:extLst>
           </p:cNvPr>
@@ -11942,7 +11936,7 @@
           <p:cNvPr id="5" name="">
             <a:extLst xmlns:a="http://schemas.openxmlformats.org/drawingml/2006/main">
               <a:ext uri="{FF2B5EF4-FFF2-40B4-BE49-F238E27FC236}">
-                <a16:creationId xmlns:a16="http://schemas.microsoft.com/office/drawing/2014/main" id="{1037B85A-C51D-436E-A461-1583CD694738}"/>
+                <a16:creationId xmlns:a16="http://schemas.microsoft.com/office/drawing/2014/main" id="{C3AABB74-3C6D-4F64-88CA-0A9667062AE5}"/>
               </a:ext>
             </a:extLst>
           </p:cNvPr>
@@ -11973,7 +11967,7 @@
           <p:cNvPr id="6" name="">
             <a:extLst xmlns:a="http://schemas.openxmlformats.org/drawingml/2006/main">
               <a:ext uri="{FF2B5EF4-FFF2-40B4-BE49-F238E27FC236}">
-                <a16:creationId xmlns:a16="http://schemas.microsoft.com/office/drawing/2014/main" id="{ACA16F00-03F4-4B4E-978E-D29A6A9AEA1E}"/>
+                <a16:creationId xmlns:a16="http://schemas.microsoft.com/office/drawing/2014/main" id="{C7592936-ADEC-4D95-A62A-940AB96A6FC4}"/>
               </a:ext>
             </a:extLst>
           </p:cNvPr>
@@ -12004,7 +11998,7 @@
           <p:cNvPr id="7" name="">
             <a:extLst xmlns:a="http://schemas.openxmlformats.org/drawingml/2006/main">
               <a:ext uri="{FF2B5EF4-FFF2-40B4-BE49-F238E27FC236}">
-                <a16:creationId xmlns:a16="http://schemas.microsoft.com/office/drawing/2014/main" id="{C77BFE09-06EB-449C-AAA5-ED2E432AB615}"/>
+                <a16:creationId xmlns:a16="http://schemas.microsoft.com/office/drawing/2014/main" id="{6961421D-D4DB-44EA-A4C7-0A2AB514DB67}"/>
               </a:ext>
             </a:extLst>
           </p:cNvPr>
@@ -12035,7 +12029,7 @@
           <p:cNvPr id="8" name="">
             <a:extLst xmlns:a="http://schemas.openxmlformats.org/drawingml/2006/main">
               <a:ext uri="{FF2B5EF4-FFF2-40B4-BE49-F238E27FC236}">
-                <a16:creationId xmlns:a16="http://schemas.microsoft.com/office/drawing/2014/main" id="{1B626860-4F2B-4E12-A943-A613F0CBA297}"/>
+                <a16:creationId xmlns:a16="http://schemas.microsoft.com/office/drawing/2014/main" id="{C03704AD-6BBD-4D84-ABD2-CBE28199958D}"/>
               </a:ext>
             </a:extLst>
           </p:cNvPr>
@@ -12066,7 +12060,7 @@
           <p:cNvPr id="9" name="">
             <a:extLst xmlns:a="http://schemas.openxmlformats.org/drawingml/2006/main">
               <a:ext uri="{FF2B5EF4-FFF2-40B4-BE49-F238E27FC236}">
-                <a16:creationId xmlns:a16="http://schemas.microsoft.com/office/drawing/2014/main" id="{5ED351C6-5B9A-4646-B4A9-7FD998288081}"/>
+                <a16:creationId xmlns:a16="http://schemas.microsoft.com/office/drawing/2014/main" id="{55879D01-569D-4BD0-8D5C-C224FE616E2C}"/>
               </a:ext>
             </a:extLst>
           </p:cNvPr>
@@ -12097,7 +12091,7 @@
           <p:cNvPr id="10" name="">
             <a:extLst xmlns:a="http://schemas.openxmlformats.org/drawingml/2006/main">
               <a:ext uri="{FF2B5EF4-FFF2-40B4-BE49-F238E27FC236}">
-                <a16:creationId xmlns:a16="http://schemas.microsoft.com/office/drawing/2014/main" id="{EAC41E5B-3FDC-4CB4-9822-5191CB2B45BE}"/>
+                <a16:creationId xmlns:a16="http://schemas.microsoft.com/office/drawing/2014/main" id="{F6AB817E-ABB9-4A94-8301-CD594CA74C3B}"/>
               </a:ext>
             </a:extLst>
           </p:cNvPr>
@@ -12128,7 +12122,7 @@
           <p:cNvPr id="11" name="">
             <a:extLst xmlns:a="http://schemas.openxmlformats.org/drawingml/2006/main">
               <a:ext uri="{FF2B5EF4-FFF2-40B4-BE49-F238E27FC236}">
-                <a16:creationId xmlns:a16="http://schemas.microsoft.com/office/drawing/2014/main" id="{C36D77B8-242B-4B35-BC10-8B7EEB86C31B}"/>
+                <a16:creationId xmlns:a16="http://schemas.microsoft.com/office/drawing/2014/main" id="{0972484E-35EF-4365-81D9-FB7C65C74DB1}"/>
               </a:ext>
             </a:extLst>
           </p:cNvPr>
@@ -12159,7 +12153,7 @@
           <p:cNvPr id="12" name="">
             <a:extLst xmlns:a="http://schemas.openxmlformats.org/drawingml/2006/main">
               <a:ext uri="{FF2B5EF4-FFF2-40B4-BE49-F238E27FC236}">
-                <a16:creationId xmlns:a16="http://schemas.microsoft.com/office/drawing/2014/main" id="{70306A9E-DEA3-4D13-82A7-6AB9E81FC92F}"/>
+                <a16:creationId xmlns:a16="http://schemas.microsoft.com/office/drawing/2014/main" id="{EF3FD75E-44FB-4BFE-BC7C-8EDD37942475}"/>
               </a:ext>
             </a:extLst>
           </p:cNvPr>
@@ -12190,7 +12184,7 @@
           <p:cNvPr id="13" name="">
             <a:extLst xmlns:a="http://schemas.openxmlformats.org/drawingml/2006/main">
               <a:ext uri="{FF2B5EF4-FFF2-40B4-BE49-F238E27FC236}">
-                <a16:creationId xmlns:a16="http://schemas.microsoft.com/office/drawing/2014/main" id="{847393BE-D313-4634-A8F9-7C52B4C40BEC}"/>
+                <a16:creationId xmlns:a16="http://schemas.microsoft.com/office/drawing/2014/main" id="{E2DD06A3-3BC8-4095-ABCD-BF5C9A408B1A}"/>
               </a:ext>
             </a:extLst>
           </p:cNvPr>
@@ -12246,7 +12240,7 @@
           <p:cNvPr id="14" name="">
             <a:extLst xmlns:a="http://schemas.openxmlformats.org/drawingml/2006/main">
               <a:ext uri="{FF2B5EF4-FFF2-40B4-BE49-F238E27FC236}">
-                <a16:creationId xmlns:a16="http://schemas.microsoft.com/office/drawing/2014/main" id="{9AD3983A-BDB4-49A0-9F10-129BF99ED699}"/>
+                <a16:creationId xmlns:a16="http://schemas.microsoft.com/office/drawing/2014/main" id="{E2207DEA-F1F7-40D3-8B0F-B459D483ED11}"/>
               </a:ext>
             </a:extLst>
           </p:cNvPr>
@@ -12302,7 +12296,7 @@
           <p:cNvPr id="15" name="">
             <a:extLst xmlns:a="http://schemas.openxmlformats.org/drawingml/2006/main">
               <a:ext uri="{FF2B5EF4-FFF2-40B4-BE49-F238E27FC236}">
-                <a16:creationId xmlns:a16="http://schemas.microsoft.com/office/drawing/2014/main" id="{FC952801-1D3D-445A-A136-512F2367F693}"/>
+                <a16:creationId xmlns:a16="http://schemas.microsoft.com/office/drawing/2014/main" id="{1F68B42D-975B-4510-8418-0088616C0E3E}"/>
               </a:ext>
             </a:extLst>
           </p:cNvPr>
@@ -12341,7 +12335,7 @@
           <p:cNvPr id="16" name="">
             <a:extLst xmlns:a="http://schemas.openxmlformats.org/drawingml/2006/main">
               <a:ext uri="{FF2B5EF4-FFF2-40B4-BE49-F238E27FC236}">
-                <a16:creationId xmlns:a16="http://schemas.microsoft.com/office/drawing/2014/main" id="{E031FC91-EA91-4761-A3C3-713C185ED5CD}"/>
+                <a16:creationId xmlns:a16="http://schemas.microsoft.com/office/drawing/2014/main" id="{E1C47E18-3983-413E-868A-C6CAF31EE0E6}"/>
               </a:ext>
             </a:extLst>
           </p:cNvPr>
@@ -12397,7 +12391,7 @@
           <p:cNvPr id="17" name="">
             <a:extLst xmlns:a="http://schemas.openxmlformats.org/drawingml/2006/main">
               <a:ext uri="{FF2B5EF4-FFF2-40B4-BE49-F238E27FC236}">
-                <a16:creationId xmlns:a16="http://schemas.microsoft.com/office/drawing/2014/main" id="{8DCEA14D-9AA1-4436-B0F5-CF0C73D6A4EC}"/>
+                <a16:creationId xmlns:a16="http://schemas.microsoft.com/office/drawing/2014/main" id="{8A45AE4C-DF90-4D89-A8C8-6CAB835E28A7}"/>
               </a:ext>
             </a:extLst>
           </p:cNvPr>
@@ -12413,7 +12407,7 @@
           </a:xfrm>
           <a:prstGeom xmlns:a="http://schemas.openxmlformats.org/drawingml/2006/main" prst="roundRect">
             <a:avLst>
-              <a:gd name="adj" fmla="val 48276"/>
+              <a:gd name="adj" fmla="val 50000"/>
             </a:avLst>
           </a:prstGeom>
           <a:solidFill xmlns:a="http://schemas.openxmlformats.org/drawingml/2006/main">
@@ -12436,7 +12430,7 @@
           <p:cNvPr id="18" name="">
             <a:extLst xmlns:a="http://schemas.openxmlformats.org/drawingml/2006/main">
               <a:ext uri="{FF2B5EF4-FFF2-40B4-BE49-F238E27FC236}">
-                <a16:creationId xmlns:a16="http://schemas.microsoft.com/office/drawing/2014/main" id="{8FAE23F6-9514-4B00-8991-657C2DA462E0}"/>
+                <a16:creationId xmlns:a16="http://schemas.microsoft.com/office/drawing/2014/main" id="{E854F998-D13C-4268-98C0-5D9BF2C5DE65}"/>
               </a:ext>
             </a:extLst>
           </p:cNvPr>
@@ -12448,7 +12442,7 @@
         <p:spPr>
           <a:xfrm xmlns:a="http://schemas.openxmlformats.org/drawingml/2006/main">
             <a:off x="3295650" y="1866900"/>
-            <a:ext cx="1847850" cy="400050"/>
+            <a:ext cx="1847850" cy="438150"/>
           </a:xfrm>
           <a:prstGeom xmlns:a="http://schemas.openxmlformats.org/drawingml/2006/main" prst="rect">
             <a:avLst/>
@@ -12492,7 +12486,7 @@
           <p:cNvPr id="19" name="">
             <a:extLst xmlns:a="http://schemas.openxmlformats.org/drawingml/2006/main">
               <a:ext uri="{FF2B5EF4-FFF2-40B4-BE49-F238E27FC236}">
-                <a16:creationId xmlns:a16="http://schemas.microsoft.com/office/drawing/2014/main" id="{E24E0CCD-A504-465A-96E6-EBB5FE00EC40}"/>
+                <a16:creationId xmlns:a16="http://schemas.microsoft.com/office/drawing/2014/main" id="{292605DE-8747-4079-84C9-D94BFB915A6A}"/>
               </a:ext>
             </a:extLst>
           </p:cNvPr>
@@ -12508,7 +12502,7 @@
           </a:xfrm>
           <a:prstGeom xmlns:a="http://schemas.openxmlformats.org/drawingml/2006/main" prst="roundRect">
             <a:avLst>
-              <a:gd name="adj" fmla="val 48276"/>
+              <a:gd name="adj" fmla="val 50000"/>
             </a:avLst>
           </a:prstGeom>
           <a:solidFill xmlns:a="http://schemas.openxmlformats.org/drawingml/2006/main">
@@ -12531,7 +12525,7 @@
           <p:cNvPr id="20" name="">
             <a:extLst xmlns:a="http://schemas.openxmlformats.org/drawingml/2006/main">
               <a:ext uri="{FF2B5EF4-FFF2-40B4-BE49-F238E27FC236}">
-                <a16:creationId xmlns:a16="http://schemas.microsoft.com/office/drawing/2014/main" id="{2125D021-10C6-40AD-8005-A7340CAB4506}"/>
+                <a16:creationId xmlns:a16="http://schemas.microsoft.com/office/drawing/2014/main" id="{B6A9A02B-DBE1-4B0C-84FE-85C68DE6FB74}"/>
               </a:ext>
             </a:extLst>
           </p:cNvPr>
@@ -12543,7 +12537,7 @@
         <p:spPr>
           <a:xfrm xmlns:a="http://schemas.openxmlformats.org/drawingml/2006/main">
             <a:off x="5695950" y="1866900"/>
-            <a:ext cx="1847850" cy="400050"/>
+            <a:ext cx="1847850" cy="438150"/>
           </a:xfrm>
           <a:prstGeom xmlns:a="http://schemas.openxmlformats.org/drawingml/2006/main" prst="rect">
             <a:avLst/>
@@ -12587,7 +12581,7 @@
           <p:cNvPr id="21" name="">
             <a:extLst xmlns:a="http://schemas.openxmlformats.org/drawingml/2006/main">
               <a:ext uri="{FF2B5EF4-FFF2-40B4-BE49-F238E27FC236}">
-                <a16:creationId xmlns:a16="http://schemas.microsoft.com/office/drawing/2014/main" id="{00E0F1E2-D1F7-4FD5-832B-DF32AFBA1690}"/>
+                <a16:creationId xmlns:a16="http://schemas.microsoft.com/office/drawing/2014/main" id="{6E93D1EE-78C4-45FA-BE23-D7D4B6C20343}"/>
               </a:ext>
             </a:extLst>
           </p:cNvPr>
@@ -12603,7 +12597,7 @@
           </a:xfrm>
           <a:prstGeom xmlns:a="http://schemas.openxmlformats.org/drawingml/2006/main" prst="roundRect">
             <a:avLst>
-              <a:gd name="adj" fmla="val 48276"/>
+              <a:gd name="adj" fmla="val 50000"/>
             </a:avLst>
           </a:prstGeom>
           <a:solidFill xmlns:a="http://schemas.openxmlformats.org/drawingml/2006/main">
@@ -12626,7 +12620,7 @@
           <p:cNvPr id="22" name="">
             <a:extLst xmlns:a="http://schemas.openxmlformats.org/drawingml/2006/main">
               <a:ext uri="{FF2B5EF4-FFF2-40B4-BE49-F238E27FC236}">
-                <a16:creationId xmlns:a16="http://schemas.microsoft.com/office/drawing/2014/main" id="{DB36799B-DD34-4875-9152-53D08E879788}"/>
+                <a16:creationId xmlns:a16="http://schemas.microsoft.com/office/drawing/2014/main" id="{66691279-9963-4DCD-B6FB-37F9FBFDA1E6}"/>
               </a:ext>
             </a:extLst>
           </p:cNvPr>
@@ -12638,7 +12632,7 @@
         <p:spPr>
           <a:xfrm xmlns:a="http://schemas.openxmlformats.org/drawingml/2006/main">
             <a:off x="8096250" y="1866900"/>
-            <a:ext cx="1847850" cy="400050"/>
+            <a:ext cx="1847850" cy="438150"/>
           </a:xfrm>
           <a:prstGeom xmlns:a="http://schemas.openxmlformats.org/drawingml/2006/main" prst="rect">
             <a:avLst/>
@@ -12682,7 +12676,7 @@
           <p:cNvPr id="23" name="">
             <a:extLst xmlns:a="http://schemas.openxmlformats.org/drawingml/2006/main">
               <a:ext uri="{FF2B5EF4-FFF2-40B4-BE49-F238E27FC236}">
-                <a16:creationId xmlns:a16="http://schemas.microsoft.com/office/drawing/2014/main" id="{514CA371-B719-4919-84AE-D1518D92755F}"/>
+                <a16:creationId xmlns:a16="http://schemas.microsoft.com/office/drawing/2014/main" id="{1016D099-F963-4A5D-9A37-028B4808A377}"/>
               </a:ext>
             </a:extLst>
           </p:cNvPr>
@@ -12698,7 +12692,7 @@
           </a:xfrm>
           <a:prstGeom xmlns:a="http://schemas.openxmlformats.org/drawingml/2006/main" prst="roundRect">
             <a:avLst>
-              <a:gd name="adj" fmla="val 48276"/>
+              <a:gd name="adj" fmla="val 50000"/>
             </a:avLst>
           </a:prstGeom>
           <a:solidFill xmlns:a="http://schemas.openxmlformats.org/drawingml/2006/main">
@@ -12721,7 +12715,7 @@
           <p:cNvPr id="24" name="">
             <a:extLst xmlns:a="http://schemas.openxmlformats.org/drawingml/2006/main">
               <a:ext uri="{FF2B5EF4-FFF2-40B4-BE49-F238E27FC236}">
-                <a16:creationId xmlns:a16="http://schemas.microsoft.com/office/drawing/2014/main" id="{E4544810-D567-450D-A410-63016ED3B8BE}"/>
+                <a16:creationId xmlns:a16="http://schemas.microsoft.com/office/drawing/2014/main" id="{0EBCF1F4-E123-4816-A790-24B33FEDF163}"/>
               </a:ext>
             </a:extLst>
           </p:cNvPr>
@@ -12733,7 +12727,7 @@
         <p:spPr>
           <a:xfrm xmlns:a="http://schemas.openxmlformats.org/drawingml/2006/main">
             <a:off x="3295650" y="3162300"/>
-            <a:ext cx="1847850" cy="400050"/>
+            <a:ext cx="1847850" cy="438150"/>
           </a:xfrm>
           <a:prstGeom xmlns:a="http://schemas.openxmlformats.org/drawingml/2006/main" prst="rect">
             <a:avLst/>
@@ -12777,7 +12771,7 @@
           <p:cNvPr id="25" name="">
             <a:extLst xmlns:a="http://schemas.openxmlformats.org/drawingml/2006/main">
               <a:ext uri="{FF2B5EF4-FFF2-40B4-BE49-F238E27FC236}">
-                <a16:creationId xmlns:a16="http://schemas.microsoft.com/office/drawing/2014/main" id="{1F0BB793-F9F8-4B3C-A240-028A92C6ED79}"/>
+                <a16:creationId xmlns:a16="http://schemas.microsoft.com/office/drawing/2014/main" id="{447B0843-88E6-4B1F-8A15-3555D2896AAB}"/>
               </a:ext>
             </a:extLst>
           </p:cNvPr>
@@ -12793,7 +12787,7 @@
           </a:xfrm>
           <a:prstGeom xmlns:a="http://schemas.openxmlformats.org/drawingml/2006/main" prst="roundRect">
             <a:avLst>
-              <a:gd name="adj" fmla="val 48276"/>
+              <a:gd name="adj" fmla="val 50000"/>
             </a:avLst>
           </a:prstGeom>
           <a:solidFill xmlns:a="http://schemas.openxmlformats.org/drawingml/2006/main">
@@ -12816,7 +12810,7 @@
           <p:cNvPr id="26" name="">
             <a:extLst xmlns:a="http://schemas.openxmlformats.org/drawingml/2006/main">
               <a:ext uri="{FF2B5EF4-FFF2-40B4-BE49-F238E27FC236}">
-                <a16:creationId xmlns:a16="http://schemas.microsoft.com/office/drawing/2014/main" id="{B478BA46-3729-4AB2-8736-1C00CB92DF17}"/>
+                <a16:creationId xmlns:a16="http://schemas.microsoft.com/office/drawing/2014/main" id="{4C78CAF8-30EC-45AD-AB7B-F580778F7643}"/>
               </a:ext>
             </a:extLst>
           </p:cNvPr>
@@ -12828,7 +12822,7 @@
         <p:spPr>
           <a:xfrm xmlns:a="http://schemas.openxmlformats.org/drawingml/2006/main">
             <a:off x="5695950" y="3162300"/>
-            <a:ext cx="1847850" cy="400050"/>
+            <a:ext cx="1847850" cy="438150"/>
           </a:xfrm>
           <a:prstGeom xmlns:a="http://schemas.openxmlformats.org/drawingml/2006/main" prst="rect">
             <a:avLst/>
@@ -12872,7 +12866,7 @@
           <p:cNvPr id="27" name="">
             <a:extLst xmlns:a="http://schemas.openxmlformats.org/drawingml/2006/main">
               <a:ext uri="{FF2B5EF4-FFF2-40B4-BE49-F238E27FC236}">
-                <a16:creationId xmlns:a16="http://schemas.microsoft.com/office/drawing/2014/main" id="{EAE56F20-BA07-4ED2-8ED4-09C173DAE5F9}"/>
+                <a16:creationId xmlns:a16="http://schemas.microsoft.com/office/drawing/2014/main" id="{4D62D5ED-2C80-4736-9EF7-E516F0B09136}"/>
               </a:ext>
             </a:extLst>
           </p:cNvPr>
@@ -12888,7 +12882,7 @@
           </a:xfrm>
           <a:prstGeom xmlns:a="http://schemas.openxmlformats.org/drawingml/2006/main" prst="roundRect">
             <a:avLst>
-              <a:gd name="adj" fmla="val 48276"/>
+              <a:gd name="adj" fmla="val 50000"/>
             </a:avLst>
           </a:prstGeom>
           <a:solidFill xmlns:a="http://schemas.openxmlformats.org/drawingml/2006/main">
@@ -12911,7 +12905,7 @@
           <p:cNvPr id="28" name="">
             <a:extLst xmlns:a="http://schemas.openxmlformats.org/drawingml/2006/main">
               <a:ext uri="{FF2B5EF4-FFF2-40B4-BE49-F238E27FC236}">
-                <a16:creationId xmlns:a16="http://schemas.microsoft.com/office/drawing/2014/main" id="{920981F1-B791-421F-932E-91F887F54C6B}"/>
+                <a16:creationId xmlns:a16="http://schemas.microsoft.com/office/drawing/2014/main" id="{0764514F-EA13-4EEB-88B6-E1E1A78AB152}"/>
               </a:ext>
             </a:extLst>
           </p:cNvPr>
@@ -12923,7 +12917,7 @@
         <p:spPr>
           <a:xfrm xmlns:a="http://schemas.openxmlformats.org/drawingml/2006/main">
             <a:off x="8096250" y="3162300"/>
-            <a:ext cx="1847850" cy="400050"/>
+            <a:ext cx="1847850" cy="438150"/>
           </a:xfrm>
           <a:prstGeom xmlns:a="http://schemas.openxmlformats.org/drawingml/2006/main" prst="rect">
             <a:avLst/>
@@ -12967,7 +12961,7 @@
           <p:cNvPr id="29" name="">
             <a:extLst xmlns:a="http://schemas.openxmlformats.org/drawingml/2006/main">
               <a:ext uri="{FF2B5EF4-FFF2-40B4-BE49-F238E27FC236}">
-                <a16:creationId xmlns:a16="http://schemas.microsoft.com/office/drawing/2014/main" id="{F11547B0-9F2B-449C-93FD-1B036545DA1D}"/>
+                <a16:creationId xmlns:a16="http://schemas.microsoft.com/office/drawing/2014/main" id="{1F1BBA07-13BB-4085-A5CC-D6D3E65A5C40}"/>
               </a:ext>
             </a:extLst>
           </p:cNvPr>
@@ -13006,7 +13000,7 @@
           <p:cNvPr id="30" name="">
             <a:extLst xmlns:a="http://schemas.openxmlformats.org/drawingml/2006/main">
               <a:ext uri="{FF2B5EF4-FFF2-40B4-BE49-F238E27FC236}">
-                <a16:creationId xmlns:a16="http://schemas.microsoft.com/office/drawing/2014/main" id="{E43FBF3D-C8E5-4075-B06E-2886A7E7E2CF}"/>
+                <a16:creationId xmlns:a16="http://schemas.microsoft.com/office/drawing/2014/main" id="{547BBCAB-F5AB-4F9B-B759-FE373A720551}"/>
               </a:ext>
             </a:extLst>
           </p:cNvPr>
@@ -13062,7 +13056,7 @@
           <p:cNvPr id="31" name="">
             <a:extLst xmlns:a="http://schemas.openxmlformats.org/drawingml/2006/main">
               <a:ext uri="{FF2B5EF4-FFF2-40B4-BE49-F238E27FC236}">
-                <a16:creationId xmlns:a16="http://schemas.microsoft.com/office/drawing/2014/main" id="{7AEB2B30-8D25-475B-9F34-BF5629E9B33D}"/>
+                <a16:creationId xmlns:a16="http://schemas.microsoft.com/office/drawing/2014/main" id="{3AD92A51-B023-4E61-AB5C-81FBD4595A79}"/>
               </a:ext>
             </a:extLst>
           </p:cNvPr>
@@ -13116,7 +13110,7 @@
     </p:spTree>
     <p:extLst>
       <p:ext uri="{BB962C8B-B14F-4D97-AF65-F5344CB8AC3E}">
-        <p14:creationId xmlns:p14="http://schemas.microsoft.com/office/powerpoint/2010/main" val="849586023"/>
+        <p14:creationId xmlns:p14="http://schemas.microsoft.com/office/powerpoint/2010/main" val="1415897930"/>
       </p:ext>
     </p:extLst>
   </p:cSld>
@@ -13147,7 +13141,7 @@
           <p:cNvPr id="1" name="">
             <a:extLst xmlns:a="http://schemas.openxmlformats.org/drawingml/2006/main">
               <a:ext uri="{FF2B5EF4-FFF2-40B4-BE49-F238E27FC236}">
-                <a16:creationId xmlns:a16="http://schemas.microsoft.com/office/drawing/2014/main" id="{70146227-E6BD-4247-A190-09606D6BF4C6}"/>
+                <a16:creationId xmlns:a16="http://schemas.microsoft.com/office/drawing/2014/main" id="{11FC1647-4263-4321-80D2-2B67634B0124}"/>
               </a:ext>
             </a:extLst>
           </p:cNvPr>
@@ -13178,7 +13172,7 @@
           <p:cNvPr id="2" name="">
             <a:extLst xmlns:a="http://schemas.openxmlformats.org/drawingml/2006/main">
               <a:ext uri="{FF2B5EF4-FFF2-40B4-BE49-F238E27FC236}">
-                <a16:creationId xmlns:a16="http://schemas.microsoft.com/office/drawing/2014/main" id="{03AAA809-A5E0-4A1F-BAFB-379428BFA04F}"/>
+                <a16:creationId xmlns:a16="http://schemas.microsoft.com/office/drawing/2014/main" id="{CBA7DD7E-39C6-47C1-9382-53065EEE58A5}"/>
               </a:ext>
             </a:extLst>
           </p:cNvPr>
@@ -13209,7 +13203,7 @@
           <p:cNvPr id="3" name="">
             <a:extLst xmlns:a="http://schemas.openxmlformats.org/drawingml/2006/main">
               <a:ext uri="{FF2B5EF4-FFF2-40B4-BE49-F238E27FC236}">
-                <a16:creationId xmlns:a16="http://schemas.microsoft.com/office/drawing/2014/main" id="{99A8B6FE-5F86-4A91-BA88-0083BD8EE2EE}"/>
+                <a16:creationId xmlns:a16="http://schemas.microsoft.com/office/drawing/2014/main" id="{7D4EE015-FDC7-4A4A-A151-8B2CE14F443B}"/>
               </a:ext>
             </a:extLst>
           </p:cNvPr>
@@ -13240,7 +13234,7 @@
           <p:cNvPr id="4" name="">
             <a:extLst xmlns:a="http://schemas.openxmlformats.org/drawingml/2006/main">
               <a:ext uri="{FF2B5EF4-FFF2-40B4-BE49-F238E27FC236}">
-                <a16:creationId xmlns:a16="http://schemas.microsoft.com/office/drawing/2014/main" id="{04B3217D-947E-4E7A-A175-6FE5B8EC3906}"/>
+                <a16:creationId xmlns:a16="http://schemas.microsoft.com/office/drawing/2014/main" id="{1D1431CB-BF05-4354-ADB7-BD85B612523F}"/>
               </a:ext>
             </a:extLst>
           </p:cNvPr>
@@ -13271,7 +13265,7 @@
           <p:cNvPr id="5" name="">
             <a:extLst xmlns:a="http://schemas.openxmlformats.org/drawingml/2006/main">
               <a:ext uri="{FF2B5EF4-FFF2-40B4-BE49-F238E27FC236}">
-                <a16:creationId xmlns:a16="http://schemas.microsoft.com/office/drawing/2014/main" id="{96D63767-C588-4D42-89AD-90CAFA55CE32}"/>
+                <a16:creationId xmlns:a16="http://schemas.microsoft.com/office/drawing/2014/main" id="{CE8B7785-D181-45AF-9FC0-E4AC7E30AB50}"/>
               </a:ext>
             </a:extLst>
           </p:cNvPr>
@@ -13302,7 +13296,7 @@
           <p:cNvPr id="6" name="">
             <a:extLst xmlns:a="http://schemas.openxmlformats.org/drawingml/2006/main">
               <a:ext uri="{FF2B5EF4-FFF2-40B4-BE49-F238E27FC236}">
-                <a16:creationId xmlns:a16="http://schemas.microsoft.com/office/drawing/2014/main" id="{7283012E-089D-4FEC-B05F-8EA3D019ADB1}"/>
+                <a16:creationId xmlns:a16="http://schemas.microsoft.com/office/drawing/2014/main" id="{BFEB360B-3BC0-434A-9910-23F4F84A4103}"/>
               </a:ext>
             </a:extLst>
           </p:cNvPr>
@@ -13333,7 +13327,7 @@
           <p:cNvPr id="7" name="">
             <a:extLst xmlns:a="http://schemas.openxmlformats.org/drawingml/2006/main">
               <a:ext uri="{FF2B5EF4-FFF2-40B4-BE49-F238E27FC236}">
-                <a16:creationId xmlns:a16="http://schemas.microsoft.com/office/drawing/2014/main" id="{24E5AD5A-7456-4392-8A73-EB7241FD6017}"/>
+                <a16:creationId xmlns:a16="http://schemas.microsoft.com/office/drawing/2014/main" id="{5D9B741A-6201-4F7B-94CB-F9C5841971D9}"/>
               </a:ext>
             </a:extLst>
           </p:cNvPr>
@@ -13364,7 +13358,7 @@
           <p:cNvPr id="8" name="">
             <a:extLst xmlns:a="http://schemas.openxmlformats.org/drawingml/2006/main">
               <a:ext uri="{FF2B5EF4-FFF2-40B4-BE49-F238E27FC236}">
-                <a16:creationId xmlns:a16="http://schemas.microsoft.com/office/drawing/2014/main" id="{2A7D59C2-0584-44D8-B9F5-AA50CB97D5DA}"/>
+                <a16:creationId xmlns:a16="http://schemas.microsoft.com/office/drawing/2014/main" id="{A30BDD2E-BF1F-42D4-9F80-EFD442DFAC5D}"/>
               </a:ext>
             </a:extLst>
           </p:cNvPr>
@@ -13395,7 +13389,7 @@
           <p:cNvPr id="9" name="">
             <a:extLst xmlns:a="http://schemas.openxmlformats.org/drawingml/2006/main">
               <a:ext uri="{FF2B5EF4-FFF2-40B4-BE49-F238E27FC236}">
-                <a16:creationId xmlns:a16="http://schemas.microsoft.com/office/drawing/2014/main" id="{1398597E-7766-43C2-A134-134FEE7F50D7}"/>
+                <a16:creationId xmlns:a16="http://schemas.microsoft.com/office/drawing/2014/main" id="{CBFF108A-3F22-44A4-80B8-D5676CD06A5C}"/>
               </a:ext>
             </a:extLst>
           </p:cNvPr>
@@ -13426,7 +13420,7 @@
           <p:cNvPr id="10" name="">
             <a:extLst xmlns:a="http://schemas.openxmlformats.org/drawingml/2006/main">
               <a:ext uri="{FF2B5EF4-FFF2-40B4-BE49-F238E27FC236}">
-                <a16:creationId xmlns:a16="http://schemas.microsoft.com/office/drawing/2014/main" id="{ED46CA5B-B2DD-4C65-ADA8-5DB803C10794}"/>
+                <a16:creationId xmlns:a16="http://schemas.microsoft.com/office/drawing/2014/main" id="{843E23C2-E651-4437-901E-4AC267E8066C}"/>
               </a:ext>
             </a:extLst>
           </p:cNvPr>
@@ -13457,7 +13451,7 @@
           <p:cNvPr id="11" name="">
             <a:extLst xmlns:a="http://schemas.openxmlformats.org/drawingml/2006/main">
               <a:ext uri="{FF2B5EF4-FFF2-40B4-BE49-F238E27FC236}">
-                <a16:creationId xmlns:a16="http://schemas.microsoft.com/office/drawing/2014/main" id="{1AE47C68-6E0D-431E-8EE1-7501FA277C32}"/>
+                <a16:creationId xmlns:a16="http://schemas.microsoft.com/office/drawing/2014/main" id="{928074B4-AEBB-4CB8-AE41-6859860BF861}"/>
               </a:ext>
             </a:extLst>
           </p:cNvPr>
@@ -13488,7 +13482,7 @@
           <p:cNvPr id="12" name="">
             <a:extLst xmlns:a="http://schemas.openxmlformats.org/drawingml/2006/main">
               <a:ext uri="{FF2B5EF4-FFF2-40B4-BE49-F238E27FC236}">
-                <a16:creationId xmlns:a16="http://schemas.microsoft.com/office/drawing/2014/main" id="{B2DBEF88-6142-41DB-A38D-698B70540A51}"/>
+                <a16:creationId xmlns:a16="http://schemas.microsoft.com/office/drawing/2014/main" id="{1A8F1905-47BB-474A-9AEB-63178F7D4EB3}"/>
               </a:ext>
             </a:extLst>
           </p:cNvPr>
@@ -13519,7 +13513,7 @@
           <p:cNvPr id="13" name="">
             <a:extLst xmlns:a="http://schemas.openxmlformats.org/drawingml/2006/main">
               <a:ext uri="{FF2B5EF4-FFF2-40B4-BE49-F238E27FC236}">
-                <a16:creationId xmlns:a16="http://schemas.microsoft.com/office/drawing/2014/main" id="{0A7D0EC8-4837-4A25-AB17-454FF8EE5100}"/>
+                <a16:creationId xmlns:a16="http://schemas.microsoft.com/office/drawing/2014/main" id="{BF65E5FB-AC28-41A3-90AC-22DC92104434}"/>
               </a:ext>
             </a:extLst>
           </p:cNvPr>
@@ -13575,7 +13569,7 @@
           <p:cNvPr id="14" name="">
             <a:extLst xmlns:a="http://schemas.openxmlformats.org/drawingml/2006/main">
               <a:ext uri="{FF2B5EF4-FFF2-40B4-BE49-F238E27FC236}">
-                <a16:creationId xmlns:a16="http://schemas.microsoft.com/office/drawing/2014/main" id="{FAA8B0BF-C2FF-44E0-9945-109686E6B161}"/>
+                <a16:creationId xmlns:a16="http://schemas.microsoft.com/office/drawing/2014/main" id="{1C9AAEB4-C8E3-4C1F-82F1-4C3AB489FDCA}"/>
               </a:ext>
             </a:extLst>
           </p:cNvPr>
@@ -13606,7 +13600,7 @@
           <p:cNvPr id="15" name="">
             <a:extLst xmlns:a="http://schemas.openxmlformats.org/drawingml/2006/main">
               <a:ext uri="{FF2B5EF4-FFF2-40B4-BE49-F238E27FC236}">
-                <a16:creationId xmlns:a16="http://schemas.microsoft.com/office/drawing/2014/main" id="{CDC499EF-AC53-469B-85AE-86EB9945BBB5}"/>
+                <a16:creationId xmlns:a16="http://schemas.microsoft.com/office/drawing/2014/main" id="{C18B4A2E-8F2D-496F-A627-98C4F47E96E7}"/>
               </a:ext>
             </a:extLst>
           </p:cNvPr>
@@ -13662,7 +13656,7 @@
           <p:cNvPr id="16" name="">
             <a:extLst xmlns:a="http://schemas.openxmlformats.org/drawingml/2006/main">
               <a:ext uri="{FF2B5EF4-FFF2-40B4-BE49-F238E27FC236}">
-                <a16:creationId xmlns:a16="http://schemas.microsoft.com/office/drawing/2014/main" id="{608DCF5A-ED44-47A6-8391-486ED6AC214B}"/>
+                <a16:creationId xmlns:a16="http://schemas.microsoft.com/office/drawing/2014/main" id="{C05F4397-6DB2-44FA-B2F8-86DFF8F7BB12}"/>
               </a:ext>
             </a:extLst>
           </p:cNvPr>
@@ -13693,7 +13687,7 @@
           <p:cNvPr id="17" name="">
             <a:extLst xmlns:a="http://schemas.openxmlformats.org/drawingml/2006/main">
               <a:ext uri="{FF2B5EF4-FFF2-40B4-BE49-F238E27FC236}">
-                <a16:creationId xmlns:a16="http://schemas.microsoft.com/office/drawing/2014/main" id="{A3FDC059-DE3B-4497-B53A-387499DEAE42}"/>
+                <a16:creationId xmlns:a16="http://schemas.microsoft.com/office/drawing/2014/main" id="{D6014E53-E189-4A1D-8700-5FBD9744E1FA}"/>
               </a:ext>
             </a:extLst>
           </p:cNvPr>
@@ -13749,7 +13743,7 @@
           <p:cNvPr id="18" name="">
             <a:extLst xmlns:a="http://schemas.openxmlformats.org/drawingml/2006/main">
               <a:ext uri="{FF2B5EF4-FFF2-40B4-BE49-F238E27FC236}">
-                <a16:creationId xmlns:a16="http://schemas.microsoft.com/office/drawing/2014/main" id="{CA3C00CF-94A9-4DC2-8065-ED7C963FFF2C}"/>
+                <a16:creationId xmlns:a16="http://schemas.microsoft.com/office/drawing/2014/main" id="{6125EA24-ABB9-40D5-9DFD-FDE0CD874108}"/>
               </a:ext>
             </a:extLst>
           </p:cNvPr>
@@ -13780,7 +13774,7 @@
           <p:cNvPr id="19" name="">
             <a:extLst xmlns:a="http://schemas.openxmlformats.org/drawingml/2006/main">
               <a:ext uri="{FF2B5EF4-FFF2-40B4-BE49-F238E27FC236}">
-                <a16:creationId xmlns:a16="http://schemas.microsoft.com/office/drawing/2014/main" id="{B22A6BA6-ECD9-4CB7-BD4B-8CC613C95E58}"/>
+                <a16:creationId xmlns:a16="http://schemas.microsoft.com/office/drawing/2014/main" id="{CC559DD0-A3AC-48F8-A692-52C76AA5D0AA}"/>
               </a:ext>
             </a:extLst>
           </p:cNvPr>
@@ -13836,7 +13830,7 @@
           <p:cNvPr id="20" name="">
             <a:extLst xmlns:a="http://schemas.openxmlformats.org/drawingml/2006/main">
               <a:ext uri="{FF2B5EF4-FFF2-40B4-BE49-F238E27FC236}">
-                <a16:creationId xmlns:a16="http://schemas.microsoft.com/office/drawing/2014/main" id="{467963F9-828F-4BD3-8EC2-E29549246CAE}"/>
+                <a16:creationId xmlns:a16="http://schemas.microsoft.com/office/drawing/2014/main" id="{5ED959D0-8A8F-40E4-9B9D-5805E79E71C0}"/>
               </a:ext>
             </a:extLst>
           </p:cNvPr>
@@ -13867,7 +13861,7 @@
           <p:cNvPr id="21" name="">
             <a:extLst xmlns:a="http://schemas.openxmlformats.org/drawingml/2006/main">
               <a:ext uri="{FF2B5EF4-FFF2-40B4-BE49-F238E27FC236}">
-                <a16:creationId xmlns:a16="http://schemas.microsoft.com/office/drawing/2014/main" id="{5511637A-E8EB-494F-976C-F2821EADDBBC}"/>
+                <a16:creationId xmlns:a16="http://schemas.microsoft.com/office/drawing/2014/main" id="{16354888-2C12-401E-8D3D-D3FE3CB20C79}"/>
               </a:ext>
             </a:extLst>
           </p:cNvPr>
@@ -13923,7 +13917,7 @@
           <p:cNvPr id="22" name="">
             <a:extLst xmlns:a="http://schemas.openxmlformats.org/drawingml/2006/main">
               <a:ext uri="{FF2B5EF4-FFF2-40B4-BE49-F238E27FC236}">
-                <a16:creationId xmlns:a16="http://schemas.microsoft.com/office/drawing/2014/main" id="{847CDC1A-75C0-4557-80C5-0ECB94F86FA6}"/>
+                <a16:creationId xmlns:a16="http://schemas.microsoft.com/office/drawing/2014/main" id="{128C55BF-7927-421D-9C5E-7BC6C5188EE1}"/>
               </a:ext>
             </a:extLst>
           </p:cNvPr>
@@ -13962,7 +13956,7 @@
           <p:cNvPr id="23" name="">
             <a:extLst xmlns:a="http://schemas.openxmlformats.org/drawingml/2006/main">
               <a:ext uri="{FF2B5EF4-FFF2-40B4-BE49-F238E27FC236}">
-                <a16:creationId xmlns:a16="http://schemas.microsoft.com/office/drawing/2014/main" id="{E2D54A5E-383B-49D1-A87B-BDAB46FCD5E2}"/>
+                <a16:creationId xmlns:a16="http://schemas.microsoft.com/office/drawing/2014/main" id="{82A30486-EF5C-4096-9F90-7A1E39C3FAC7}"/>
               </a:ext>
             </a:extLst>
           </p:cNvPr>
@@ -14022,7 +14016,7 @@
           <p:nvPr/>
         </p:nvPicPr>
         <p:blipFill>
-          <a:blip xmlns:r="http://schemas.openxmlformats.org/officeDocument/2006/relationships" xmlns:a="http://schemas.openxmlformats.org/drawingml/2006/main" r:embed="Ra3791e89fc5a4e4b"/>
+          <a:blip xmlns:r="http://schemas.openxmlformats.org/officeDocument/2006/relationships" xmlns:a="http://schemas.openxmlformats.org/drawingml/2006/main" r:embed="R089545a07e92472a"/>
           <a:stretch xmlns:a="http://schemas.openxmlformats.org/drawingml/2006/main"/>
         </p:blipFill>
         <p:spPr>
@@ -14040,7 +14034,7 @@
           <p:cNvPr id="25" name="">
             <a:extLst xmlns:a="http://schemas.openxmlformats.org/drawingml/2006/main">
               <a:ext uri="{FF2B5EF4-FFF2-40B4-BE49-F238E27FC236}">
-                <a16:creationId xmlns:a16="http://schemas.microsoft.com/office/drawing/2014/main" id="{F457954E-D829-4B4D-B9A0-D55CB4AE97A7}"/>
+                <a16:creationId xmlns:a16="http://schemas.microsoft.com/office/drawing/2014/main" id="{0A69EED0-5A45-46D4-8E05-4E1CBCFB113C}"/>
               </a:ext>
             </a:extLst>
           </p:cNvPr>
@@ -14094,7 +14088,7 @@
     </p:spTree>
     <p:extLst>
       <p:ext uri="{BB962C8B-B14F-4D97-AF65-F5344CB8AC3E}">
-        <p14:creationId xmlns:p14="http://schemas.microsoft.com/office/powerpoint/2010/main" val="898190156"/>
+        <p14:creationId xmlns:p14="http://schemas.microsoft.com/office/powerpoint/2010/main" val="824580829"/>
       </p:ext>
     </p:extLst>
   </p:cSld>

</xml_diff>